<commit_message>
Deploy updated hackathon certificate template with design and spacing fixes
</commit_message>
<xml_diff>
--- a/backend/CERTIFICATE_TEMPLATE - hackathon.pptx
+++ b/backend/CERTIFICATE_TEMPLATE - hackathon.pptx
@@ -1,46 +1,55 @@
 
 <file path=ppt/presentation.xml><?xml version="1.0" encoding="utf-8"?>
-<p:presentation xmlns:a="http://schemas.openxmlformats.org/drawingml/2006/main" xmlns:r="http://schemas.openxmlformats.org/officeDocument/2006/relationships" xmlns:p="http://schemas.openxmlformats.org/presentationml/2006/main" saveSubsetFonts="1" embedTrueTypeFonts="true">
+<p:presentation xmlns:a="http://schemas.openxmlformats.org/drawingml/2006/main" xmlns:r="http://schemas.openxmlformats.org/officeDocument/2006/relationships" xmlns:p="http://schemas.openxmlformats.org/presentationml/2006/main" embedTrueTypeFonts="1" saveSubsetFonts="1">
   <p:sldMasterIdLst>
     <p:sldMasterId id="2147483648" r:id="rId1"/>
   </p:sldMasterIdLst>
   <p:sldIdLst>
-    <p:sldId id="256" r:id="rId6"/>
+    <p:sldId id="256" r:id="rId3"/>
   </p:sldIdLst>
   <p:sldSz cx="10693400" cy="7556500"/>
   <p:notesSz cx="6858000" cy="9144000"/>
   <p:embeddedFontLst>
     <p:embeddedFont>
-      <p:font typeface="Caladea" charset="1" panose="02040503050406030204"/>
+      <p:font typeface="Caladea" panose="02040503050406030204"/>
       <p:regular r:id="rId7"/>
+      <p:bold r:id="rId8"/>
+      <p:italic r:id="rId9"/>
+      <p:boldItalic r:id="rId10"/>
     </p:embeddedFont>
     <p:embeddedFont>
-      <p:font typeface="Caladea Bold" charset="1" panose="02040803050406030204"/>
-      <p:regular r:id="rId8"/>
+      <p:font typeface="Caladea Bold" panose="02040803050406030204"/>
+      <p:bold r:id="rId11"/>
     </p:embeddedFont>
     <p:embeddedFont>
-      <p:font typeface="Palatino Bold" charset="1" panose="02040702050505030304"/>
-      <p:regular r:id="rId9"/>
+      <p:font typeface="Inria Serif Bold"/>
+      <p:bold r:id="rId12"/>
     </p:embeddedFont>
     <p:embeddedFont>
-      <p:font typeface="Inria Serif Bold" charset="1" panose="00000000000000000000"/>
-      <p:regular r:id="rId10"/>
-    </p:embeddedFont>
-    <p:embeddedFont>
-      <p:font typeface="Inria Serif" charset="1" panose="00000000000000000000"/>
-      <p:regular r:id="rId11"/>
-    </p:embeddedFont>
-    <p:embeddedFont>
-      <p:font typeface="Cormorant Garamond" charset="1" panose="00000500000000000000"/>
-      <p:regular r:id="rId12"/>
-    </p:embeddedFont>
-    <p:embeddedFont>
-      <p:font typeface="Cormorant Garamond Bold" charset="1" panose="00000800000000000000"/>
+      <p:font typeface="Inria Serif"/>
       <p:regular r:id="rId13"/>
     </p:embeddedFont>
     <p:embeddedFont>
-      <p:font typeface="Great Vibes" charset="1" panose="02000507080000020002"/>
+      <p:font typeface="Cormorant Garamond"/>
       <p:regular r:id="rId14"/>
+      <p:bold r:id="rId15"/>
+      <p:italic r:id="rId16"/>
+      <p:boldItalic r:id="rId17"/>
+    </p:embeddedFont>
+    <p:embeddedFont>
+      <p:font typeface="Cormorant Garamond Bold" panose="00000800000000000000"/>
+      <p:bold r:id="rId18"/>
+    </p:embeddedFont>
+    <p:embeddedFont>
+      <p:font typeface="Great Vibes"/>
+      <p:regular r:id="rId19"/>
+    </p:embeddedFont>
+    <p:embeddedFont>
+      <p:font typeface="Calibri" panose="020F0502020204030204" charset="0"/>
+      <p:regular r:id="rId20"/>
+      <p:bold r:id="rId21"/>
+      <p:italic r:id="rId22"/>
+      <p:boldItalic r:id="rId23"/>
     </p:embeddedFont>
   </p:embeddedFontLst>
   <p:defaultTextStyle>
@@ -138,6 +147,22 @@
       </a:defRPr>
     </a:lvl9pPr>
   </p:defaultTextStyle>
+  <p:extLst>
+    <p:ext uri="{EFAFB233-063F-42B5-8137-9DF3F51BA10A}">
+      <p15:sldGuideLst xmlns:p15="http://schemas.microsoft.com/office/powerpoint/2012/main">
+        <p15:guide id="1" orient="horz" pos="2160" userDrawn="1">
+          <p15:clr>
+            <a:srgbClr val="A4A3A4"/>
+          </p15:clr>
+        </p15:guide>
+        <p15:guide id="2" pos="2880" userDrawn="1">
+          <p15:clr>
+            <a:srgbClr val="A4A3A4"/>
+          </p15:clr>
+        </p15:guide>
+      </p15:sldGuideLst>
+    </p:ext>
+  </p:extLst>
 </p:presentation>
 </file>
 
@@ -322,8 +347,6 @@
           <a:p>
             <a:fld id="{1D8BD707-D9CF-40AE-B4C6-C98DA3205C09}" type="datetimeFigureOut">
               <a:rPr lang="en-US" smtClean="0"/>
-              <a:pPr/>
-              <a:t>8/1/2011</a:t>
             </a:fld>
             <a:endParaRPr lang="en-US"/>
           </a:p>
@@ -365,8 +388,6 @@
           <a:p>
             <a:fld id="{B6F15528-21DE-4FAA-801E-634DDDAF4B2B}" type="slidenum">
               <a:rPr lang="en-US" smtClean="0"/>
-              <a:pPr/>
-              <a:t>‹#›</a:t>
             </a:fld>
             <a:endParaRPr lang="en-US"/>
           </a:p>
@@ -440,6 +461,7 @@
               <a:rPr lang="en-US" smtClean="0"/>
               <a:t>Click to edit Master text styles</a:t>
             </a:r>
+            <a:endParaRPr lang="en-US" smtClean="0"/>
           </a:p>
           <a:p>
             <a:pPr lvl="1"/>
@@ -447,6 +469,7 @@
               <a:rPr lang="en-US" smtClean="0"/>
               <a:t>Second level</a:t>
             </a:r>
+            <a:endParaRPr lang="en-US" smtClean="0"/>
           </a:p>
           <a:p>
             <a:pPr lvl="2"/>
@@ -454,6 +477,7 @@
               <a:rPr lang="en-US" smtClean="0"/>
               <a:t>Third level</a:t>
             </a:r>
+            <a:endParaRPr lang="en-US" smtClean="0"/>
           </a:p>
           <a:p>
             <a:pPr lvl="3"/>
@@ -461,6 +485,7 @@
               <a:rPr lang="en-US" smtClean="0"/>
               <a:t>Fourth level</a:t>
             </a:r>
+            <a:endParaRPr lang="en-US" smtClean="0"/>
           </a:p>
           <a:p>
             <a:pPr lvl="4"/>
@@ -489,8 +514,6 @@
           <a:p>
             <a:fld id="{1D8BD707-D9CF-40AE-B4C6-C98DA3205C09}" type="datetimeFigureOut">
               <a:rPr lang="en-US" smtClean="0"/>
-              <a:pPr/>
-              <a:t>8/1/2011</a:t>
             </a:fld>
             <a:endParaRPr lang="en-US"/>
           </a:p>
@@ -532,8 +555,6 @@
           <a:p>
             <a:fld id="{B6F15528-21DE-4FAA-801E-634DDDAF4B2B}" type="slidenum">
               <a:rPr lang="en-US" smtClean="0"/>
-              <a:pPr/>
-              <a:t>‹#›</a:t>
             </a:fld>
             <a:endParaRPr lang="en-US"/>
           </a:p>
@@ -617,6 +638,7 @@
               <a:rPr lang="en-US" smtClean="0"/>
               <a:t>Click to edit Master text styles</a:t>
             </a:r>
+            <a:endParaRPr lang="en-US" smtClean="0"/>
           </a:p>
           <a:p>
             <a:pPr lvl="1"/>
@@ -624,6 +646,7 @@
               <a:rPr lang="en-US" smtClean="0"/>
               <a:t>Second level</a:t>
             </a:r>
+            <a:endParaRPr lang="en-US" smtClean="0"/>
           </a:p>
           <a:p>
             <a:pPr lvl="2"/>
@@ -631,6 +654,7 @@
               <a:rPr lang="en-US" smtClean="0"/>
               <a:t>Third level</a:t>
             </a:r>
+            <a:endParaRPr lang="en-US" smtClean="0"/>
           </a:p>
           <a:p>
             <a:pPr lvl="3"/>
@@ -638,6 +662,7 @@
               <a:rPr lang="en-US" smtClean="0"/>
               <a:t>Fourth level</a:t>
             </a:r>
+            <a:endParaRPr lang="en-US" smtClean="0"/>
           </a:p>
           <a:p>
             <a:pPr lvl="4"/>
@@ -666,8 +691,6 @@
           <a:p>
             <a:fld id="{1D8BD707-D9CF-40AE-B4C6-C98DA3205C09}" type="datetimeFigureOut">
               <a:rPr lang="en-US" smtClean="0"/>
-              <a:pPr/>
-              <a:t>8/1/2011</a:t>
             </a:fld>
             <a:endParaRPr lang="en-US"/>
           </a:p>
@@ -709,8 +732,6 @@
           <a:p>
             <a:fld id="{B6F15528-21DE-4FAA-801E-634DDDAF4B2B}" type="slidenum">
               <a:rPr lang="en-US" smtClean="0"/>
-              <a:pPr/>
-              <a:t>‹#›</a:t>
             </a:fld>
             <a:endParaRPr lang="en-US"/>
           </a:p>
@@ -784,6 +805,7 @@
               <a:rPr lang="en-US" smtClean="0"/>
               <a:t>Click to edit Master text styles</a:t>
             </a:r>
+            <a:endParaRPr lang="en-US" smtClean="0"/>
           </a:p>
           <a:p>
             <a:pPr lvl="1"/>
@@ -791,6 +813,7 @@
               <a:rPr lang="en-US" smtClean="0"/>
               <a:t>Second level</a:t>
             </a:r>
+            <a:endParaRPr lang="en-US" smtClean="0"/>
           </a:p>
           <a:p>
             <a:pPr lvl="2"/>
@@ -798,6 +821,7 @@
               <a:rPr lang="en-US" smtClean="0"/>
               <a:t>Third level</a:t>
             </a:r>
+            <a:endParaRPr lang="en-US" smtClean="0"/>
           </a:p>
           <a:p>
             <a:pPr lvl="3"/>
@@ -805,6 +829,7 @@
               <a:rPr lang="en-US" smtClean="0"/>
               <a:t>Fourth level</a:t>
             </a:r>
+            <a:endParaRPr lang="en-US" smtClean="0"/>
           </a:p>
           <a:p>
             <a:pPr lvl="4"/>
@@ -833,8 +858,6 @@
           <a:p>
             <a:fld id="{1D8BD707-D9CF-40AE-B4C6-C98DA3205C09}" type="datetimeFigureOut">
               <a:rPr lang="en-US" smtClean="0"/>
-              <a:pPr/>
-              <a:t>8/1/2011</a:t>
             </a:fld>
             <a:endParaRPr lang="en-US"/>
           </a:p>
@@ -876,8 +899,6 @@
           <a:p>
             <a:fld id="{B6F15528-21DE-4FAA-801E-634DDDAF4B2B}" type="slidenum">
               <a:rPr lang="en-US" smtClean="0"/>
-              <a:pPr/>
-              <a:t>‹#›</a:t>
             </a:fld>
             <a:endParaRPr lang="en-US"/>
           </a:p>
@@ -1056,6 +1077,7 @@
               <a:rPr lang="en-US" smtClean="0"/>
               <a:t>Click to edit Master text styles</a:t>
             </a:r>
+            <a:endParaRPr lang="en-US" smtClean="0"/>
           </a:p>
         </p:txBody>
       </p:sp>
@@ -1076,8 +1098,6 @@
           <a:p>
             <a:fld id="{1D8BD707-D9CF-40AE-B4C6-C98DA3205C09}" type="datetimeFigureOut">
               <a:rPr lang="en-US" smtClean="0"/>
-              <a:pPr/>
-              <a:t>8/1/2011</a:t>
             </a:fld>
             <a:endParaRPr lang="en-US"/>
           </a:p>
@@ -1119,8 +1139,6 @@
           <a:p>
             <a:fld id="{B6F15528-21DE-4FAA-801E-634DDDAF4B2B}" type="slidenum">
               <a:rPr lang="en-US" smtClean="0"/>
-              <a:pPr/>
-              <a:t>‹#›</a:t>
             </a:fld>
             <a:endParaRPr lang="en-US"/>
           </a:p>
@@ -1227,6 +1245,7 @@
               <a:rPr lang="en-US" smtClean="0"/>
               <a:t>Click to edit Master text styles</a:t>
             </a:r>
+            <a:endParaRPr lang="en-US" smtClean="0"/>
           </a:p>
           <a:p>
             <a:pPr lvl="1"/>
@@ -1234,6 +1253,7 @@
               <a:rPr lang="en-US" smtClean="0"/>
               <a:t>Second level</a:t>
             </a:r>
+            <a:endParaRPr lang="en-US" smtClean="0"/>
           </a:p>
           <a:p>
             <a:pPr lvl="2"/>
@@ -1241,6 +1261,7 @@
               <a:rPr lang="en-US" smtClean="0"/>
               <a:t>Third level</a:t>
             </a:r>
+            <a:endParaRPr lang="en-US" smtClean="0"/>
           </a:p>
           <a:p>
             <a:pPr lvl="3"/>
@@ -1248,6 +1269,7 @@
               <a:rPr lang="en-US" smtClean="0"/>
               <a:t>Fourth level</a:t>
             </a:r>
+            <a:endParaRPr lang="en-US" smtClean="0"/>
           </a:p>
           <a:p>
             <a:pPr lvl="4"/>
@@ -1312,6 +1334,7 @@
               <a:rPr lang="en-US" smtClean="0"/>
               <a:t>Click to edit Master text styles</a:t>
             </a:r>
+            <a:endParaRPr lang="en-US" smtClean="0"/>
           </a:p>
           <a:p>
             <a:pPr lvl="1"/>
@@ -1319,6 +1342,7 @@
               <a:rPr lang="en-US" smtClean="0"/>
               <a:t>Second level</a:t>
             </a:r>
+            <a:endParaRPr lang="en-US" smtClean="0"/>
           </a:p>
           <a:p>
             <a:pPr lvl="2"/>
@@ -1326,6 +1350,7 @@
               <a:rPr lang="en-US" smtClean="0"/>
               <a:t>Third level</a:t>
             </a:r>
+            <a:endParaRPr lang="en-US" smtClean="0"/>
           </a:p>
           <a:p>
             <a:pPr lvl="3"/>
@@ -1333,6 +1358,7 @@
               <a:rPr lang="en-US" smtClean="0"/>
               <a:t>Fourth level</a:t>
             </a:r>
+            <a:endParaRPr lang="en-US" smtClean="0"/>
           </a:p>
           <a:p>
             <a:pPr lvl="4"/>
@@ -1361,8 +1387,6 @@
           <a:p>
             <a:fld id="{1D8BD707-D9CF-40AE-B4C6-C98DA3205C09}" type="datetimeFigureOut">
               <a:rPr lang="en-US" smtClean="0"/>
-              <a:pPr/>
-              <a:t>8/1/2011</a:t>
             </a:fld>
             <a:endParaRPr lang="en-US"/>
           </a:p>
@@ -1404,8 +1428,6 @@
           <a:p>
             <a:fld id="{B6F15528-21DE-4FAA-801E-634DDDAF4B2B}" type="slidenum">
               <a:rPr lang="en-US" smtClean="0"/>
-              <a:pPr/>
-              <a:t>‹#›</a:t>
             </a:fld>
             <a:endParaRPr lang="en-US"/>
           </a:p>
@@ -1525,6 +1547,7 @@
               <a:rPr lang="en-US" smtClean="0"/>
               <a:t>Click to edit Master text styles</a:t>
             </a:r>
+            <a:endParaRPr lang="en-US" smtClean="0"/>
           </a:p>
         </p:txBody>
       </p:sp>
@@ -1581,6 +1604,7 @@
               <a:rPr lang="en-US" smtClean="0"/>
               <a:t>Click to edit Master text styles</a:t>
             </a:r>
+            <a:endParaRPr lang="en-US" smtClean="0"/>
           </a:p>
           <a:p>
             <a:pPr lvl="1"/>
@@ -1588,6 +1612,7 @@
               <a:rPr lang="en-US" smtClean="0"/>
               <a:t>Second level</a:t>
             </a:r>
+            <a:endParaRPr lang="en-US" smtClean="0"/>
           </a:p>
           <a:p>
             <a:pPr lvl="2"/>
@@ -1595,6 +1620,7 @@
               <a:rPr lang="en-US" smtClean="0"/>
               <a:t>Third level</a:t>
             </a:r>
+            <a:endParaRPr lang="en-US" smtClean="0"/>
           </a:p>
           <a:p>
             <a:pPr lvl="3"/>
@@ -1602,6 +1628,7 @@
               <a:rPr lang="en-US" smtClean="0"/>
               <a:t>Fourth level</a:t>
             </a:r>
+            <a:endParaRPr lang="en-US" smtClean="0"/>
           </a:p>
           <a:p>
             <a:pPr lvl="4"/>
@@ -1675,6 +1702,7 @@
               <a:rPr lang="en-US" smtClean="0"/>
               <a:t>Click to edit Master text styles</a:t>
             </a:r>
+            <a:endParaRPr lang="en-US" smtClean="0"/>
           </a:p>
         </p:txBody>
       </p:sp>
@@ -1731,6 +1759,7 @@
               <a:rPr lang="en-US" smtClean="0"/>
               <a:t>Click to edit Master text styles</a:t>
             </a:r>
+            <a:endParaRPr lang="en-US" smtClean="0"/>
           </a:p>
           <a:p>
             <a:pPr lvl="1"/>
@@ -1738,6 +1767,7 @@
               <a:rPr lang="en-US" smtClean="0"/>
               <a:t>Second level</a:t>
             </a:r>
+            <a:endParaRPr lang="en-US" smtClean="0"/>
           </a:p>
           <a:p>
             <a:pPr lvl="2"/>
@@ -1745,6 +1775,7 @@
               <a:rPr lang="en-US" smtClean="0"/>
               <a:t>Third level</a:t>
             </a:r>
+            <a:endParaRPr lang="en-US" smtClean="0"/>
           </a:p>
           <a:p>
             <a:pPr lvl="3"/>
@@ -1752,6 +1783,7 @@
               <a:rPr lang="en-US" smtClean="0"/>
               <a:t>Fourth level</a:t>
             </a:r>
+            <a:endParaRPr lang="en-US" smtClean="0"/>
           </a:p>
           <a:p>
             <a:pPr lvl="4"/>
@@ -1780,8 +1812,6 @@
           <a:p>
             <a:fld id="{1D8BD707-D9CF-40AE-B4C6-C98DA3205C09}" type="datetimeFigureOut">
               <a:rPr lang="en-US" smtClean="0"/>
-              <a:pPr/>
-              <a:t>8/1/2011</a:t>
             </a:fld>
             <a:endParaRPr lang="en-US"/>
           </a:p>
@@ -1823,8 +1853,6 @@
           <a:p>
             <a:fld id="{B6F15528-21DE-4FAA-801E-634DDDAF4B2B}" type="slidenum">
               <a:rPr lang="en-US" smtClean="0"/>
-              <a:pPr/>
-              <a:t>‹#›</a:t>
             </a:fld>
             <a:endParaRPr lang="en-US"/>
           </a:p>
@@ -1895,8 +1923,6 @@
           <a:p>
             <a:fld id="{1D8BD707-D9CF-40AE-B4C6-C98DA3205C09}" type="datetimeFigureOut">
               <a:rPr lang="en-US" smtClean="0"/>
-              <a:pPr/>
-              <a:t>8/1/2011</a:t>
             </a:fld>
             <a:endParaRPr lang="en-US"/>
           </a:p>
@@ -1938,8 +1964,6 @@
           <a:p>
             <a:fld id="{B6F15528-21DE-4FAA-801E-634DDDAF4B2B}" type="slidenum">
               <a:rPr lang="en-US" smtClean="0"/>
-              <a:pPr/>
-              <a:t>‹#›</a:t>
             </a:fld>
             <a:endParaRPr lang="en-US"/>
           </a:p>
@@ -1987,8 +2011,6 @@
           <a:p>
             <a:fld id="{1D8BD707-D9CF-40AE-B4C6-C98DA3205C09}" type="datetimeFigureOut">
               <a:rPr lang="en-US" smtClean="0"/>
-              <a:pPr/>
-              <a:t>8/1/2011</a:t>
             </a:fld>
             <a:endParaRPr lang="en-US"/>
           </a:p>
@@ -2030,8 +2052,6 @@
           <a:p>
             <a:fld id="{B6F15528-21DE-4FAA-801E-634DDDAF4B2B}" type="slidenum">
               <a:rPr lang="en-US" smtClean="0"/>
-              <a:pPr/>
-              <a:t>‹#›</a:t>
             </a:fld>
             <a:endParaRPr lang="en-US"/>
           </a:p>
@@ -2147,6 +2167,7 @@
               <a:rPr lang="en-US" smtClean="0"/>
               <a:t>Click to edit Master text styles</a:t>
             </a:r>
+            <a:endParaRPr lang="en-US" smtClean="0"/>
           </a:p>
           <a:p>
             <a:pPr lvl="1"/>
@@ -2154,6 +2175,7 @@
               <a:rPr lang="en-US" smtClean="0"/>
               <a:t>Second level</a:t>
             </a:r>
+            <a:endParaRPr lang="en-US" smtClean="0"/>
           </a:p>
           <a:p>
             <a:pPr lvl="2"/>
@@ -2161,6 +2183,7 @@
               <a:rPr lang="en-US" smtClean="0"/>
               <a:t>Third level</a:t>
             </a:r>
+            <a:endParaRPr lang="en-US" smtClean="0"/>
           </a:p>
           <a:p>
             <a:pPr lvl="3"/>
@@ -2168,6 +2191,7 @@
               <a:rPr lang="en-US" smtClean="0"/>
               <a:t>Fourth level</a:t>
             </a:r>
+            <a:endParaRPr lang="en-US" smtClean="0"/>
           </a:p>
           <a:p>
             <a:pPr lvl="4"/>
@@ -2241,6 +2265,7 @@
               <a:rPr lang="en-US" smtClean="0"/>
               <a:t>Click to edit Master text styles</a:t>
             </a:r>
+            <a:endParaRPr lang="en-US" smtClean="0"/>
           </a:p>
         </p:txBody>
       </p:sp>
@@ -2261,8 +2286,6 @@
           <a:p>
             <a:fld id="{1D8BD707-D9CF-40AE-B4C6-C98DA3205C09}" type="datetimeFigureOut">
               <a:rPr lang="en-US" smtClean="0"/>
-              <a:pPr/>
-              <a:t>8/1/2011</a:t>
             </a:fld>
             <a:endParaRPr lang="en-US"/>
           </a:p>
@@ -2304,8 +2327,6 @@
           <a:p>
             <a:fld id="{B6F15528-21DE-4FAA-801E-634DDDAF4B2B}" type="slidenum">
               <a:rPr lang="en-US" smtClean="0"/>
-              <a:pPr/>
-              <a:t>‹#›</a:t>
             </a:fld>
             <a:endParaRPr lang="en-US"/>
           </a:p>
@@ -2491,6 +2512,7 @@
               <a:rPr lang="en-US" smtClean="0"/>
               <a:t>Click to edit Master text styles</a:t>
             </a:r>
+            <a:endParaRPr lang="en-US" smtClean="0"/>
           </a:p>
         </p:txBody>
       </p:sp>
@@ -2511,8 +2533,6 @@
           <a:p>
             <a:fld id="{1D8BD707-D9CF-40AE-B4C6-C98DA3205C09}" type="datetimeFigureOut">
               <a:rPr lang="en-US" smtClean="0"/>
-              <a:pPr/>
-              <a:t>8/1/2011</a:t>
             </a:fld>
             <a:endParaRPr lang="en-US"/>
           </a:p>
@@ -2554,8 +2574,6 @@
           <a:p>
             <a:fld id="{B6F15528-21DE-4FAA-801E-634DDDAF4B2B}" type="slidenum">
               <a:rPr lang="en-US" smtClean="0"/>
-              <a:pPr/>
-              <a:t>‹#›</a:t>
             </a:fld>
             <a:endParaRPr lang="en-US"/>
           </a:p>
@@ -2654,6 +2672,7 @@
               <a:rPr lang="en-US" smtClean="0"/>
               <a:t>Click to edit Master text styles</a:t>
             </a:r>
+            <a:endParaRPr lang="en-US" smtClean="0"/>
           </a:p>
           <a:p>
             <a:pPr lvl="1"/>
@@ -2661,6 +2680,7 @@
               <a:rPr lang="en-US" smtClean="0"/>
               <a:t>Second level</a:t>
             </a:r>
+            <a:endParaRPr lang="en-US" smtClean="0"/>
           </a:p>
           <a:p>
             <a:pPr lvl="2"/>
@@ -2668,6 +2688,7 @@
               <a:rPr lang="en-US" smtClean="0"/>
               <a:t>Third level</a:t>
             </a:r>
+            <a:endParaRPr lang="en-US" smtClean="0"/>
           </a:p>
           <a:p>
             <a:pPr lvl="3"/>
@@ -2675,6 +2696,7 @@
               <a:rPr lang="en-US" smtClean="0"/>
               <a:t>Fourth level</a:t>
             </a:r>
+            <a:endParaRPr lang="en-US" smtClean="0"/>
           </a:p>
           <a:p>
             <a:pPr lvl="4"/>
@@ -2721,8 +2743,6 @@
           <a:p>
             <a:fld id="{1D8BD707-D9CF-40AE-B4C6-C98DA3205C09}" type="datetimeFigureOut">
               <a:rPr lang="en-US" smtClean="0"/>
-              <a:pPr/>
-              <a:t>8/1/2011</a:t>
             </a:fld>
             <a:endParaRPr lang="en-US"/>
           </a:p>
@@ -2800,8 +2820,6 @@
           <a:p>
             <a:fld id="{B6F15528-21DE-4FAA-801E-634DDDAF4B2B}" type="slidenum">
               <a:rPr lang="en-US" smtClean="0"/>
-              <a:pPr/>
-              <a:t>‹#›</a:t>
             </a:fld>
             <a:endParaRPr lang="en-US"/>
           </a:p>
@@ -2845,7 +2863,7 @@
         <a:spcBef>
           <a:spcPct val="20000"/>
         </a:spcBef>
-        <a:buFont typeface="Arial" pitchFamily="34" charset="0"/>
+        <a:buFont typeface="Arial" panose="020B0604020202020204" pitchFamily="34" charset="0"/>
         <a:buChar char="•"/>
         <a:defRPr sz="3200" kern="1200">
           <a:solidFill>
@@ -2860,7 +2878,7 @@
         <a:spcBef>
           <a:spcPct val="20000"/>
         </a:spcBef>
-        <a:buFont typeface="Arial" pitchFamily="34" charset="0"/>
+        <a:buFont typeface="Arial" panose="020B0604020202020204" pitchFamily="34" charset="0"/>
         <a:buChar char="–"/>
         <a:defRPr sz="2800" kern="1200">
           <a:solidFill>
@@ -2875,7 +2893,7 @@
         <a:spcBef>
           <a:spcPct val="20000"/>
         </a:spcBef>
-        <a:buFont typeface="Arial" pitchFamily="34" charset="0"/>
+        <a:buFont typeface="Arial" panose="020B0604020202020204" pitchFamily="34" charset="0"/>
         <a:buChar char="•"/>
         <a:defRPr sz="2400" kern="1200">
           <a:solidFill>
@@ -2890,7 +2908,7 @@
         <a:spcBef>
           <a:spcPct val="20000"/>
         </a:spcBef>
-        <a:buFont typeface="Arial" pitchFamily="34" charset="0"/>
+        <a:buFont typeface="Arial" panose="020B0604020202020204" pitchFamily="34" charset="0"/>
         <a:buChar char="–"/>
         <a:defRPr sz="2000" kern="1200">
           <a:solidFill>
@@ -2905,7 +2923,7 @@
         <a:spcBef>
           <a:spcPct val="20000"/>
         </a:spcBef>
-        <a:buFont typeface="Arial" pitchFamily="34" charset="0"/>
+        <a:buFont typeface="Arial" panose="020B0604020202020204" pitchFamily="34" charset="0"/>
         <a:buChar char="»"/>
         <a:defRPr sz="2000" kern="1200">
           <a:solidFill>
@@ -2920,7 +2938,7 @@
         <a:spcBef>
           <a:spcPct val="20000"/>
         </a:spcBef>
-        <a:buFont typeface="Arial" pitchFamily="34" charset="0"/>
+        <a:buFont typeface="Arial" panose="020B0604020202020204" pitchFamily="34" charset="0"/>
         <a:buChar char="•"/>
         <a:defRPr sz="2000" kern="1200">
           <a:solidFill>
@@ -2935,7 +2953,7 @@
         <a:spcBef>
           <a:spcPct val="20000"/>
         </a:spcBef>
-        <a:buFont typeface="Arial" pitchFamily="34" charset="0"/>
+        <a:buFont typeface="Arial" panose="020B0604020202020204" pitchFamily="34" charset="0"/>
         <a:buChar char="•"/>
         <a:defRPr sz="2000" kern="1200">
           <a:solidFill>
@@ -2950,7 +2968,7 @@
         <a:spcBef>
           <a:spcPct val="20000"/>
         </a:spcBef>
-        <a:buFont typeface="Arial" pitchFamily="34" charset="0"/>
+        <a:buFont typeface="Arial" panose="020B0604020202020204" pitchFamily="34" charset="0"/>
         <a:buChar char="•"/>
         <a:defRPr sz="2000" kern="1200">
           <a:solidFill>
@@ -2965,7 +2983,7 @@
         <a:spcBef>
           <a:spcPct val="20000"/>
         </a:spcBef>
-        <a:buFont typeface="Arial" pitchFamily="34" charset="0"/>
+        <a:buFont typeface="Arial" panose="020B0604020202020204" pitchFamily="34" charset="0"/>
         <a:buChar char="•"/>
         <a:defRPr sz="2000" kern="1200">
           <a:solidFill>
@@ -3077,7 +3095,7 @@
 </file>
 
 <file path=ppt/slides/slide1.xml><?xml version="1.0" encoding="utf-8"?>
-<p:sld xmlns:p="http://schemas.openxmlformats.org/presentationml/2006/main" xmlns:a="http://schemas.openxmlformats.org/drawingml/2006/main" xmlns:r="http://schemas.openxmlformats.org/officeDocument/2006/relationships">
+<p:sld xmlns:a="http://schemas.openxmlformats.org/drawingml/2006/main" xmlns:r="http://schemas.openxmlformats.org/officeDocument/2006/relationships" xmlns:p="http://schemas.openxmlformats.org/presentationml/2006/main">
   <p:cSld>
     <p:spTree>
       <p:nvGrpSpPr>
@@ -3093,9 +3111,61 @@
           <a:chExt cx="0" cy="0"/>
         </a:xfrm>
       </p:grpSpPr>
+      <p:sp>
+        <p:nvSpPr>
+          <p:cNvPr id="2" name="Freeform 2"/>
+          <p:cNvSpPr/>
+          <p:nvPr/>
+        </p:nvSpPr>
+        <p:spPr>
+          <a:xfrm>
+            <a:off x="0" y="0"/>
+            <a:ext cx="10692000" cy="7524531"/>
+          </a:xfrm>
+          <a:custGeom>
+            <a:avLst/>
+            <a:gdLst/>
+            <a:ahLst/>
+            <a:cxnLst/>
+            <a:rect l="l" t="t" r="r" b="b"/>
+            <a:pathLst>
+              <a:path w="10692000" h="7524531">
+                <a:moveTo>
+                  <a:pt x="0" y="0"/>
+                </a:moveTo>
+                <a:lnTo>
+                  <a:pt x="10692000" y="0"/>
+                </a:lnTo>
+                <a:lnTo>
+                  <a:pt x="10692000" y="7524531"/>
+                </a:lnTo>
+                <a:lnTo>
+                  <a:pt x="0" y="7524531"/>
+                </a:lnTo>
+                <a:lnTo>
+                  <a:pt x="0" y="0"/>
+                </a:lnTo>
+                <a:close/>
+              </a:path>
+            </a:pathLst>
+          </a:custGeom>
+          <a:blipFill>
+            <a:blip r:embed="rId1"/>
+            <a:stretch>
+              <a:fillRect/>
+            </a:stretch>
+          </a:blipFill>
+        </p:spPr>
+        <p:txBody>
+          <a:bodyPr/>
+          <a:p>
+            <a:endParaRPr lang="en-US"/>
+          </a:p>
+        </p:txBody>
+      </p:sp>
       <p:grpSp>
         <p:nvGrpSpPr>
-          <p:cNvPr name="Group 2" id="2"/>
+          <p:cNvPr id="3" name="Group 3"/>
           <p:cNvGrpSpPr/>
           <p:nvPr/>
         </p:nvGrpSpPr>
@@ -3109,7 +3179,7 @@
         </p:grpSpPr>
         <p:grpSp>
           <p:nvGrpSpPr>
-            <p:cNvPr name="Group 3" id="3"/>
+            <p:cNvPr id="4" name="Group 4"/>
             <p:cNvGrpSpPr/>
             <p:nvPr/>
           </p:nvGrpSpPr>
@@ -3123,12 +3193,12 @@
           </p:grpSpPr>
           <p:sp>
             <p:nvSpPr>
-              <p:cNvPr name="Freeform 4" id="4"/>
+              <p:cNvPr id="5" name="Freeform 5"/>
               <p:cNvSpPr/>
               <p:nvPr/>
             </p:nvSpPr>
             <p:spPr>
-              <a:xfrm flipH="false" flipV="false" rot="0">
+              <a:xfrm>
                 <a:off x="50800" y="-4496"/>
                 <a:ext cx="4839970" cy="3711878"/>
               </a:xfrm>
@@ -3137,9 +3207,9 @@
                 <a:gdLst/>
                 <a:ahLst/>
                 <a:cxnLst/>
-                <a:rect r="r" b="b" t="t" l="l"/>
+                <a:rect l="l" t="t" r="r" b="b"/>
                 <a:pathLst>
-                  <a:path h="3711878" w="4839970">
+                  <a:path w="4839970" h="3711878">
                     <a:moveTo>
                       <a:pt x="0" y="2384476"/>
                     </a:moveTo>
@@ -3846,7 +3916,7 @@
         </p:grpSp>
         <p:grpSp>
           <p:nvGrpSpPr>
-            <p:cNvPr name="Group 5" id="5"/>
+            <p:cNvPr id="6" name="Group 6"/>
             <p:cNvGrpSpPr/>
             <p:nvPr/>
           </p:nvGrpSpPr>
@@ -3860,12 +3930,12 @@
           </p:grpSpPr>
           <p:sp>
             <p:nvSpPr>
-              <p:cNvPr name="Freeform 6" id="6"/>
+              <p:cNvPr id="7" name="Freeform 7"/>
               <p:cNvSpPr/>
               <p:nvPr/>
             </p:nvSpPr>
             <p:spPr>
-              <a:xfrm flipH="false" flipV="false" rot="0">
+              <a:xfrm>
                 <a:off x="50800" y="50800"/>
                 <a:ext cx="1679712" cy="1252324"/>
               </a:xfrm>
@@ -3874,9 +3944,9 @@
                 <a:gdLst/>
                 <a:ahLst/>
                 <a:cxnLst/>
-                <a:rect r="r" b="b" t="t" l="l"/>
+                <a:rect l="l" t="t" r="r" b="b"/>
                 <a:pathLst>
-                  <a:path h="1252324" w="1679712">
+                  <a:path w="1679712" h="1252324">
                     <a:moveTo>
                       <a:pt x="0" y="580390"/>
                     </a:moveTo>
@@ -4193,7 +4263,7 @@
         </p:grpSp>
         <p:grpSp>
           <p:nvGrpSpPr>
-            <p:cNvPr name="Group 7" id="7"/>
+            <p:cNvPr id="8" name="Group 8"/>
             <p:cNvGrpSpPr/>
             <p:nvPr/>
           </p:nvGrpSpPr>
@@ -4207,12 +4277,12 @@
           </p:grpSpPr>
           <p:sp>
             <p:nvSpPr>
-              <p:cNvPr name="Freeform 8" id="8"/>
+              <p:cNvPr id="9" name="Freeform 9"/>
               <p:cNvSpPr/>
               <p:nvPr/>
             </p:nvSpPr>
             <p:spPr>
-              <a:xfrm flipH="false" flipV="false" rot="0">
+              <a:xfrm>
                 <a:off x="50032" y="41295"/>
                 <a:ext cx="1241558" cy="1269219"/>
               </a:xfrm>
@@ -4221,9 +4291,9 @@
                 <a:gdLst/>
                 <a:ahLst/>
                 <a:cxnLst/>
-                <a:rect r="r" b="b" t="t" l="l"/>
+                <a:rect l="l" t="t" r="r" b="b"/>
                 <a:pathLst>
-                  <a:path h="1269219" w="1241558">
+                  <a:path w="1241558" h="1269219">
                     <a:moveTo>
                       <a:pt x="1241558" y="445115"/>
                     </a:moveTo>
@@ -4300,7 +4370,7 @@
         </p:grpSp>
         <p:grpSp>
           <p:nvGrpSpPr>
-            <p:cNvPr name="Group 9" id="9"/>
+            <p:cNvPr id="10" name="Group 10"/>
             <p:cNvGrpSpPr/>
             <p:nvPr/>
           </p:nvGrpSpPr>
@@ -4314,12 +4384,12 @@
           </p:grpSpPr>
           <p:sp>
             <p:nvSpPr>
-              <p:cNvPr name="Freeform 10" id="10"/>
+              <p:cNvPr id="11" name="Freeform 11"/>
               <p:cNvSpPr/>
               <p:nvPr/>
             </p:nvSpPr>
             <p:spPr>
-              <a:xfrm flipH="false" flipV="false" rot="0">
+              <a:xfrm>
                 <a:off x="50170" y="50800"/>
                 <a:ext cx="4555438" cy="3884930"/>
               </a:xfrm>
@@ -4328,9 +4398,9 @@
                 <a:gdLst/>
                 <a:ahLst/>
                 <a:cxnLst/>
-                <a:rect r="r" b="b" t="t" l="l"/>
+                <a:rect l="l" t="t" r="r" b="b"/>
                 <a:pathLst>
-                  <a:path h="3884930" w="4555438">
+                  <a:path w="4555438" h="3884930">
                     <a:moveTo>
                       <a:pt x="630" y="1440180"/>
                     </a:moveTo>
@@ -4797,7 +4867,7 @@
         </p:grpSp>
         <p:grpSp>
           <p:nvGrpSpPr>
-            <p:cNvPr name="Group 11" id="11"/>
+            <p:cNvPr id="12" name="Group 12"/>
             <p:cNvGrpSpPr/>
             <p:nvPr/>
           </p:nvGrpSpPr>
@@ -4811,12 +4881,12 @@
           </p:grpSpPr>
           <p:sp>
             <p:nvSpPr>
-              <p:cNvPr name="Freeform 12" id="12"/>
+              <p:cNvPr id="13" name="Freeform 13"/>
               <p:cNvSpPr/>
               <p:nvPr/>
             </p:nvSpPr>
             <p:spPr>
-              <a:xfrm flipH="false" flipV="false" rot="0">
+              <a:xfrm>
                 <a:off x="50032" y="40910"/>
                 <a:ext cx="1241558" cy="1269229"/>
               </a:xfrm>
@@ -4825,9 +4895,9 @@
                 <a:gdLst/>
                 <a:ahLst/>
                 <a:cxnLst/>
-                <a:rect r="r" b="b" t="t" l="l"/>
+                <a:rect l="l" t="t" r="r" b="b"/>
                 <a:pathLst>
-                  <a:path h="1269229" w="1241558">
+                  <a:path w="1241558" h="1269229">
                     <a:moveTo>
                       <a:pt x="1241558" y="445500"/>
                     </a:moveTo>
@@ -4904,7 +4974,7 @@
         </p:grpSp>
         <p:grpSp>
           <p:nvGrpSpPr>
-            <p:cNvPr name="Group 13" id="13"/>
+            <p:cNvPr id="14" name="Group 14"/>
             <p:cNvGrpSpPr/>
             <p:nvPr/>
           </p:nvGrpSpPr>
@@ -4918,12 +4988,12 @@
           </p:grpSpPr>
           <p:sp>
             <p:nvSpPr>
-              <p:cNvPr name="Freeform 14" id="14"/>
+              <p:cNvPr id="15" name="Freeform 15"/>
               <p:cNvSpPr/>
               <p:nvPr/>
             </p:nvSpPr>
             <p:spPr>
-              <a:xfrm flipH="false" flipV="false" rot="0">
+              <a:xfrm>
                 <a:off x="50800" y="48157"/>
                 <a:ext cx="2552933" cy="1741443"/>
               </a:xfrm>
@@ -4932,9 +5002,9 @@
                 <a:gdLst/>
                 <a:ahLst/>
                 <a:cxnLst/>
-                <a:rect r="r" b="b" t="t" l="l"/>
+                <a:rect l="l" t="t" r="r" b="b"/>
                 <a:pathLst>
-                  <a:path h="1741443" w="2552933">
+                  <a:path w="2552933" h="1741443">
                     <a:moveTo>
                       <a:pt x="2162810" y="1220573"/>
                     </a:moveTo>
@@ -5321,7 +5391,7 @@
         </p:grpSp>
         <p:grpSp>
           <p:nvGrpSpPr>
-            <p:cNvPr name="Group 15" id="15"/>
+            <p:cNvPr id="16" name="Group 16"/>
             <p:cNvGrpSpPr/>
             <p:nvPr/>
           </p:nvGrpSpPr>
@@ -5335,12 +5405,12 @@
           </p:grpSpPr>
           <p:sp>
             <p:nvSpPr>
-              <p:cNvPr name="Freeform 16" id="16"/>
+              <p:cNvPr id="17" name="Freeform 17"/>
               <p:cNvSpPr/>
               <p:nvPr/>
             </p:nvSpPr>
             <p:spPr>
-              <a:xfrm flipH="false" flipV="false" rot="0">
+              <a:xfrm>
                 <a:off x="50800" y="48720"/>
                 <a:ext cx="3124847" cy="1933111"/>
               </a:xfrm>
@@ -5349,9 +5419,9 @@
                 <a:gdLst/>
                 <a:ahLst/>
                 <a:cxnLst/>
-                <a:rect r="r" b="b" t="t" l="l"/>
+                <a:rect l="l" t="t" r="r" b="b"/>
                 <a:pathLst>
-                  <a:path h="1933111" w="3124847">
+                  <a:path w="3124847" h="1933111">
                     <a:moveTo>
                       <a:pt x="2694940" y="1235250"/>
                     </a:moveTo>
@@ -5738,7 +5808,7 @@
         </p:grpSp>
         <p:grpSp>
           <p:nvGrpSpPr>
-            <p:cNvPr name="Group 17" id="17"/>
+            <p:cNvPr id="18" name="Group 18"/>
             <p:cNvGrpSpPr/>
             <p:nvPr/>
           </p:nvGrpSpPr>
@@ -5752,12 +5822,12 @@
           </p:grpSpPr>
           <p:sp>
             <p:nvSpPr>
-              <p:cNvPr name="Freeform 18" id="18"/>
+              <p:cNvPr id="19" name="Freeform 19"/>
               <p:cNvSpPr/>
               <p:nvPr/>
             </p:nvSpPr>
             <p:spPr>
-              <a:xfrm flipH="false" flipV="false" rot="0">
+              <a:xfrm>
                 <a:off x="50800" y="49305"/>
                 <a:ext cx="2969260" cy="2131489"/>
               </a:xfrm>
@@ -5766,9 +5836,9 @@
                 <a:gdLst/>
                 <a:ahLst/>
                 <a:cxnLst/>
-                <a:rect r="r" b="b" t="t" l="l"/>
+                <a:rect l="l" t="t" r="r" b="b"/>
                 <a:pathLst>
-                  <a:path h="2131489" w="2969260">
+                  <a:path w="2969260" h="2131489">
                     <a:moveTo>
                       <a:pt x="0" y="1134335"/>
                     </a:moveTo>
@@ -6225,7 +6295,7 @@
         </p:grpSp>
         <p:grpSp>
           <p:nvGrpSpPr>
-            <p:cNvPr name="Group 19" id="19"/>
+            <p:cNvPr id="20" name="Group 20"/>
             <p:cNvGrpSpPr/>
             <p:nvPr/>
           </p:nvGrpSpPr>
@@ -6239,12 +6309,12 @@
           </p:grpSpPr>
           <p:sp>
             <p:nvSpPr>
-              <p:cNvPr name="Freeform 20" id="20"/>
+              <p:cNvPr id="21" name="Freeform 21"/>
               <p:cNvSpPr/>
               <p:nvPr/>
             </p:nvSpPr>
             <p:spPr>
-              <a:xfrm flipH="false" flipV="false" rot="0">
+              <a:xfrm>
                 <a:off x="50800" y="50800"/>
                 <a:ext cx="2841554" cy="2381081"/>
               </a:xfrm>
@@ -6253,9 +6323,9 @@
                 <a:gdLst/>
                 <a:ahLst/>
                 <a:cxnLst/>
-                <a:rect r="r" b="b" t="t" l="l"/>
+                <a:rect l="l" t="t" r="r" b="b"/>
                 <a:pathLst>
-                  <a:path h="2381081" w="2841554">
+                  <a:path w="2841554" h="2381081">
                     <a:moveTo>
                       <a:pt x="0" y="685800"/>
                     </a:moveTo>
@@ -6662,7 +6732,7 @@
         </p:grpSp>
         <p:grpSp>
           <p:nvGrpSpPr>
-            <p:cNvPr name="Group 21" id="21"/>
+            <p:cNvPr id="22" name="Group 22"/>
             <p:cNvGrpSpPr/>
             <p:nvPr/>
           </p:nvGrpSpPr>
@@ -6676,12 +6746,12 @@
           </p:grpSpPr>
           <p:sp>
             <p:nvSpPr>
-              <p:cNvPr name="Freeform 22" id="22"/>
+              <p:cNvPr id="23" name="Freeform 23"/>
               <p:cNvSpPr/>
               <p:nvPr/>
             </p:nvSpPr>
             <p:spPr>
-              <a:xfrm flipH="false" flipV="false" rot="0">
+              <a:xfrm>
                 <a:off x="50800" y="50800"/>
                 <a:ext cx="4634240" cy="4117340"/>
               </a:xfrm>
@@ -6690,9 +6760,9 @@
                 <a:gdLst/>
                 <a:ahLst/>
                 <a:cxnLst/>
-                <a:rect r="r" b="b" t="t" l="l"/>
+                <a:rect l="l" t="t" r="r" b="b"/>
                 <a:pathLst>
-                  <a:path h="4117340" w="4634240">
+                  <a:path w="4634240" h="4117340">
                     <a:moveTo>
                       <a:pt x="0" y="3488690"/>
                     </a:moveTo>
@@ -7264,7 +7334,7 @@
         </p:grpSp>
         <p:grpSp>
           <p:nvGrpSpPr>
-            <p:cNvPr name="Group 23" id="23"/>
+            <p:cNvPr id="24" name="Group 24"/>
             <p:cNvGrpSpPr/>
             <p:nvPr/>
           </p:nvGrpSpPr>
@@ -7278,12 +7348,12 @@
           </p:grpSpPr>
           <p:sp>
             <p:nvSpPr>
-              <p:cNvPr name="Freeform 24" id="24"/>
+              <p:cNvPr id="25" name="Freeform 25"/>
               <p:cNvSpPr/>
               <p:nvPr/>
             </p:nvSpPr>
             <p:spPr>
-              <a:xfrm flipH="false" flipV="false" rot="0">
+              <a:xfrm>
                 <a:off x="50800" y="50608"/>
                 <a:ext cx="9660890" cy="3496502"/>
               </a:xfrm>
@@ -7292,9 +7362,9 @@
                 <a:gdLst/>
                 <a:ahLst/>
                 <a:cxnLst/>
-                <a:rect r="r" b="b" t="t" l="l"/>
+                <a:rect l="l" t="t" r="r" b="b"/>
                 <a:pathLst>
-                  <a:path h="3496502" w="9660890">
+                  <a:path w="9660890" h="3496502">
                     <a:moveTo>
                       <a:pt x="0" y="2290002"/>
                     </a:moveTo>
@@ -8141,7 +8211,7 @@
         </p:grpSp>
         <p:grpSp>
           <p:nvGrpSpPr>
-            <p:cNvPr name="Group 25" id="25"/>
+            <p:cNvPr id="26" name="Group 26"/>
             <p:cNvGrpSpPr/>
             <p:nvPr/>
           </p:nvGrpSpPr>
@@ -8155,12 +8225,12 @@
           </p:grpSpPr>
           <p:sp>
             <p:nvSpPr>
-              <p:cNvPr name="Freeform 26" id="26"/>
+              <p:cNvPr id="27" name="Freeform 27"/>
               <p:cNvSpPr/>
               <p:nvPr/>
             </p:nvSpPr>
             <p:spPr>
-              <a:xfrm flipH="false" flipV="false" rot="0">
+              <a:xfrm>
                 <a:off x="50800" y="50185"/>
                 <a:ext cx="3733800" cy="1922125"/>
               </a:xfrm>
@@ -8169,9 +8239,9 @@
                 <a:gdLst/>
                 <a:ahLst/>
                 <a:cxnLst/>
-                <a:rect r="r" b="b" t="t" l="l"/>
+                <a:rect l="l" t="t" r="r" b="b"/>
                 <a:pathLst>
-                  <a:path h="1922125" w="3733800">
+                  <a:path w="3733800" h="1922125">
                     <a:moveTo>
                       <a:pt x="0" y="955655"/>
                     </a:moveTo>
@@ -8646,7 +8716,7 @@
         </p:grpSp>
         <p:grpSp>
           <p:nvGrpSpPr>
-            <p:cNvPr name="Group 27" id="27"/>
+            <p:cNvPr id="28" name="Group 28"/>
             <p:cNvGrpSpPr/>
             <p:nvPr/>
           </p:nvGrpSpPr>
@@ -8660,12 +8730,12 @@
           </p:grpSpPr>
           <p:sp>
             <p:nvSpPr>
-              <p:cNvPr name="Freeform 28" id="28"/>
+              <p:cNvPr id="29" name="Freeform 29"/>
               <p:cNvSpPr/>
               <p:nvPr/>
             </p:nvSpPr>
             <p:spPr>
-              <a:xfrm flipH="false" flipV="false" rot="0">
+              <a:xfrm>
                 <a:off x="50032" y="41295"/>
                 <a:ext cx="1241558" cy="1269220"/>
               </a:xfrm>
@@ -8674,9 +8744,9 @@
                 <a:gdLst/>
                 <a:ahLst/>
                 <a:cxnLst/>
-                <a:rect r="r" b="b" t="t" l="l"/>
+                <a:rect l="l" t="t" r="r" b="b"/>
                 <a:pathLst>
-                  <a:path h="1269220" w="1241558">
+                  <a:path w="1241558" h="1269220">
                     <a:moveTo>
                       <a:pt x="1241558" y="446385"/>
                     </a:moveTo>
@@ -8753,7 +8823,7 @@
         </p:grpSp>
         <p:grpSp>
           <p:nvGrpSpPr>
-            <p:cNvPr name="Group 29" id="29"/>
+            <p:cNvPr id="30" name="Group 30"/>
             <p:cNvGrpSpPr/>
             <p:nvPr/>
           </p:nvGrpSpPr>
@@ -8767,12 +8837,12 @@
           </p:grpSpPr>
           <p:sp>
             <p:nvSpPr>
-              <p:cNvPr name="Freeform 30" id="30"/>
+              <p:cNvPr id="31" name="Freeform 31"/>
               <p:cNvSpPr/>
               <p:nvPr/>
             </p:nvSpPr>
             <p:spPr>
-              <a:xfrm flipH="false" flipV="false" rot="0">
+              <a:xfrm>
                 <a:off x="50032" y="41295"/>
                 <a:ext cx="1241558" cy="1269220"/>
               </a:xfrm>
@@ -8781,9 +8851,9 @@
                 <a:gdLst/>
                 <a:ahLst/>
                 <a:cxnLst/>
-                <a:rect r="r" b="b" t="t" l="l"/>
+                <a:rect l="l" t="t" r="r" b="b"/>
                 <a:pathLst>
-                  <a:path h="1269220" w="1241558">
+                  <a:path w="1241558" h="1269220">
                     <a:moveTo>
                       <a:pt x="1241558" y="446385"/>
                     </a:moveTo>
@@ -8860,7 +8930,7 @@
         </p:grpSp>
         <p:grpSp>
           <p:nvGrpSpPr>
-            <p:cNvPr name="Group 31" id="31"/>
+            <p:cNvPr id="32" name="Group 32"/>
             <p:cNvGrpSpPr/>
             <p:nvPr/>
           </p:nvGrpSpPr>
@@ -8874,12 +8944,12 @@
           </p:grpSpPr>
           <p:sp>
             <p:nvSpPr>
-              <p:cNvPr name="Freeform 32" id="32"/>
+              <p:cNvPr id="33" name="Freeform 33"/>
               <p:cNvSpPr/>
               <p:nvPr/>
             </p:nvSpPr>
             <p:spPr>
-              <a:xfrm flipH="false" flipV="false" rot="0">
+              <a:xfrm>
                 <a:off x="50032" y="41295"/>
                 <a:ext cx="1241558" cy="1269220"/>
               </a:xfrm>
@@ -8888,9 +8958,9 @@
                 <a:gdLst/>
                 <a:ahLst/>
                 <a:cxnLst/>
-                <a:rect r="r" b="b" t="t" l="l"/>
+                <a:rect l="l" t="t" r="r" b="b"/>
                 <a:pathLst>
-                  <a:path h="1269220" w="1241558">
+                  <a:path w="1241558" h="1269220">
                     <a:moveTo>
                       <a:pt x="1241558" y="446385"/>
                     </a:moveTo>
@@ -8967,7 +9037,7 @@
         </p:grpSp>
         <p:grpSp>
           <p:nvGrpSpPr>
-            <p:cNvPr name="Group 33" id="33"/>
+            <p:cNvPr id="34" name="Group 34"/>
             <p:cNvGrpSpPr/>
             <p:nvPr/>
           </p:nvGrpSpPr>
@@ -8981,12 +9051,12 @@
           </p:grpSpPr>
           <p:sp>
             <p:nvSpPr>
-              <p:cNvPr name="Freeform 34" id="34"/>
+              <p:cNvPr id="35" name="Freeform 35"/>
               <p:cNvSpPr/>
               <p:nvPr/>
             </p:nvSpPr>
             <p:spPr>
-              <a:xfrm flipH="false" flipV="false" rot="0">
+              <a:xfrm>
                 <a:off x="50032" y="41295"/>
                 <a:ext cx="1241558" cy="1269220"/>
               </a:xfrm>
@@ -8995,9 +9065,9 @@
                 <a:gdLst/>
                 <a:ahLst/>
                 <a:cxnLst/>
-                <a:rect r="r" b="b" t="t" l="l"/>
+                <a:rect l="l" t="t" r="r" b="b"/>
                 <a:pathLst>
-                  <a:path h="1269220" w="1241558">
+                  <a:path w="1241558" h="1269220">
                     <a:moveTo>
                       <a:pt x="1241558" y="446385"/>
                     </a:moveTo>
@@ -9074,7 +9144,7 @@
         </p:grpSp>
         <p:grpSp>
           <p:nvGrpSpPr>
-            <p:cNvPr name="Group 35" id="35"/>
+            <p:cNvPr id="36" name="Group 36"/>
             <p:cNvGrpSpPr/>
             <p:nvPr/>
           </p:nvGrpSpPr>
@@ -9088,12 +9158,12 @@
           </p:grpSpPr>
           <p:sp>
             <p:nvSpPr>
-              <p:cNvPr name="Freeform 36" id="36"/>
+              <p:cNvPr id="37" name="Freeform 37"/>
               <p:cNvSpPr/>
               <p:nvPr/>
             </p:nvSpPr>
             <p:spPr>
-              <a:xfrm flipH="false" flipV="false" rot="0">
+              <a:xfrm>
                 <a:off x="50032" y="41295"/>
                 <a:ext cx="1241558" cy="1269220"/>
               </a:xfrm>
@@ -9102,9 +9172,9 @@
                 <a:gdLst/>
                 <a:ahLst/>
                 <a:cxnLst/>
-                <a:rect r="r" b="b" t="t" l="l"/>
+                <a:rect l="l" t="t" r="r" b="b"/>
                 <a:pathLst>
-                  <a:path h="1269220" w="1241558">
+                  <a:path w="1241558" h="1269220">
                     <a:moveTo>
                       <a:pt x="1241558" y="446385"/>
                     </a:moveTo>
@@ -9181,7 +9251,7 @@
         </p:grpSp>
         <p:grpSp>
           <p:nvGrpSpPr>
-            <p:cNvPr name="Group 37" id="37"/>
+            <p:cNvPr id="38" name="Group 38"/>
             <p:cNvGrpSpPr/>
             <p:nvPr/>
           </p:nvGrpSpPr>
@@ -9195,12 +9265,12 @@
           </p:grpSpPr>
           <p:sp>
             <p:nvSpPr>
-              <p:cNvPr name="Freeform 38" id="38"/>
+              <p:cNvPr id="39" name="Freeform 39"/>
               <p:cNvSpPr/>
               <p:nvPr/>
             </p:nvSpPr>
             <p:spPr>
-              <a:xfrm flipH="false" flipV="false" rot="0">
+              <a:xfrm>
                 <a:off x="50032" y="41295"/>
                 <a:ext cx="1241558" cy="1269220"/>
               </a:xfrm>
@@ -9209,9 +9279,9 @@
                 <a:gdLst/>
                 <a:ahLst/>
                 <a:cxnLst/>
-                <a:rect r="r" b="b" t="t" l="l"/>
+                <a:rect l="l" t="t" r="r" b="b"/>
                 <a:pathLst>
-                  <a:path h="1269220" w="1241558">
+                  <a:path w="1241558" h="1269220">
                     <a:moveTo>
                       <a:pt x="1241558" y="446385"/>
                     </a:moveTo>
@@ -9288,7 +9358,7 @@
         </p:grpSp>
         <p:grpSp>
           <p:nvGrpSpPr>
-            <p:cNvPr name="Group 39" id="39"/>
+            <p:cNvPr id="40" name="Group 40"/>
             <p:cNvGrpSpPr/>
             <p:nvPr/>
           </p:nvGrpSpPr>
@@ -9302,12 +9372,12 @@
           </p:grpSpPr>
           <p:sp>
             <p:nvSpPr>
-              <p:cNvPr name="Freeform 40" id="40"/>
+              <p:cNvPr id="41" name="Freeform 41"/>
               <p:cNvSpPr/>
               <p:nvPr/>
             </p:nvSpPr>
             <p:spPr>
-              <a:xfrm flipH="false" flipV="false" rot="0">
+              <a:xfrm>
                 <a:off x="50032" y="41295"/>
                 <a:ext cx="1241558" cy="1269220"/>
               </a:xfrm>
@@ -9316,9 +9386,9 @@
                 <a:gdLst/>
                 <a:ahLst/>
                 <a:cxnLst/>
-                <a:rect r="r" b="b" t="t" l="l"/>
+                <a:rect l="l" t="t" r="r" b="b"/>
                 <a:pathLst>
-                  <a:path h="1269220" w="1241558">
+                  <a:path w="1241558" h="1269220">
                     <a:moveTo>
                       <a:pt x="1241558" y="446385"/>
                     </a:moveTo>
@@ -9395,7 +9465,7 @@
         </p:grpSp>
         <p:grpSp>
           <p:nvGrpSpPr>
-            <p:cNvPr name="Group 41" id="41"/>
+            <p:cNvPr id="42" name="Group 42"/>
             <p:cNvGrpSpPr/>
             <p:nvPr/>
           </p:nvGrpSpPr>
@@ -9409,12 +9479,12 @@
           </p:grpSpPr>
           <p:sp>
             <p:nvSpPr>
-              <p:cNvPr name="Freeform 42" id="42"/>
+              <p:cNvPr id="43" name="Freeform 43"/>
               <p:cNvSpPr/>
               <p:nvPr/>
             </p:nvSpPr>
             <p:spPr>
-              <a:xfrm flipH="false" flipV="false" rot="0">
+              <a:xfrm>
                 <a:off x="50032" y="41295"/>
                 <a:ext cx="1241558" cy="1269220"/>
               </a:xfrm>
@@ -9423,9 +9493,9 @@
                 <a:gdLst/>
                 <a:ahLst/>
                 <a:cxnLst/>
-                <a:rect r="r" b="b" t="t" l="l"/>
+                <a:rect l="l" t="t" r="r" b="b"/>
                 <a:pathLst>
-                  <a:path h="1269220" w="1241558">
+                  <a:path w="1241558" h="1269220">
                     <a:moveTo>
                       <a:pt x="1241558" y="446385"/>
                     </a:moveTo>
@@ -9502,7 +9572,7 @@
         </p:grpSp>
         <p:grpSp>
           <p:nvGrpSpPr>
-            <p:cNvPr name="Group 43" id="43"/>
+            <p:cNvPr id="44" name="Group 44"/>
             <p:cNvGrpSpPr/>
             <p:nvPr/>
           </p:nvGrpSpPr>
@@ -9516,12 +9586,12 @@
           </p:grpSpPr>
           <p:sp>
             <p:nvSpPr>
-              <p:cNvPr name="Freeform 44" id="44"/>
+              <p:cNvPr id="45" name="Freeform 45"/>
               <p:cNvSpPr/>
               <p:nvPr/>
             </p:nvSpPr>
             <p:spPr>
-              <a:xfrm flipH="false" flipV="false" rot="0">
+              <a:xfrm>
                 <a:off x="50032" y="41295"/>
                 <a:ext cx="1241558" cy="1269220"/>
               </a:xfrm>
@@ -9530,9 +9600,9 @@
                 <a:gdLst/>
                 <a:ahLst/>
                 <a:cxnLst/>
-                <a:rect r="r" b="b" t="t" l="l"/>
+                <a:rect l="l" t="t" r="r" b="b"/>
                 <a:pathLst>
-                  <a:path h="1269220" w="1241558">
+                  <a:path w="1241558" h="1269220">
                     <a:moveTo>
                       <a:pt x="1241558" y="446385"/>
                     </a:moveTo>
@@ -9609,7 +9679,7 @@
         </p:grpSp>
         <p:grpSp>
           <p:nvGrpSpPr>
-            <p:cNvPr name="Group 45" id="45"/>
+            <p:cNvPr id="46" name="Group 46"/>
             <p:cNvGrpSpPr/>
             <p:nvPr/>
           </p:nvGrpSpPr>
@@ -9623,12 +9693,12 @@
           </p:grpSpPr>
           <p:sp>
             <p:nvSpPr>
-              <p:cNvPr name="Freeform 46" id="46"/>
+              <p:cNvPr id="47" name="Freeform 47"/>
               <p:cNvSpPr/>
               <p:nvPr/>
             </p:nvSpPr>
             <p:spPr>
-              <a:xfrm flipH="false" flipV="false" rot="0">
+              <a:xfrm>
                 <a:off x="49655" y="41295"/>
                 <a:ext cx="1240690" cy="1269219"/>
               </a:xfrm>
@@ -9637,9 +9707,9 @@
                 <a:gdLst/>
                 <a:ahLst/>
                 <a:cxnLst/>
-                <a:rect r="r" b="b" t="t" l="l"/>
+                <a:rect l="l" t="t" r="r" b="b"/>
                 <a:pathLst>
-                  <a:path h="1269219" w="1240690">
+                  <a:path w="1240690" h="1269219">
                     <a:moveTo>
                       <a:pt x="1240665" y="445115"/>
                     </a:moveTo>
@@ -9716,7 +9786,7 @@
         </p:grpSp>
         <p:grpSp>
           <p:nvGrpSpPr>
-            <p:cNvPr name="Group 47" id="47"/>
+            <p:cNvPr id="48" name="Group 48"/>
             <p:cNvGrpSpPr/>
             <p:nvPr/>
           </p:nvGrpSpPr>
@@ -9730,12 +9800,12 @@
           </p:grpSpPr>
           <p:sp>
             <p:nvSpPr>
-              <p:cNvPr name="Freeform 48" id="48"/>
+              <p:cNvPr id="49" name="Freeform 49"/>
               <p:cNvSpPr/>
               <p:nvPr/>
             </p:nvSpPr>
             <p:spPr>
-              <a:xfrm flipH="false" flipV="false" rot="0">
+              <a:xfrm>
                 <a:off x="48720" y="50153"/>
                 <a:ext cx="1280316" cy="1275610"/>
               </a:xfrm>
@@ -9744,9 +9814,9 @@
                 <a:gdLst/>
                 <a:ahLst/>
                 <a:cxnLst/>
-                <a:rect r="r" b="b" t="t" l="l"/>
+                <a:rect l="l" t="t" r="r" b="b"/>
                 <a:pathLst>
-                  <a:path h="1275610" w="1280316">
+                  <a:path w="1280316" h="1275610">
                     <a:moveTo>
                       <a:pt x="929180" y="71767"/>
                     </a:moveTo>
@@ -9973,7 +10043,7 @@
         </p:grpSp>
         <p:grpSp>
           <p:nvGrpSpPr>
-            <p:cNvPr name="Group 49" id="49"/>
+            <p:cNvPr id="50" name="Group 50"/>
             <p:cNvGrpSpPr/>
             <p:nvPr/>
           </p:nvGrpSpPr>
@@ -9987,12 +10057,12 @@
           </p:grpSpPr>
           <p:sp>
             <p:nvSpPr>
-              <p:cNvPr name="Freeform 50" id="50"/>
+              <p:cNvPr id="51" name="Freeform 51"/>
               <p:cNvSpPr/>
               <p:nvPr/>
             </p:nvSpPr>
             <p:spPr>
-              <a:xfrm flipH="false" flipV="false" rot="0">
+              <a:xfrm>
                 <a:off x="47135" y="50800"/>
                 <a:ext cx="1274623" cy="1270160"/>
               </a:xfrm>
@@ -10001,9 +10071,9 @@
                 <a:gdLst/>
                 <a:ahLst/>
                 <a:cxnLst/>
-                <a:rect r="r" b="b" t="t" l="l"/>
+                <a:rect l="l" t="t" r="r" b="b"/>
                 <a:pathLst>
-                  <a:path h="1270160" w="1274623">
+                  <a:path w="1274623" h="1270160">
                     <a:moveTo>
                       <a:pt x="639935" y="0"/>
                     </a:moveTo>
@@ -10230,7 +10300,7 @@
         </p:grpSp>
         <p:grpSp>
           <p:nvGrpSpPr>
-            <p:cNvPr name="Group 51" id="51"/>
+            <p:cNvPr id="52" name="Group 52"/>
             <p:cNvGrpSpPr/>
             <p:nvPr/>
           </p:nvGrpSpPr>
@@ -10244,12 +10314,12 @@
           </p:grpSpPr>
           <p:sp>
             <p:nvSpPr>
-              <p:cNvPr name="Freeform 52" id="52"/>
+              <p:cNvPr id="53" name="Freeform 53"/>
               <p:cNvSpPr/>
               <p:nvPr/>
             </p:nvSpPr>
             <p:spPr>
-              <a:xfrm flipH="false" flipV="false" rot="0">
+              <a:xfrm>
                 <a:off x="46037" y="50800"/>
                 <a:ext cx="1276151" cy="1274963"/>
               </a:xfrm>
@@ -10258,9 +10328,9 @@
                 <a:gdLst/>
                 <a:ahLst/>
                 <a:cxnLst/>
-                <a:rect r="r" b="b" t="t" l="l"/>
+                <a:rect l="l" t="t" r="r" b="b"/>
                 <a:pathLst>
-                  <a:path h="1274963" w="1276151">
+                  <a:path w="1276151" h="1274963">
                     <a:moveTo>
                       <a:pt x="1065213" y="167640"/>
                     </a:moveTo>
@@ -10487,7 +10557,7 @@
         </p:grpSp>
         <p:grpSp>
           <p:nvGrpSpPr>
-            <p:cNvPr name="Group 53" id="53"/>
+            <p:cNvPr id="54" name="Group 54"/>
             <p:cNvGrpSpPr/>
             <p:nvPr/>
           </p:nvGrpSpPr>
@@ -10501,12 +10571,12 @@
           </p:grpSpPr>
           <p:sp>
             <p:nvSpPr>
-              <p:cNvPr name="Freeform 54" id="54"/>
+              <p:cNvPr id="55" name="Freeform 55"/>
               <p:cNvSpPr/>
               <p:nvPr/>
             </p:nvSpPr>
             <p:spPr>
-              <a:xfrm flipH="false" flipV="false" rot="0">
+              <a:xfrm>
                 <a:off x="48775" y="50153"/>
                 <a:ext cx="1280097" cy="1280189"/>
               </a:xfrm>
@@ -10515,9 +10585,9 @@
                 <a:gdLst/>
                 <a:ahLst/>
                 <a:cxnLst/>
-                <a:rect r="r" b="b" t="t" l="l"/>
+                <a:rect l="l" t="t" r="r" b="b"/>
                 <a:pathLst>
-                  <a:path h="1280189" w="1280097">
+                  <a:path w="1280097" h="1280189">
                     <a:moveTo>
                       <a:pt x="1094225" y="194957"/>
                     </a:moveTo>
@@ -10744,7 +10814,7 @@
         </p:grpSp>
         <p:grpSp>
           <p:nvGrpSpPr>
-            <p:cNvPr name="Group 55" id="55"/>
+            <p:cNvPr id="56" name="Group 56"/>
             <p:cNvGrpSpPr/>
             <p:nvPr/>
           </p:nvGrpSpPr>
@@ -10758,12 +10828,12 @@
           </p:grpSpPr>
           <p:sp>
             <p:nvSpPr>
-              <p:cNvPr name="Freeform 56" id="56"/>
+              <p:cNvPr id="57" name="Freeform 57"/>
               <p:cNvSpPr/>
               <p:nvPr/>
             </p:nvSpPr>
             <p:spPr>
-              <a:xfrm flipH="false" flipV="false" rot="0">
+              <a:xfrm>
                 <a:off x="50033" y="41295"/>
                 <a:ext cx="1241557" cy="1269219"/>
               </a:xfrm>
@@ -10772,9 +10842,9 @@
                 <a:gdLst/>
                 <a:ahLst/>
                 <a:cxnLst/>
-                <a:rect r="r" b="b" t="t" l="l"/>
+                <a:rect l="l" t="t" r="r" b="b"/>
                 <a:pathLst>
-                  <a:path h="1269219" w="1241557">
+                  <a:path w="1241557" h="1269219">
                     <a:moveTo>
                       <a:pt x="1241557" y="445115"/>
                     </a:moveTo>
@@ -10851,7 +10921,7 @@
         </p:grpSp>
         <p:grpSp>
           <p:nvGrpSpPr>
-            <p:cNvPr name="Group 57" id="57"/>
+            <p:cNvPr id="58" name="Group 58"/>
             <p:cNvGrpSpPr/>
             <p:nvPr/>
           </p:nvGrpSpPr>
@@ -10865,12 +10935,12 @@
           </p:grpSpPr>
           <p:sp>
             <p:nvSpPr>
-              <p:cNvPr name="Freeform 58" id="58"/>
+              <p:cNvPr id="59" name="Freeform 59"/>
               <p:cNvSpPr/>
               <p:nvPr/>
             </p:nvSpPr>
             <p:spPr>
-              <a:xfrm flipH="false" flipV="false" rot="0">
+              <a:xfrm>
                 <a:off x="49655" y="41295"/>
                 <a:ext cx="1240690" cy="1269219"/>
               </a:xfrm>
@@ -10879,9 +10949,9 @@
                 <a:gdLst/>
                 <a:ahLst/>
                 <a:cxnLst/>
-                <a:rect r="r" b="b" t="t" l="l"/>
+                <a:rect l="l" t="t" r="r" b="b"/>
                 <a:pathLst>
-                  <a:path h="1269219" w="1240690">
+                  <a:path w="1240690" h="1269219">
                     <a:moveTo>
                       <a:pt x="1240665" y="445115"/>
                     </a:moveTo>
@@ -10958,7 +11028,7 @@
         </p:grpSp>
         <p:grpSp>
           <p:nvGrpSpPr>
-            <p:cNvPr name="Group 59" id="59"/>
+            <p:cNvPr id="60" name="Group 60"/>
             <p:cNvGrpSpPr/>
             <p:nvPr/>
           </p:nvGrpSpPr>
@@ -10972,12 +11042,12 @@
           </p:grpSpPr>
           <p:sp>
             <p:nvSpPr>
-              <p:cNvPr name="Freeform 60" id="60"/>
+              <p:cNvPr id="61" name="Freeform 61"/>
               <p:cNvSpPr/>
               <p:nvPr/>
             </p:nvSpPr>
             <p:spPr>
-              <a:xfrm flipH="false" flipV="false" rot="0">
+              <a:xfrm>
                 <a:off x="50032" y="41295"/>
                 <a:ext cx="1241558" cy="1269219"/>
               </a:xfrm>
@@ -10986,9 +11056,9 @@
                 <a:gdLst/>
                 <a:ahLst/>
                 <a:cxnLst/>
-                <a:rect r="r" b="b" t="t" l="l"/>
+                <a:rect l="l" t="t" r="r" b="b"/>
                 <a:pathLst>
-                  <a:path h="1269219" w="1241558">
+                  <a:path w="1241558" h="1269219">
                     <a:moveTo>
                       <a:pt x="1241558" y="445115"/>
                     </a:moveTo>
@@ -11065,7 +11135,7 @@
         </p:grpSp>
         <p:grpSp>
           <p:nvGrpSpPr>
-            <p:cNvPr name="Group 61" id="61"/>
+            <p:cNvPr id="62" name="Group 62"/>
             <p:cNvGrpSpPr/>
             <p:nvPr/>
           </p:nvGrpSpPr>
@@ -11079,12 +11149,12 @@
           </p:grpSpPr>
           <p:sp>
             <p:nvSpPr>
-              <p:cNvPr name="Freeform 62" id="62"/>
+              <p:cNvPr id="63" name="Freeform 63"/>
               <p:cNvSpPr/>
               <p:nvPr/>
             </p:nvSpPr>
             <p:spPr>
-              <a:xfrm flipH="false" flipV="false" rot="0">
+              <a:xfrm>
                 <a:off x="50032" y="41295"/>
                 <a:ext cx="1241558" cy="1269219"/>
               </a:xfrm>
@@ -11093,9 +11163,9 @@
                 <a:gdLst/>
                 <a:ahLst/>
                 <a:cxnLst/>
-                <a:rect r="r" b="b" t="t" l="l"/>
+                <a:rect l="l" t="t" r="r" b="b"/>
                 <a:pathLst>
-                  <a:path h="1269219" w="1241558">
+                  <a:path w="1241558" h="1269219">
                     <a:moveTo>
                       <a:pt x="1241558" y="445115"/>
                     </a:moveTo>
@@ -11172,7 +11242,7 @@
         </p:grpSp>
         <p:grpSp>
           <p:nvGrpSpPr>
-            <p:cNvPr name="Group 63" id="63"/>
+            <p:cNvPr id="64" name="Group 64"/>
             <p:cNvGrpSpPr/>
             <p:nvPr/>
           </p:nvGrpSpPr>
@@ -11186,12 +11256,12 @@
           </p:grpSpPr>
           <p:sp>
             <p:nvSpPr>
-              <p:cNvPr name="Freeform 64" id="64"/>
+              <p:cNvPr id="65" name="Freeform 65"/>
               <p:cNvSpPr/>
               <p:nvPr/>
             </p:nvSpPr>
             <p:spPr>
-              <a:xfrm flipH="false" flipV="false" rot="0">
+              <a:xfrm>
                 <a:off x="50033" y="41295"/>
                 <a:ext cx="1241557" cy="1269219"/>
               </a:xfrm>
@@ -11200,9 +11270,9 @@
                 <a:gdLst/>
                 <a:ahLst/>
                 <a:cxnLst/>
-                <a:rect r="r" b="b" t="t" l="l"/>
+                <a:rect l="l" t="t" r="r" b="b"/>
                 <a:pathLst>
-                  <a:path h="1269219" w="1241557">
+                  <a:path w="1241557" h="1269219">
                     <a:moveTo>
                       <a:pt x="1241557" y="445115"/>
                     </a:moveTo>
@@ -11279,7 +11349,7 @@
         </p:grpSp>
         <p:grpSp>
           <p:nvGrpSpPr>
-            <p:cNvPr name="Group 65" id="65"/>
+            <p:cNvPr id="66" name="Group 66"/>
             <p:cNvGrpSpPr/>
             <p:nvPr/>
           </p:nvGrpSpPr>
@@ -11293,12 +11363,12 @@
           </p:grpSpPr>
           <p:sp>
             <p:nvSpPr>
-              <p:cNvPr name="Freeform 66" id="66"/>
+              <p:cNvPr id="67" name="Freeform 67"/>
               <p:cNvSpPr/>
               <p:nvPr/>
             </p:nvSpPr>
             <p:spPr>
-              <a:xfrm flipH="false" flipV="false" rot="0">
+              <a:xfrm>
                 <a:off x="50033" y="40910"/>
                 <a:ext cx="1241557" cy="1269605"/>
               </a:xfrm>
@@ -11307,9 +11377,9 @@
                 <a:gdLst/>
                 <a:ahLst/>
                 <a:cxnLst/>
-                <a:rect r="r" b="b" t="t" l="l"/>
+                <a:rect l="l" t="t" r="r" b="b"/>
                 <a:pathLst>
-                  <a:path h="1269605" w="1241557">
+                  <a:path w="1241557" h="1269605">
                     <a:moveTo>
                       <a:pt x="1241557" y="445500"/>
                     </a:moveTo>
@@ -11386,7 +11456,7 @@
         </p:grpSp>
         <p:grpSp>
           <p:nvGrpSpPr>
-            <p:cNvPr name="Group 67" id="67"/>
+            <p:cNvPr id="68" name="Group 68"/>
             <p:cNvGrpSpPr/>
             <p:nvPr/>
           </p:nvGrpSpPr>
@@ -11400,12 +11470,12 @@
           </p:grpSpPr>
           <p:sp>
             <p:nvSpPr>
-              <p:cNvPr name="Freeform 68" id="68"/>
+              <p:cNvPr id="69" name="Freeform 69"/>
               <p:cNvSpPr/>
               <p:nvPr/>
             </p:nvSpPr>
             <p:spPr>
-              <a:xfrm flipH="false" flipV="false" rot="0">
+              <a:xfrm>
                 <a:off x="46625" y="50800"/>
                 <a:ext cx="1280207" cy="1271430"/>
               </a:xfrm>
@@ -11414,9 +11484,9 @@
                 <a:gdLst/>
                 <a:ahLst/>
                 <a:cxnLst/>
-                <a:rect r="r" b="b" t="t" l="l"/>
+                <a:rect l="l" t="t" r="r" b="b"/>
                 <a:pathLst>
-                  <a:path h="1271430" w="1280207">
+                  <a:path w="1280207" h="1271430">
                     <a:moveTo>
                       <a:pt x="644255" y="0"/>
                     </a:moveTo>
@@ -11643,7 +11713,7 @@
         </p:grpSp>
         <p:grpSp>
           <p:nvGrpSpPr>
-            <p:cNvPr name="Group 69" id="69"/>
+            <p:cNvPr id="70" name="Group 70"/>
             <p:cNvGrpSpPr/>
             <p:nvPr/>
           </p:nvGrpSpPr>
@@ -11657,12 +11727,12 @@
           </p:grpSpPr>
           <p:sp>
             <p:nvSpPr>
-              <p:cNvPr name="Freeform 70" id="70"/>
+              <p:cNvPr id="71" name="Freeform 71"/>
               <p:cNvSpPr/>
               <p:nvPr/>
             </p:nvSpPr>
             <p:spPr>
-              <a:xfrm flipH="false" flipV="false" rot="0">
+              <a:xfrm>
                 <a:off x="47665" y="50800"/>
                 <a:ext cx="1279961" cy="1271430"/>
               </a:xfrm>
@@ -11671,9 +11741,9 @@
                 <a:gdLst/>
                 <a:ahLst/>
                 <a:cxnLst/>
-                <a:rect r="r" b="b" t="t" l="l"/>
+                <a:rect l="l" t="t" r="r" b="b"/>
                 <a:pathLst>
-                  <a:path h="1271430" w="1279961">
+                  <a:path w="1279961" h="1271430">
                     <a:moveTo>
                       <a:pt x="644485" y="0"/>
                     </a:moveTo>
@@ -11900,7 +11970,7 @@
         </p:grpSp>
         <p:grpSp>
           <p:nvGrpSpPr>
-            <p:cNvPr name="Group 71" id="71"/>
+            <p:cNvPr id="72" name="Group 72"/>
             <p:cNvGrpSpPr/>
             <p:nvPr/>
           </p:nvGrpSpPr>
@@ -11914,12 +11984,12 @@
           </p:grpSpPr>
           <p:sp>
             <p:nvSpPr>
-              <p:cNvPr name="Freeform 72" id="72"/>
+              <p:cNvPr id="73" name="Freeform 73"/>
               <p:cNvSpPr/>
               <p:nvPr/>
             </p:nvSpPr>
             <p:spPr>
-              <a:xfrm flipH="false" flipV="false" rot="0">
+              <a:xfrm>
                 <a:off x="49655" y="41295"/>
                 <a:ext cx="1240690" cy="1269219"/>
               </a:xfrm>
@@ -11928,9 +11998,9 @@
                 <a:gdLst/>
                 <a:ahLst/>
                 <a:cxnLst/>
-                <a:rect r="r" b="b" t="t" l="l"/>
+                <a:rect l="l" t="t" r="r" b="b"/>
                 <a:pathLst>
-                  <a:path h="1269219" w="1240690">
+                  <a:path w="1240690" h="1269219">
                     <a:moveTo>
                       <a:pt x="1240665" y="445115"/>
                     </a:moveTo>
@@ -12007,7 +12077,7 @@
         </p:grpSp>
         <p:grpSp>
           <p:nvGrpSpPr>
-            <p:cNvPr name="Group 73" id="73"/>
+            <p:cNvPr id="74" name="Group 74"/>
             <p:cNvGrpSpPr/>
             <p:nvPr/>
           </p:nvGrpSpPr>
@@ -12021,12 +12091,12 @@
           </p:grpSpPr>
           <p:sp>
             <p:nvSpPr>
-              <p:cNvPr name="Freeform 74" id="74"/>
+              <p:cNvPr id="75" name="Freeform 75"/>
               <p:cNvSpPr/>
               <p:nvPr/>
             </p:nvSpPr>
             <p:spPr>
-              <a:xfrm flipH="false" flipV="false" rot="0">
+              <a:xfrm>
                 <a:off x="46037" y="49530"/>
                 <a:ext cx="1298581" cy="1272677"/>
               </a:xfrm>
@@ -12035,9 +12105,9 @@
                 <a:gdLst/>
                 <a:ahLst/>
                 <a:cxnLst/>
-                <a:rect r="r" b="b" t="t" l="l"/>
+                <a:rect l="l" t="t" r="r" b="b"/>
                 <a:pathLst>
-                  <a:path h="1272677" w="1298581">
+                  <a:path w="1298581" h="1272677">
                     <a:moveTo>
                       <a:pt x="634683" y="1270"/>
                     </a:moveTo>
@@ -12264,7 +12334,7 @@
         </p:grpSp>
         <p:grpSp>
           <p:nvGrpSpPr>
-            <p:cNvPr name="Group 75" id="75"/>
+            <p:cNvPr id="76" name="Group 76"/>
             <p:cNvGrpSpPr/>
             <p:nvPr/>
           </p:nvGrpSpPr>
@@ -12278,12 +12348,12 @@
           </p:grpSpPr>
           <p:sp>
             <p:nvSpPr>
-              <p:cNvPr name="Freeform 76" id="76"/>
+              <p:cNvPr id="77" name="Freeform 77"/>
               <p:cNvSpPr/>
               <p:nvPr/>
             </p:nvSpPr>
             <p:spPr>
-              <a:xfrm flipH="false" flipV="false" rot="0">
+              <a:xfrm>
                 <a:off x="47135" y="50800"/>
                 <a:ext cx="1274623" cy="1271408"/>
               </a:xfrm>
@@ -12292,9 +12362,9 @@
                 <a:gdLst/>
                 <a:ahLst/>
                 <a:cxnLst/>
-                <a:rect r="r" b="b" t="t" l="l"/>
+                <a:rect l="l" t="t" r="r" b="b"/>
                 <a:pathLst>
-                  <a:path h="1271408" w="1274623">
+                  <a:path w="1274623" h="1271408">
                     <a:moveTo>
                       <a:pt x="639935" y="0"/>
                     </a:moveTo>
@@ -12521,7 +12591,7 @@
         </p:grpSp>
         <p:grpSp>
           <p:nvGrpSpPr>
-            <p:cNvPr name="Group 77" id="77"/>
+            <p:cNvPr id="78" name="Group 78"/>
             <p:cNvGrpSpPr/>
             <p:nvPr/>
           </p:nvGrpSpPr>
@@ -12535,12 +12605,12 @@
           </p:grpSpPr>
           <p:sp>
             <p:nvSpPr>
-              <p:cNvPr name="Freeform 78" id="78"/>
+              <p:cNvPr id="79" name="Freeform 79"/>
               <p:cNvSpPr/>
               <p:nvPr/>
             </p:nvSpPr>
             <p:spPr>
-              <a:xfrm flipH="false" flipV="false" rot="0">
+              <a:xfrm>
                 <a:off x="50033" y="40910"/>
                 <a:ext cx="1241557" cy="1269229"/>
               </a:xfrm>
@@ -12549,9 +12619,9 @@
                 <a:gdLst/>
                 <a:ahLst/>
                 <a:cxnLst/>
-                <a:rect r="r" b="b" t="t" l="l"/>
+                <a:rect l="l" t="t" r="r" b="b"/>
                 <a:pathLst>
-                  <a:path h="1269229" w="1241557">
+                  <a:path w="1241557" h="1269229">
                     <a:moveTo>
                       <a:pt x="1241557" y="445500"/>
                     </a:moveTo>
@@ -12628,7 +12698,7 @@
         </p:grpSp>
         <p:grpSp>
           <p:nvGrpSpPr>
-            <p:cNvPr name="Group 79" id="79"/>
+            <p:cNvPr id="80" name="Group 80"/>
             <p:cNvGrpSpPr/>
             <p:nvPr/>
           </p:nvGrpSpPr>
@@ -12642,12 +12712,12 @@
           </p:grpSpPr>
           <p:sp>
             <p:nvSpPr>
-              <p:cNvPr name="Freeform 80" id="80"/>
+              <p:cNvPr id="81" name="Freeform 81"/>
               <p:cNvSpPr/>
               <p:nvPr/>
             </p:nvSpPr>
             <p:spPr>
-              <a:xfrm flipH="false" flipV="false" rot="0">
+              <a:xfrm>
                 <a:off x="47260" y="50800"/>
                 <a:ext cx="1284659" cy="1271826"/>
               </a:xfrm>
@@ -12656,9 +12726,9 @@
                 <a:gdLst/>
                 <a:ahLst/>
                 <a:cxnLst/>
-                <a:rect r="r" b="b" t="t" l="l"/>
+                <a:rect l="l" t="t" r="r" b="b"/>
                 <a:pathLst>
-                  <a:path h="1271826" w="1284659">
+                  <a:path w="1284659" h="1271826">
                     <a:moveTo>
                       <a:pt x="648700" y="0"/>
                     </a:moveTo>
@@ -12885,7 +12955,7 @@
         </p:grpSp>
         <p:grpSp>
           <p:nvGrpSpPr>
-            <p:cNvPr name="Group 81" id="81"/>
+            <p:cNvPr id="82" name="Group 82"/>
             <p:cNvGrpSpPr/>
             <p:nvPr/>
           </p:nvGrpSpPr>
@@ -12899,12 +12969,12 @@
           </p:grpSpPr>
           <p:sp>
             <p:nvSpPr>
-              <p:cNvPr name="Freeform 82" id="82"/>
+              <p:cNvPr id="83" name="Freeform 83"/>
               <p:cNvSpPr/>
               <p:nvPr/>
             </p:nvSpPr>
             <p:spPr>
-              <a:xfrm flipH="false" flipV="false" rot="0">
+              <a:xfrm>
                 <a:off x="47665" y="50800"/>
                 <a:ext cx="1288990" cy="1280598"/>
               </a:xfrm>
@@ -12913,9 +12983,9 @@
                 <a:gdLst/>
                 <a:ahLst/>
                 <a:cxnLst/>
-                <a:rect r="r" b="b" t="t" l="l"/>
+                <a:rect l="l" t="t" r="r" b="b"/>
                 <a:pathLst>
-                  <a:path h="1280598" w="1288990">
+                  <a:path w="1288990" h="1280598">
                     <a:moveTo>
                       <a:pt x="920075" y="67310"/>
                     </a:moveTo>
@@ -13142,7 +13212,7 @@
         </p:grpSp>
         <p:grpSp>
           <p:nvGrpSpPr>
-            <p:cNvPr name="Group 83" id="83"/>
+            <p:cNvPr id="84" name="Group 84"/>
             <p:cNvGrpSpPr/>
             <p:nvPr/>
           </p:nvGrpSpPr>
@@ -13156,12 +13226,12 @@
           </p:grpSpPr>
           <p:sp>
             <p:nvSpPr>
-              <p:cNvPr name="Freeform 84" id="84"/>
+              <p:cNvPr id="85" name="Freeform 85"/>
               <p:cNvSpPr/>
               <p:nvPr/>
             </p:nvSpPr>
             <p:spPr>
-              <a:xfrm flipH="false" flipV="false" rot="0">
+              <a:xfrm>
                 <a:off x="46185" y="50800"/>
                 <a:ext cx="1275485" cy="1270160"/>
               </a:xfrm>
@@ -13170,9 +13240,9 @@
                 <a:gdLst/>
                 <a:ahLst/>
                 <a:cxnLst/>
-                <a:rect r="r" b="b" t="t" l="l"/>
+                <a:rect l="l" t="t" r="r" b="b"/>
                 <a:pathLst>
-                  <a:path h="1270160" w="1275485">
+                  <a:path w="1275485" h="1270160">
                     <a:moveTo>
                       <a:pt x="639615" y="0"/>
                     </a:moveTo>
@@ -13399,7 +13469,7 @@
         </p:grpSp>
         <p:grpSp>
           <p:nvGrpSpPr>
-            <p:cNvPr name="Group 85" id="85"/>
+            <p:cNvPr id="86" name="Group 86"/>
             <p:cNvGrpSpPr/>
             <p:nvPr/>
           </p:nvGrpSpPr>
@@ -13413,12 +13483,12 @@
           </p:grpSpPr>
           <p:sp>
             <p:nvSpPr>
-              <p:cNvPr name="Freeform 86" id="86"/>
+              <p:cNvPr id="87" name="Freeform 87"/>
               <p:cNvSpPr/>
               <p:nvPr/>
             </p:nvSpPr>
             <p:spPr>
-              <a:xfrm flipH="false" flipV="false" rot="0">
+              <a:xfrm>
                 <a:off x="50640" y="46037"/>
                 <a:ext cx="1270160" cy="1275239"/>
               </a:xfrm>
@@ -13427,9 +13497,9 @@
                 <a:gdLst/>
                 <a:ahLst/>
                 <a:cxnLst/>
-                <a:rect r="r" b="b" t="t" l="l"/>
+                <a:rect l="l" t="t" r="r" b="b"/>
                 <a:pathLst>
-                  <a:path h="1275239" w="1270160">
+                  <a:path w="1270160" h="1275239">
                     <a:moveTo>
                       <a:pt x="1270160" y="639763"/>
                     </a:moveTo>
@@ -13656,7 +13726,7 @@
         </p:grpSp>
         <p:grpSp>
           <p:nvGrpSpPr>
-            <p:cNvPr name="Group 87" id="87"/>
+            <p:cNvPr id="88" name="Group 88"/>
             <p:cNvGrpSpPr/>
             <p:nvPr/>
           </p:nvGrpSpPr>
@@ -13670,12 +13740,12 @@
           </p:grpSpPr>
           <p:sp>
             <p:nvSpPr>
-              <p:cNvPr name="Freeform 88" id="88"/>
+              <p:cNvPr id="89" name="Freeform 89"/>
               <p:cNvSpPr/>
               <p:nvPr/>
             </p:nvSpPr>
             <p:spPr>
-              <a:xfrm flipH="false" flipV="false" rot="0">
+              <a:xfrm>
                 <a:off x="49842" y="50244"/>
                 <a:ext cx="1279579" cy="1270604"/>
               </a:xfrm>
@@ -13684,9 +13754,9 @@
                 <a:gdLst/>
                 <a:ahLst/>
                 <a:cxnLst/>
-                <a:rect r="r" b="b" t="t" l="l"/>
+                <a:rect l="l" t="t" r="r" b="b"/>
                 <a:pathLst>
-                  <a:path h="1270604" w="1279579">
+                  <a:path w="1279579" h="1270604">
                     <a:moveTo>
                       <a:pt x="635958" y="1270556"/>
                     </a:moveTo>
@@ -13913,7 +13983,7 @@
         </p:grpSp>
         <p:grpSp>
           <p:nvGrpSpPr>
-            <p:cNvPr name="Group 89" id="89"/>
+            <p:cNvPr id="90" name="Group 90"/>
             <p:cNvGrpSpPr/>
             <p:nvPr/>
           </p:nvGrpSpPr>
@@ -13927,12 +13997,12 @@
           </p:grpSpPr>
           <p:sp>
             <p:nvSpPr>
-              <p:cNvPr name="Freeform 90" id="90"/>
+              <p:cNvPr id="91" name="Freeform 91"/>
               <p:cNvSpPr/>
               <p:nvPr/>
             </p:nvSpPr>
             <p:spPr>
-              <a:xfrm flipH="false" flipV="false" rot="0">
+              <a:xfrm>
                 <a:off x="49655" y="40974"/>
                 <a:ext cx="1240690" cy="1269541"/>
               </a:xfrm>
@@ -13941,9 +14011,9 @@
                 <a:gdLst/>
                 <a:ahLst/>
                 <a:cxnLst/>
-                <a:rect r="r" b="b" t="t" l="l"/>
+                <a:rect l="l" t="t" r="r" b="b"/>
                 <a:pathLst>
-                  <a:path h="1269541" w="1240690">
+                  <a:path w="1240690" h="1269541">
                     <a:moveTo>
                       <a:pt x="1240665" y="445436"/>
                     </a:moveTo>
@@ -14020,7 +14090,7 @@
         </p:grpSp>
         <p:grpSp>
           <p:nvGrpSpPr>
-            <p:cNvPr name="Group 91" id="91"/>
+            <p:cNvPr id="92" name="Group 92"/>
             <p:cNvGrpSpPr/>
             <p:nvPr/>
           </p:nvGrpSpPr>
@@ -14034,12 +14104,12 @@
           </p:grpSpPr>
           <p:sp>
             <p:nvSpPr>
-              <p:cNvPr name="Freeform 92" id="92"/>
+              <p:cNvPr id="93" name="Freeform 93"/>
               <p:cNvSpPr/>
               <p:nvPr/>
             </p:nvSpPr>
             <p:spPr>
-              <a:xfrm flipH="false" flipV="false" rot="0">
+              <a:xfrm>
                 <a:off x="49655" y="40910"/>
                 <a:ext cx="1240690" cy="1269229"/>
               </a:xfrm>
@@ -14048,9 +14118,9 @@
                 <a:gdLst/>
                 <a:ahLst/>
                 <a:cxnLst/>
-                <a:rect r="r" b="b" t="t" l="l"/>
+                <a:rect l="l" t="t" r="r" b="b"/>
                 <a:pathLst>
-                  <a:path h="1269229" w="1240690">
+                  <a:path w="1240690" h="1269229">
                     <a:moveTo>
                       <a:pt x="1240665" y="445500"/>
                     </a:moveTo>
@@ -14127,7 +14197,7 @@
         </p:grpSp>
         <p:grpSp>
           <p:nvGrpSpPr>
-            <p:cNvPr name="Group 93" id="93"/>
+            <p:cNvPr id="94" name="Group 94"/>
             <p:cNvGrpSpPr/>
             <p:nvPr/>
           </p:nvGrpSpPr>
@@ -14141,12 +14211,12 @@
           </p:grpSpPr>
           <p:sp>
             <p:nvSpPr>
-              <p:cNvPr name="Freeform 94" id="94"/>
+              <p:cNvPr id="95" name="Freeform 95"/>
               <p:cNvSpPr/>
               <p:nvPr/>
             </p:nvSpPr>
             <p:spPr>
-              <a:xfrm flipH="false" flipV="false" rot="0">
+              <a:xfrm>
                 <a:off x="47135" y="50800"/>
                 <a:ext cx="1313686" cy="1283084"/>
               </a:xfrm>
@@ -14155,9 +14225,9 @@
                 <a:gdLst/>
                 <a:ahLst/>
                 <a:cxnLst/>
-                <a:rect r="r" b="b" t="t" l="l"/>
+                <a:rect l="l" t="t" r="r" b="b"/>
                 <a:pathLst>
-                  <a:path h="1283084" w="1313686">
+                  <a:path w="1313686" h="1283084">
                     <a:moveTo>
                       <a:pt x="785985" y="19050"/>
                     </a:moveTo>
@@ -14384,7 +14454,7 @@
         </p:grpSp>
         <p:grpSp>
           <p:nvGrpSpPr>
-            <p:cNvPr name="Group 95" id="95"/>
+            <p:cNvPr id="96" name="Group 96"/>
             <p:cNvGrpSpPr/>
             <p:nvPr/>
           </p:nvGrpSpPr>
@@ -14398,12 +14468,12 @@
           </p:grpSpPr>
           <p:sp>
             <p:nvSpPr>
-              <p:cNvPr name="Freeform 96" id="96"/>
+              <p:cNvPr id="97" name="Freeform 97"/>
               <p:cNvSpPr/>
               <p:nvPr/>
             </p:nvSpPr>
             <p:spPr>
-              <a:xfrm flipH="false" flipV="false" rot="0">
+              <a:xfrm>
                 <a:off x="50033" y="41295"/>
                 <a:ext cx="1241557" cy="1269220"/>
               </a:xfrm>
@@ -14412,9 +14482,9 @@
                 <a:gdLst/>
                 <a:ahLst/>
                 <a:cxnLst/>
-                <a:rect r="r" b="b" t="t" l="l"/>
+                <a:rect l="l" t="t" r="r" b="b"/>
                 <a:pathLst>
-                  <a:path h="1269220" w="1241557">
+                  <a:path w="1241557" h="1269220">
                     <a:moveTo>
                       <a:pt x="1241557" y="446385"/>
                     </a:moveTo>
@@ -14491,7 +14561,7 @@
         </p:grpSp>
         <p:grpSp>
           <p:nvGrpSpPr>
-            <p:cNvPr name="Group 97" id="97"/>
+            <p:cNvPr id="98" name="Group 98"/>
             <p:cNvGrpSpPr/>
             <p:nvPr/>
           </p:nvGrpSpPr>
@@ -14505,12 +14575,12 @@
           </p:grpSpPr>
           <p:sp>
             <p:nvSpPr>
-              <p:cNvPr name="Freeform 98" id="98"/>
+              <p:cNvPr id="99" name="Freeform 99"/>
               <p:cNvSpPr/>
               <p:nvPr/>
             </p:nvSpPr>
             <p:spPr>
-              <a:xfrm flipH="false" flipV="false" rot="0">
+              <a:xfrm>
                 <a:off x="49848" y="50244"/>
                 <a:ext cx="1282891" cy="1271826"/>
               </a:xfrm>
@@ -14519,9 +14589,9 @@
                 <a:gdLst/>
                 <a:ahLst/>
                 <a:cxnLst/>
-                <a:rect r="r" b="b" t="t" l="l"/>
+                <a:rect l="l" t="t" r="r" b="b"/>
                 <a:pathLst>
-                  <a:path h="1271826" w="1282891">
+                  <a:path w="1282891" h="1271826">
                     <a:moveTo>
                       <a:pt x="635952" y="1271826"/>
                     </a:moveTo>
@@ -14748,7 +14818,7 @@
         </p:grpSp>
         <p:grpSp>
           <p:nvGrpSpPr>
-            <p:cNvPr name="Group 99" id="99"/>
+            <p:cNvPr id="100" name="Group 100"/>
             <p:cNvGrpSpPr/>
             <p:nvPr/>
           </p:nvGrpSpPr>
@@ -14762,12 +14832,12 @@
           </p:grpSpPr>
           <p:sp>
             <p:nvSpPr>
-              <p:cNvPr name="Freeform 100" id="100"/>
+              <p:cNvPr id="101" name="Freeform 101"/>
               <p:cNvSpPr/>
               <p:nvPr/>
             </p:nvSpPr>
             <p:spPr>
-              <a:xfrm flipH="false" flipV="false" rot="0">
+              <a:xfrm>
                 <a:off x="47665" y="50800"/>
                 <a:ext cx="1281713" cy="1271826"/>
               </a:xfrm>
@@ -14776,9 +14846,9 @@
                 <a:gdLst/>
                 <a:ahLst/>
                 <a:cxnLst/>
-                <a:rect r="r" b="b" t="t" l="l"/>
+                <a:rect l="l" t="t" r="r" b="b"/>
                 <a:pathLst>
-                  <a:path h="1271826" w="1281713">
+                  <a:path w="1281713" h="1271826">
                     <a:moveTo>
                       <a:pt x="647025" y="0"/>
                     </a:moveTo>
@@ -15005,7 +15075,7 @@
         </p:grpSp>
         <p:grpSp>
           <p:nvGrpSpPr>
-            <p:cNvPr name="Group 101" id="101"/>
+            <p:cNvPr id="102" name="Group 102"/>
             <p:cNvGrpSpPr/>
             <p:nvPr/>
           </p:nvGrpSpPr>
@@ -15019,12 +15089,12 @@
           </p:grpSpPr>
           <p:sp>
             <p:nvSpPr>
-              <p:cNvPr name="Freeform 102" id="102"/>
+              <p:cNvPr id="103" name="Freeform 103"/>
               <p:cNvSpPr/>
               <p:nvPr/>
             </p:nvSpPr>
             <p:spPr>
-              <a:xfrm flipH="false" flipV="false" rot="0">
+              <a:xfrm>
                 <a:off x="47829" y="50800"/>
                 <a:ext cx="1292974" cy="1273181"/>
               </a:xfrm>
@@ -15033,9 +15103,9 @@
                 <a:gdLst/>
                 <a:ahLst/>
                 <a:cxnLst/>
-                <a:rect r="r" b="b" t="t" l="l"/>
+                <a:rect l="l" t="t" r="r" b="b"/>
                 <a:pathLst>
-                  <a:path h="1273181" w="1292974">
+                  <a:path w="1292974" h="1273181">
                     <a:moveTo>
                       <a:pt x="657021" y="0"/>
                     </a:moveTo>
@@ -15262,7 +15332,7 @@
         </p:grpSp>
         <p:grpSp>
           <p:nvGrpSpPr>
-            <p:cNvPr name="Group 103" id="103"/>
+            <p:cNvPr id="104" name="Group 104"/>
             <p:cNvGrpSpPr/>
             <p:nvPr/>
           </p:nvGrpSpPr>
@@ -15276,12 +15346,12 @@
           </p:grpSpPr>
           <p:sp>
             <p:nvSpPr>
-              <p:cNvPr name="Freeform 104" id="104"/>
+              <p:cNvPr id="105" name="Freeform 105"/>
               <p:cNvSpPr/>
               <p:nvPr/>
             </p:nvSpPr>
             <p:spPr>
-              <a:xfrm flipH="false" flipV="false" rot="0">
+              <a:xfrm>
                 <a:off x="50032" y="40910"/>
                 <a:ext cx="1241558" cy="1268335"/>
               </a:xfrm>
@@ -15290,9 +15360,9 @@
                 <a:gdLst/>
                 <a:ahLst/>
                 <a:cxnLst/>
-                <a:rect r="r" b="b" t="t" l="l"/>
+                <a:rect l="l" t="t" r="r" b="b"/>
                 <a:pathLst>
-                  <a:path h="1268335" w="1241558">
+                  <a:path w="1241558" h="1268335">
                     <a:moveTo>
                       <a:pt x="1241558" y="445500"/>
                     </a:moveTo>
@@ -15369,7 +15439,7 @@
         </p:grpSp>
         <p:grpSp>
           <p:nvGrpSpPr>
-            <p:cNvPr name="Group 105" id="105"/>
+            <p:cNvPr id="106" name="Group 106"/>
             <p:cNvGrpSpPr/>
             <p:nvPr/>
           </p:nvGrpSpPr>
@@ -15383,12 +15453,12 @@
           </p:grpSpPr>
           <p:sp>
             <p:nvSpPr>
-              <p:cNvPr name="Freeform 106" id="106"/>
+              <p:cNvPr id="107" name="Freeform 107"/>
               <p:cNvSpPr/>
               <p:nvPr/>
             </p:nvSpPr>
             <p:spPr>
-              <a:xfrm flipH="false" flipV="false" rot="0">
+              <a:xfrm>
                 <a:off x="49655" y="41295"/>
                 <a:ext cx="1240690" cy="1269219"/>
               </a:xfrm>
@@ -15397,9 +15467,9 @@
                 <a:gdLst/>
                 <a:ahLst/>
                 <a:cxnLst/>
-                <a:rect r="r" b="b" t="t" l="l"/>
+                <a:rect l="l" t="t" r="r" b="b"/>
                 <a:pathLst>
-                  <a:path h="1269219" w="1240690">
+                  <a:path w="1240690" h="1269219">
                     <a:moveTo>
                       <a:pt x="1240665" y="445115"/>
                     </a:moveTo>
@@ -15476,7 +15546,7 @@
         </p:grpSp>
         <p:grpSp>
           <p:nvGrpSpPr>
-            <p:cNvPr name="Group 107" id="107"/>
+            <p:cNvPr id="108" name="Group 108"/>
             <p:cNvGrpSpPr/>
             <p:nvPr/>
           </p:nvGrpSpPr>
@@ -15490,12 +15560,12 @@
           </p:grpSpPr>
           <p:sp>
             <p:nvSpPr>
-              <p:cNvPr name="Freeform 108" id="108"/>
+              <p:cNvPr id="109" name="Freeform 109"/>
               <p:cNvSpPr/>
               <p:nvPr/>
             </p:nvSpPr>
             <p:spPr>
-              <a:xfrm flipH="false" flipV="false" rot="0">
+              <a:xfrm>
                 <a:off x="49655" y="40910"/>
                 <a:ext cx="1240665" cy="1269227"/>
               </a:xfrm>
@@ -15504,9 +15574,9 @@
                 <a:gdLst/>
                 <a:ahLst/>
                 <a:cxnLst/>
-                <a:rect r="r" b="b" t="t" l="l"/>
+                <a:rect l="l" t="t" r="r" b="b"/>
                 <a:pathLst>
-                  <a:path h="1269227" w="1240665">
+                  <a:path w="1240665" h="1269227">
                     <a:moveTo>
                       <a:pt x="1240665" y="445500"/>
                     </a:moveTo>
@@ -15583,7 +15653,7 @@
         </p:grpSp>
         <p:grpSp>
           <p:nvGrpSpPr>
-            <p:cNvPr name="Group 109" id="109"/>
+            <p:cNvPr id="110" name="Group 110"/>
             <p:cNvGrpSpPr/>
             <p:nvPr/>
           </p:nvGrpSpPr>
@@ -15597,12 +15667,12 @@
           </p:grpSpPr>
           <p:sp>
             <p:nvSpPr>
-              <p:cNvPr name="Freeform 110" id="110"/>
+              <p:cNvPr id="111" name="Freeform 111"/>
               <p:cNvSpPr/>
               <p:nvPr/>
             </p:nvSpPr>
             <p:spPr>
-              <a:xfrm flipH="false" flipV="false" rot="0">
+              <a:xfrm>
                 <a:off x="50032" y="41295"/>
                 <a:ext cx="1241558" cy="1269219"/>
               </a:xfrm>
@@ -15611,9 +15681,9 @@
                 <a:gdLst/>
                 <a:ahLst/>
                 <a:cxnLst/>
-                <a:rect r="r" b="b" t="t" l="l"/>
+                <a:rect l="l" t="t" r="r" b="b"/>
                 <a:pathLst>
-                  <a:path h="1269219" w="1241558">
+                  <a:path w="1241558" h="1269219">
                     <a:moveTo>
                       <a:pt x="1241558" y="445115"/>
                     </a:moveTo>
@@ -15690,7 +15760,7 @@
         </p:grpSp>
         <p:grpSp>
           <p:nvGrpSpPr>
-            <p:cNvPr name="Group 111" id="111"/>
+            <p:cNvPr id="112" name="Group 112"/>
             <p:cNvGrpSpPr/>
             <p:nvPr/>
           </p:nvGrpSpPr>
@@ -15704,12 +15774,12 @@
           </p:grpSpPr>
           <p:sp>
             <p:nvSpPr>
-              <p:cNvPr name="Freeform 112" id="112"/>
+              <p:cNvPr id="113" name="Freeform 113"/>
               <p:cNvSpPr/>
               <p:nvPr/>
             </p:nvSpPr>
             <p:spPr>
-              <a:xfrm flipH="false" flipV="false" rot="0">
+              <a:xfrm>
                 <a:off x="49655" y="41295"/>
                 <a:ext cx="1240690" cy="1269219"/>
               </a:xfrm>
@@ -15718,9 +15788,9 @@
                 <a:gdLst/>
                 <a:ahLst/>
                 <a:cxnLst/>
-                <a:rect r="r" b="b" t="t" l="l"/>
+                <a:rect l="l" t="t" r="r" b="b"/>
                 <a:pathLst>
-                  <a:path h="1269219" w="1240690">
+                  <a:path w="1240690" h="1269219">
                     <a:moveTo>
                       <a:pt x="1240665" y="445115"/>
                     </a:moveTo>
@@ -15797,7 +15867,7 @@
         </p:grpSp>
         <p:grpSp>
           <p:nvGrpSpPr>
-            <p:cNvPr name="Group 113" id="113"/>
+            <p:cNvPr id="114" name="Group 114"/>
             <p:cNvGrpSpPr/>
             <p:nvPr/>
           </p:nvGrpSpPr>
@@ -15811,12 +15881,12 @@
           </p:grpSpPr>
           <p:sp>
             <p:nvSpPr>
-              <p:cNvPr name="Freeform 114" id="114"/>
+              <p:cNvPr id="115" name="Freeform 115"/>
               <p:cNvSpPr/>
               <p:nvPr/>
             </p:nvSpPr>
             <p:spPr>
-              <a:xfrm flipH="false" flipV="false" rot="0">
+              <a:xfrm>
                 <a:off x="50033" y="41295"/>
                 <a:ext cx="1241557" cy="1269219"/>
               </a:xfrm>
@@ -15825,9 +15895,9 @@
                 <a:gdLst/>
                 <a:ahLst/>
                 <a:cxnLst/>
-                <a:rect r="r" b="b" t="t" l="l"/>
+                <a:rect l="l" t="t" r="r" b="b"/>
                 <a:pathLst>
-                  <a:path h="1269219" w="1241557">
+                  <a:path w="1241557" h="1269219">
                     <a:moveTo>
                       <a:pt x="1241557" y="445115"/>
                     </a:moveTo>
@@ -15904,7 +15974,7 @@
         </p:grpSp>
         <p:grpSp>
           <p:nvGrpSpPr>
-            <p:cNvPr name="Group 115" id="115"/>
+            <p:cNvPr id="116" name="Group 116"/>
             <p:cNvGrpSpPr/>
             <p:nvPr/>
           </p:nvGrpSpPr>
@@ -15918,12 +15988,12 @@
           </p:grpSpPr>
           <p:sp>
             <p:nvSpPr>
-              <p:cNvPr name="Freeform 116" id="116"/>
+              <p:cNvPr id="117" name="Freeform 117"/>
               <p:cNvSpPr/>
               <p:nvPr/>
             </p:nvSpPr>
             <p:spPr>
-              <a:xfrm flipH="false" flipV="false" rot="0">
+              <a:xfrm>
                 <a:off x="49655" y="41295"/>
                 <a:ext cx="1240690" cy="1269220"/>
               </a:xfrm>
@@ -15932,9 +16002,9 @@
                 <a:gdLst/>
                 <a:ahLst/>
                 <a:cxnLst/>
-                <a:rect r="r" b="b" t="t" l="l"/>
+                <a:rect l="l" t="t" r="r" b="b"/>
                 <a:pathLst>
-                  <a:path h="1269220" w="1240690">
+                  <a:path w="1240690" h="1269220">
                     <a:moveTo>
                       <a:pt x="1240665" y="446385"/>
                     </a:moveTo>
@@ -16011,7 +16081,7 @@
         </p:grpSp>
         <p:grpSp>
           <p:nvGrpSpPr>
-            <p:cNvPr name="Group 117" id="117"/>
+            <p:cNvPr id="118" name="Group 118"/>
             <p:cNvGrpSpPr/>
             <p:nvPr/>
           </p:nvGrpSpPr>
@@ -16025,12 +16095,12 @@
           </p:grpSpPr>
           <p:sp>
             <p:nvSpPr>
-              <p:cNvPr name="Freeform 118" id="118"/>
+              <p:cNvPr id="119" name="Freeform 119"/>
               <p:cNvSpPr/>
               <p:nvPr/>
             </p:nvSpPr>
             <p:spPr>
-              <a:xfrm flipH="false" flipV="false" rot="0">
+              <a:xfrm>
                 <a:off x="49655" y="41295"/>
                 <a:ext cx="1241935" cy="1269219"/>
               </a:xfrm>
@@ -16039,9 +16109,9 @@
                 <a:gdLst/>
                 <a:ahLst/>
                 <a:cxnLst/>
-                <a:rect r="r" b="b" t="t" l="l"/>
+                <a:rect l="l" t="t" r="r" b="b"/>
                 <a:pathLst>
-                  <a:path h="1269219" w="1241935">
+                  <a:path w="1241935" h="1269219">
                     <a:moveTo>
                       <a:pt x="1241935" y="445115"/>
                     </a:moveTo>
@@ -16118,7 +16188,7 @@
         </p:grpSp>
         <p:grpSp>
           <p:nvGrpSpPr>
-            <p:cNvPr name="Group 119" id="119"/>
+            <p:cNvPr id="120" name="Group 120"/>
             <p:cNvGrpSpPr/>
             <p:nvPr/>
           </p:nvGrpSpPr>
@@ -16132,12 +16202,12 @@
           </p:grpSpPr>
           <p:sp>
             <p:nvSpPr>
-              <p:cNvPr name="Freeform 120" id="120"/>
+              <p:cNvPr id="121" name="Freeform 121"/>
               <p:cNvSpPr/>
               <p:nvPr/>
             </p:nvSpPr>
             <p:spPr>
-              <a:xfrm flipH="false" flipV="false" rot="0">
+              <a:xfrm>
                 <a:off x="50033" y="41295"/>
                 <a:ext cx="1241557" cy="1269219"/>
               </a:xfrm>
@@ -16146,9 +16216,9 @@
                 <a:gdLst/>
                 <a:ahLst/>
                 <a:cxnLst/>
-                <a:rect r="r" b="b" t="t" l="l"/>
+                <a:rect l="l" t="t" r="r" b="b"/>
                 <a:pathLst>
-                  <a:path h="1269219" w="1241557">
+                  <a:path w="1241557" h="1269219">
                     <a:moveTo>
                       <a:pt x="1241557" y="445115"/>
                     </a:moveTo>
@@ -16225,7 +16295,7 @@
         </p:grpSp>
         <p:grpSp>
           <p:nvGrpSpPr>
-            <p:cNvPr name="Group 121" id="121"/>
+            <p:cNvPr id="122" name="Group 122"/>
             <p:cNvGrpSpPr/>
             <p:nvPr/>
           </p:nvGrpSpPr>
@@ -16239,12 +16309,12 @@
           </p:grpSpPr>
           <p:sp>
             <p:nvSpPr>
-              <p:cNvPr name="Freeform 122" id="122"/>
+              <p:cNvPr id="123" name="Freeform 123"/>
               <p:cNvSpPr/>
               <p:nvPr/>
             </p:nvSpPr>
             <p:spPr>
-              <a:xfrm flipH="false" flipV="false" rot="0">
+              <a:xfrm>
                 <a:off x="49842" y="50608"/>
                 <a:ext cx="1292089" cy="1272732"/>
               </a:xfrm>
@@ -16253,9 +16323,9 @@
                 <a:gdLst/>
                 <a:ahLst/>
                 <a:cxnLst/>
-                <a:rect r="r" b="b" t="t" l="l"/>
+                <a:rect l="l" t="t" r="r" b="b"/>
                 <a:pathLst>
-                  <a:path h="1272732" w="1292089">
+                  <a:path w="1292089" h="1272732">
                     <a:moveTo>
                       <a:pt x="635958" y="1272732"/>
                     </a:moveTo>
@@ -16482,7 +16552,7 @@
         </p:grpSp>
         <p:grpSp>
           <p:nvGrpSpPr>
-            <p:cNvPr name="Group 123" id="123"/>
+            <p:cNvPr id="124" name="Group 124"/>
             <p:cNvGrpSpPr/>
             <p:nvPr/>
           </p:nvGrpSpPr>
@@ -16496,12 +16566,12 @@
           </p:grpSpPr>
           <p:sp>
             <p:nvSpPr>
-              <p:cNvPr name="Freeform 124" id="124"/>
+              <p:cNvPr id="125" name="Freeform 125"/>
               <p:cNvSpPr/>
               <p:nvPr/>
             </p:nvSpPr>
             <p:spPr>
-              <a:xfrm flipH="false" flipV="false" rot="0">
+              <a:xfrm>
                 <a:off x="48720" y="50800"/>
                 <a:ext cx="1292089" cy="1273181"/>
               </a:xfrm>
@@ -16510,9 +16580,9 @@
                 <a:gdLst/>
                 <a:ahLst/>
                 <a:cxnLst/>
-                <a:rect r="r" b="b" t="t" l="l"/>
+                <a:rect l="l" t="t" r="r" b="b"/>
                 <a:pathLst>
-                  <a:path h="1273181" w="1292089">
+                  <a:path w="1292089" h="1273181">
                     <a:moveTo>
                       <a:pt x="656130" y="0"/>
                     </a:moveTo>
@@ -16739,7 +16809,7 @@
         </p:grpSp>
         <p:grpSp>
           <p:nvGrpSpPr>
-            <p:cNvPr name="Group 125" id="125"/>
+            <p:cNvPr id="126" name="Group 126"/>
             <p:cNvGrpSpPr/>
             <p:nvPr/>
           </p:nvGrpSpPr>
@@ -16753,12 +16823,12 @@
           </p:grpSpPr>
           <p:sp>
             <p:nvSpPr>
-              <p:cNvPr name="Freeform 126" id="126"/>
+              <p:cNvPr id="127" name="Freeform 127"/>
               <p:cNvSpPr/>
               <p:nvPr/>
             </p:nvSpPr>
             <p:spPr>
-              <a:xfrm flipH="false" flipV="false" rot="0">
+              <a:xfrm>
                 <a:off x="47136" y="48077"/>
                 <a:ext cx="1294103" cy="1291933"/>
               </a:xfrm>
@@ -16767,9 +16837,9 @@
                 <a:gdLst/>
                 <a:ahLst/>
                 <a:cxnLst/>
-                <a:rect r="r" b="b" t="t" l="l"/>
+                <a:rect l="l" t="t" r="r" b="b"/>
                 <a:pathLst>
-                  <a:path h="1291933" w="1294103">
+                  <a:path w="1294103" h="1291933">
                     <a:moveTo>
                       <a:pt x="210674" y="184333"/>
                     </a:moveTo>
@@ -16996,7 +17066,7 @@
         </p:grpSp>
         <p:grpSp>
           <p:nvGrpSpPr>
-            <p:cNvPr name="Group 127" id="127"/>
+            <p:cNvPr id="128" name="Group 128"/>
             <p:cNvGrpSpPr/>
             <p:nvPr/>
           </p:nvGrpSpPr>
@@ -17010,12 +17080,12 @@
           </p:grpSpPr>
           <p:sp>
             <p:nvSpPr>
-              <p:cNvPr name="Freeform 128" id="128"/>
+              <p:cNvPr id="129" name="Freeform 129"/>
               <p:cNvSpPr/>
               <p:nvPr/>
             </p:nvSpPr>
             <p:spPr>
-              <a:xfrm flipH="false" flipV="false" rot="0">
+              <a:xfrm>
                 <a:off x="50033" y="40910"/>
                 <a:ext cx="1241557" cy="1269605"/>
               </a:xfrm>
@@ -17024,9 +17094,9 @@
                 <a:gdLst/>
                 <a:ahLst/>
                 <a:cxnLst/>
-                <a:rect r="r" b="b" t="t" l="l"/>
+                <a:rect l="l" t="t" r="r" b="b"/>
                 <a:pathLst>
-                  <a:path h="1269605" w="1241557">
+                  <a:path w="1241557" h="1269605">
                     <a:moveTo>
                       <a:pt x="1241557" y="445500"/>
                     </a:moveTo>
@@ -17104,12 +17174,12 @@
       </p:grpSp>
       <p:sp>
         <p:nvSpPr>
-          <p:cNvPr name="Freeform 129" id="129"/>
+          <p:cNvPr id="130" name="Freeform 130"/>
           <p:cNvSpPr/>
           <p:nvPr/>
         </p:nvSpPr>
         <p:spPr>
-          <a:xfrm flipH="false" flipV="false" rot="0">
+          <a:xfrm>
             <a:off x="7970415" y="515342"/>
             <a:ext cx="614185" cy="647636"/>
           </a:xfrm>
@@ -17118,9 +17188,9 @@
             <a:gdLst/>
             <a:ahLst/>
             <a:cxnLst/>
-            <a:rect r="r" b="b" t="t" l="l"/>
+            <a:rect l="l" t="t" r="r" b="b"/>
             <a:pathLst>
-              <a:path h="647636" w="614185">
+              <a:path w="614185" h="647636">
                 <a:moveTo>
                   <a:pt x="0" y="0"/>
                 </a:moveTo>
@@ -17143,19 +17213,19 @@
           <a:blipFill>
             <a:blip r:embed="rId2"/>
             <a:stretch>
-              <a:fillRect l="0" t="-12600" r="0" b="-12293"/>
+              <a:fillRect t="-12600" b="-12293"/>
             </a:stretch>
           </a:blipFill>
         </p:spPr>
       </p:sp>
       <p:sp>
         <p:nvSpPr>
-          <p:cNvPr name="Freeform 130" id="130"/>
+          <p:cNvPr id="131" name="Freeform 131"/>
           <p:cNvSpPr/>
           <p:nvPr/>
         </p:nvSpPr>
         <p:spPr>
-          <a:xfrm flipH="false" flipV="false" rot="0">
+          <a:xfrm>
             <a:off x="8803676" y="521724"/>
             <a:ext cx="612730" cy="645031"/>
           </a:xfrm>
@@ -17164,9 +17234,9 @@
             <a:gdLst/>
             <a:ahLst/>
             <a:cxnLst/>
-            <a:rect r="r" b="b" t="t" l="l"/>
+            <a:rect l="l" t="t" r="r" b="b"/>
             <a:pathLst>
-              <a:path h="645031" w="612730">
+              <a:path w="612730" h="645031">
                 <a:moveTo>
                   <a:pt x="0" y="0"/>
                 </a:moveTo>
@@ -17196,12 +17266,12 @@
       </p:sp>
       <p:sp>
         <p:nvSpPr>
-          <p:cNvPr name="Freeform 131" id="131"/>
+          <p:cNvPr id="132" name="Freeform 132"/>
           <p:cNvSpPr/>
           <p:nvPr/>
         </p:nvSpPr>
         <p:spPr>
-          <a:xfrm flipH="false" flipV="false" rot="0">
+          <a:xfrm>
             <a:off x="1291034" y="515342"/>
             <a:ext cx="591436" cy="647636"/>
           </a:xfrm>
@@ -17210,9 +17280,9 @@
             <a:gdLst/>
             <a:ahLst/>
             <a:cxnLst/>
-            <a:rect r="r" b="b" t="t" l="l"/>
+            <a:rect l="l" t="t" r="r" b="b"/>
             <a:pathLst>
-              <a:path h="647636" w="591436">
+              <a:path w="591436" h="647636">
                 <a:moveTo>
                   <a:pt x="0" y="0"/>
                 </a:moveTo>
@@ -17242,12 +17312,12 @@
       </p:sp>
       <p:sp>
         <p:nvSpPr>
-          <p:cNvPr name="Freeform 132" id="132"/>
+          <p:cNvPr id="133" name="Freeform 133"/>
           <p:cNvSpPr/>
           <p:nvPr/>
         </p:nvSpPr>
         <p:spPr>
-          <a:xfrm flipH="false" flipV="false" rot="0">
+          <a:xfrm>
             <a:off x="2058850" y="515342"/>
             <a:ext cx="654205" cy="647636"/>
           </a:xfrm>
@@ -17256,9 +17326,9 @@
             <a:gdLst/>
             <a:ahLst/>
             <a:cxnLst/>
-            <a:rect r="r" b="b" t="t" l="l"/>
+            <a:rect l="l" t="t" r="r" b="b"/>
             <a:pathLst>
-              <a:path h="647636" w="654205">
+              <a:path w="654205" h="647636">
                 <a:moveTo>
                   <a:pt x="0" y="0"/>
                 </a:moveTo>
@@ -17281,19 +17351,19 @@
           <a:blipFill>
             <a:blip r:embed="rId5"/>
             <a:stretch>
-              <a:fillRect l="-1847" t="0" r="-1847" b="0"/>
+              <a:fillRect l="-1847" r="-1847"/>
             </a:stretch>
           </a:blipFill>
         </p:spPr>
       </p:sp>
       <p:sp>
         <p:nvSpPr>
-          <p:cNvPr name="Freeform 133" id="133"/>
+          <p:cNvPr id="134" name="Freeform 134"/>
           <p:cNvSpPr/>
           <p:nvPr/>
         </p:nvSpPr>
         <p:spPr>
-          <a:xfrm flipH="false" flipV="false" rot="0">
+          <a:xfrm>
             <a:off x="8183477" y="1204856"/>
             <a:ext cx="1232929" cy="555522"/>
           </a:xfrm>
@@ -17302,9 +17372,9 @@
             <a:gdLst/>
             <a:ahLst/>
             <a:cxnLst/>
-            <a:rect r="r" b="b" t="t" l="l"/>
+            <a:rect l="l" t="t" r="r" b="b"/>
             <a:pathLst>
-              <a:path h="555522" w="1232929">
+              <a:path w="1232929" h="555522">
                 <a:moveTo>
                   <a:pt x="0" y="0"/>
                 </a:moveTo>
@@ -17327,43 +17397,43 @@
           <a:blipFill>
             <a:blip r:embed="rId6"/>
             <a:stretch>
-              <a:fillRect l="0" t="-59066" r="0" b="-62874"/>
+              <a:fillRect t="-59066" b="-62874"/>
             </a:stretch>
           </a:blipFill>
         </p:spPr>
       </p:sp>
       <p:sp>
         <p:nvSpPr>
-          <p:cNvPr name="AutoShape 134" id="134"/>
+          <p:cNvPr id="135" name="AutoShape 135"/>
           <p:cNvSpPr/>
           <p:nvPr/>
         </p:nvSpPr>
         <p:spPr>
-          <a:xfrm flipV="true">
+          <a:xfrm flipV="1">
             <a:off x="2381886" y="4392938"/>
             <a:ext cx="5928227" cy="0"/>
           </a:xfrm>
           <a:prstGeom prst="line">
             <a:avLst/>
           </a:prstGeom>
-          <a:ln cap="flat" w="19050">
+          <a:ln w="19050" cap="flat">
             <a:solidFill>
               <a:srgbClr val="000000"/>
             </a:solidFill>
             <a:prstDash val="solid"/>
-            <a:headEnd type="none" len="sm" w="sm"/>
-            <a:tailEnd type="none" len="sm" w="sm"/>
+            <a:headEnd type="none" w="sm" len="sm"/>
+            <a:tailEnd type="none" w="sm" len="sm"/>
           </a:ln>
         </p:spPr>
       </p:sp>
       <p:sp>
         <p:nvSpPr>
-          <p:cNvPr name="Freeform 135" id="135"/>
+          <p:cNvPr id="136" name="Freeform 136"/>
           <p:cNvSpPr/>
           <p:nvPr/>
         </p:nvSpPr>
         <p:spPr>
-          <a:xfrm flipH="false" flipV="false" rot="0">
+          <a:xfrm>
             <a:off x="0" y="5116794"/>
             <a:ext cx="10692000" cy="4886413"/>
           </a:xfrm>
@@ -17372,9 +17442,9 @@
             <a:gdLst/>
             <a:ahLst/>
             <a:cxnLst/>
-            <a:rect r="r" b="b" t="t" l="l"/>
+            <a:rect l="l" t="t" r="r" b="b"/>
             <a:pathLst>
-              <a:path h="4886413" w="10692000">
+              <a:path w="10692000" h="4886413">
                 <a:moveTo>
                   <a:pt x="0" y="0"/>
                 </a:moveTo>
@@ -17399,118 +17469,20 @@
               <a:alphaModFix amt="9999"/>
             </a:blip>
             <a:stretch>
-              <a:fillRect l="-31747" t="-33393" r="0" b="-28763"/>
-            </a:stretch>
-          </a:blipFill>
-        </p:spPr>
-      </p:sp>
-      <p:sp>
-        <p:nvSpPr>
-          <p:cNvPr name="Freeform 136" id="136"/>
-          <p:cNvSpPr/>
-          <p:nvPr/>
-        </p:nvSpPr>
-        <p:spPr>
-          <a:xfrm flipH="false" flipV="false" rot="5400000">
-            <a:off x="1722364" y="-1471646"/>
-            <a:ext cx="7247272" cy="10503292"/>
-          </a:xfrm>
-          <a:custGeom>
-            <a:avLst/>
-            <a:gdLst/>
-            <a:ahLst/>
-            <a:cxnLst/>
-            <a:rect r="r" b="b" t="t" l="l"/>
-            <a:pathLst>
-              <a:path h="10503292" w="7247272">
-                <a:moveTo>
-                  <a:pt x="0" y="0"/>
-                </a:moveTo>
-                <a:lnTo>
-                  <a:pt x="7247272" y="0"/>
-                </a:lnTo>
-                <a:lnTo>
-                  <a:pt x="7247272" y="10503292"/>
-                </a:lnTo>
-                <a:lnTo>
-                  <a:pt x="0" y="10503292"/>
-                </a:lnTo>
-                <a:lnTo>
-                  <a:pt x="0" y="0"/>
-                </a:lnTo>
-                <a:close/>
-              </a:path>
-            </a:pathLst>
-          </a:custGeom>
-          <a:blipFill>
-            <a:blip r:embed="rId8">
-              <a:extLst>
-                <a:ext uri="{96DAC541-7B7A-43D3-8B79-37D633B846F1}">
-                  <asvg:svgBlip xmlns:asvg="http://schemas.microsoft.com/office/drawing/2016/SVG/main" r:embed="rId9"/>
-                </a:ext>
-              </a:extLst>
-            </a:blip>
-            <a:stretch>
-              <a:fillRect l="0" t="0" r="0" b="0"/>
-            </a:stretch>
-          </a:blipFill>
-        </p:spPr>
-      </p:sp>
-      <p:sp>
-        <p:nvSpPr>
-          <p:cNvPr name="Freeform 137" id="137"/>
-          <p:cNvSpPr/>
-          <p:nvPr/>
-        </p:nvSpPr>
-        <p:spPr>
-          <a:xfrm flipH="false" flipV="false" rot="-5400000">
-            <a:off x="8620274" y="5143968"/>
-            <a:ext cx="1695643" cy="3136422"/>
-          </a:xfrm>
-          <a:custGeom>
-            <a:avLst/>
-            <a:gdLst/>
-            <a:ahLst/>
-            <a:cxnLst/>
-            <a:rect r="r" b="b" t="t" l="l"/>
-            <a:pathLst>
-              <a:path h="3136422" w="1695643">
-                <a:moveTo>
-                  <a:pt x="0" y="0"/>
-                </a:moveTo>
-                <a:lnTo>
-                  <a:pt x="1695643" y="0"/>
-                </a:lnTo>
-                <a:lnTo>
-                  <a:pt x="1695643" y="3136421"/>
-                </a:lnTo>
-                <a:lnTo>
-                  <a:pt x="0" y="3136421"/>
-                </a:lnTo>
-                <a:lnTo>
-                  <a:pt x="0" y="0"/>
-                </a:lnTo>
-                <a:close/>
-              </a:path>
-            </a:pathLst>
-          </a:custGeom>
-          <a:blipFill>
-            <a:blip r:embed="rId10"/>
-            <a:stretch>
-              <a:fillRect l="0" t="-3389" r="-104533" b="0"/>
+              <a:fillRect l="-31747" t="-33393" b="-28763"/>
             </a:stretch>
           </a:blipFill>
         </p:spPr>
       </p:sp>
       <p:grpSp>
         <p:nvGrpSpPr>
-          <p:cNvPr name="Group 138" id="138"/>
+          <p:cNvPr id="138" name="Group 138"/>
           <p:cNvGrpSpPr/>
           <p:nvPr/>
         </p:nvGrpSpPr>
         <p:grpSpPr>
           <a:xfrm rot="0">
-            <a:off x="2272268" y="5814060"/>
+            <a:off x="2323856" y="5516737"/>
             <a:ext cx="5859622" cy="1624382"/>
             <a:chOff x="0" y="0"/>
             <a:chExt cx="7812829" cy="2165843"/>
@@ -17518,12 +17490,12 @@
         </p:grpSpPr>
         <p:sp>
           <p:nvSpPr>
-            <p:cNvPr name="Freeform 139" id="139"/>
+            <p:cNvPr id="139" name="Freeform 139"/>
             <p:cNvSpPr/>
             <p:nvPr/>
           </p:nvSpPr>
           <p:spPr>
-            <a:xfrm flipH="false" flipV="false" rot="5400000">
+            <a:xfrm rot="5400000">
               <a:off x="5353761" y="-335327"/>
               <a:ext cx="2123741" cy="2794396"/>
             </a:xfrm>
@@ -17532,9 +17504,9 @@
               <a:gdLst/>
               <a:ahLst/>
               <a:cxnLst/>
-              <a:rect r="r" b="b" t="t" l="l"/>
+              <a:rect l="l" t="t" r="r" b="b"/>
               <a:pathLst>
-                <a:path h="2794396" w="2123741">
+                <a:path w="2123741" h="2794396">
                   <a:moveTo>
                     <a:pt x="0" y="0"/>
                   </a:moveTo>
@@ -17555,21 +17527,21 @@
               </a:pathLst>
             </a:custGeom>
             <a:blipFill>
-              <a:blip r:embed="rId11"/>
+              <a:blip r:embed="rId8"/>
               <a:stretch>
-                <a:fillRect l="0" t="0" r="0" b="0"/>
+                <a:fillRect/>
               </a:stretch>
             </a:blipFill>
           </p:spPr>
         </p:sp>
         <p:sp>
           <p:nvSpPr>
-            <p:cNvPr name="Freeform 140" id="140"/>
+            <p:cNvPr id="140" name="Freeform 140"/>
             <p:cNvSpPr/>
             <p:nvPr/>
           </p:nvSpPr>
           <p:spPr>
-            <a:xfrm flipH="false" flipV="false" rot="5400000">
+            <a:xfrm rot="5400000">
               <a:off x="333954" y="-283154"/>
               <a:ext cx="2115043" cy="2782951"/>
             </a:xfrm>
@@ -17578,9 +17550,9 @@
               <a:gdLst/>
               <a:ahLst/>
               <a:cxnLst/>
-              <a:rect r="r" b="b" t="t" l="l"/>
+              <a:rect l="l" t="t" r="r" b="b"/>
               <a:pathLst>
-                <a:path h="2782951" w="2115043">
+                <a:path w="2115043" h="2782951">
                   <a:moveTo>
                     <a:pt x="0" y="0"/>
                   </a:moveTo>
@@ -17601,21 +17573,21 @@
               </a:pathLst>
             </a:custGeom>
             <a:blipFill>
-              <a:blip r:embed="rId11"/>
+              <a:blip r:embed="rId8"/>
               <a:stretch>
-                <a:fillRect l="0" t="0" r="0" b="0"/>
+                <a:fillRect/>
               </a:stretch>
             </a:blipFill>
           </p:spPr>
         </p:sp>
         <p:sp>
           <p:nvSpPr>
-            <p:cNvPr name="TextBox 141" id="141"/>
-            <p:cNvSpPr txBox="true"/>
+            <p:cNvPr id="141" name="TextBox 141"/>
+            <p:cNvSpPr txBox="1"/>
             <p:nvPr/>
           </p:nvSpPr>
           <p:spPr>
-            <a:xfrm rot="0">
+            <a:xfrm>
               <a:off x="149481" y="1391633"/>
               <a:ext cx="2791493" cy="198580"/>
             </a:xfrm>
@@ -17624,7 +17596,7 @@
             </a:prstGeom>
           </p:spPr>
           <p:txBody>
-            <a:bodyPr anchor="t" rtlCol="false" tIns="0" lIns="0" bIns="0" rIns="0">
+            <a:bodyPr lIns="0" tIns="0" rIns="0" bIns="0" rtlCol="0" anchor="t">
               <a:spAutoFit/>
             </a:bodyPr>
             <a:lstStyle/>
@@ -17639,72 +17611,81 @@
                   <a:solidFill>
                     <a:srgbClr val="01327B"/>
                   </a:solidFill>
-                  <a:latin typeface="Caladea"/>
-                  <a:ea typeface="Caladea"/>
-                  <a:cs typeface="Caladea"/>
-                  <a:sym typeface="Caladea"/>
+                  <a:latin typeface="Caladea" panose="02040503050406030204"/>
+                  <a:ea typeface="Caladea" panose="02040503050406030204"/>
+                  <a:cs typeface="Caladea" panose="02040503050406030204"/>
+                  <a:sym typeface="Caladea" panose="02040503050406030204"/>
                 </a:rPr>
                 <a:t>R&amp;D Chief Coordinator</a:t>
               </a:r>
+              <a:endParaRPr lang="en-US" sz="1100">
+                <a:solidFill>
+                  <a:srgbClr val="01327B"/>
+                </a:solidFill>
+                <a:latin typeface="Caladea" panose="02040503050406030204"/>
+                <a:ea typeface="Caladea" panose="02040503050406030204"/>
+                <a:cs typeface="Caladea" panose="02040503050406030204"/>
+                <a:sym typeface="Caladea" panose="02040503050406030204"/>
+              </a:endParaRPr>
             </a:p>
           </p:txBody>
         </p:sp>
         <p:sp>
           <p:nvSpPr>
-            <p:cNvPr name="AutoShape 142" id="142"/>
+            <p:cNvPr id="142" name="AutoShape 142"/>
             <p:cNvSpPr/>
             <p:nvPr/>
           </p:nvSpPr>
           <p:spPr>
-            <a:xfrm flipV="true">
+            <a:xfrm flipV="1">
               <a:off x="324220" y="1078109"/>
               <a:ext cx="2442014" cy="0"/>
             </a:xfrm>
             <a:prstGeom prst="line">
               <a:avLst/>
             </a:prstGeom>
-            <a:ln cap="flat" w="12700">
+            <a:ln w="12700" cap="flat">
               <a:solidFill>
                 <a:srgbClr val="000000"/>
               </a:solidFill>
               <a:prstDash val="solid"/>
-              <a:headEnd type="none" len="sm" w="sm"/>
-              <a:tailEnd type="none" len="sm" w="sm"/>
+              <a:headEnd type="none" w="sm" len="sm"/>
+              <a:tailEnd type="none" w="sm" len="sm"/>
             </a:ln>
           </p:spPr>
         </p:sp>
         <p:sp>
           <p:nvSpPr>
-            <p:cNvPr name="AutoShape 143" id="143"/>
+            <p:cNvPr id="143" name="AutoShape 143"/>
             <p:cNvSpPr/>
             <p:nvPr/>
           </p:nvSpPr>
           <p:spPr>
-            <a:xfrm flipV="true">
+            <a:xfrm flipV="1">
               <a:off x="5830018" y="1078109"/>
               <a:ext cx="1840057" cy="0"/>
             </a:xfrm>
             <a:prstGeom prst="line">
               <a:avLst/>
             </a:prstGeom>
-            <a:ln cap="flat" w="12700">
+            <a:ln w="12700" cap="flat">
               <a:solidFill>
                 <a:srgbClr val="000000"/>
               </a:solidFill>
               <a:prstDash val="solid"/>
-              <a:headEnd type="none" len="sm" w="sm"/>
-              <a:tailEnd type="none" len="sm" w="sm"/>
+              <a:headEnd type="none" w="sm" len="sm"/>
+              <a:tailEnd type="none" w="sm" len="sm"/>
             </a:ln>
           </p:spPr>
         </p:sp>
         <p:sp>
           <p:nvSpPr>
-            <p:cNvPr name="TextBox 144" id="144"/>
-            <p:cNvSpPr txBox="true"/>
+            <p:cNvPr id="144" name="TextBox 144"/>
+            <p:cNvSpPr txBox="1"/>
             <p:nvPr/>
           </p:nvSpPr>
           <p:spPr>
-            <a:xfrm rot="0">
+            <a:xfrm>
               <a:off x="5830018" y="1167384"/>
               <a:ext cx="1840057" cy="207609"/>
             </a:xfrm>
@@ -17713,7 +17694,7 @@
             </a:prstGeom>
           </p:spPr>
           <p:txBody>
-            <a:bodyPr anchor="t" rtlCol="false" tIns="0" lIns="0" bIns="0" rIns="0">
+            <a:bodyPr lIns="0" tIns="0" rIns="0" bIns="0" rtlCol="0" anchor="t">
               <a:spAutoFit/>
             </a:bodyPr>
             <a:lstStyle/>
@@ -17724,28 +17705,37 @@
                 </a:lnSpc>
               </a:pPr>
               <a:r>
-                <a:rPr lang="en-US" sz="1200" b="true">
+                <a:rPr lang="en-US" sz="1200" b="1">
                   <a:solidFill>
                     <a:srgbClr val="01327B"/>
                   </a:solidFill>
-                  <a:latin typeface="Caladea Bold"/>
-                  <a:ea typeface="Caladea Bold"/>
-                  <a:cs typeface="Caladea Bold"/>
-                  <a:sym typeface="Caladea Bold"/>
+                  <a:latin typeface="Caladea Bold" panose="02040803050406030204"/>
+                  <a:ea typeface="Caladea Bold" panose="02040803050406030204"/>
+                  <a:cs typeface="Caladea Bold" panose="02040803050406030204"/>
+                  <a:sym typeface="Caladea Bold" panose="02040803050406030204"/>
                 </a:rPr>
                 <a:t>Dr. Mani Ganesh</a:t>
               </a:r>
+              <a:endParaRPr lang="en-US" sz="1200" b="1">
+                <a:solidFill>
+                  <a:srgbClr val="01327B"/>
+                </a:solidFill>
+                <a:latin typeface="Caladea Bold" panose="02040803050406030204"/>
+                <a:ea typeface="Caladea Bold" panose="02040803050406030204"/>
+                <a:cs typeface="Caladea Bold" panose="02040803050406030204"/>
+                <a:sym typeface="Caladea Bold" panose="02040803050406030204"/>
+              </a:endParaRPr>
             </a:p>
           </p:txBody>
         </p:sp>
         <p:sp>
           <p:nvSpPr>
-            <p:cNvPr name="TextBox 145" id="145"/>
-            <p:cNvSpPr txBox="true"/>
+            <p:cNvPr id="145" name="TextBox 145"/>
+            <p:cNvSpPr txBox="1"/>
             <p:nvPr/>
           </p:nvSpPr>
           <p:spPr>
-            <a:xfrm rot="0">
+            <a:xfrm>
               <a:off x="138228" y="1167384"/>
               <a:ext cx="2813998" cy="207609"/>
             </a:xfrm>
@@ -17754,7 +17744,7 @@
             </a:prstGeom>
           </p:spPr>
           <p:txBody>
-            <a:bodyPr anchor="t" rtlCol="false" tIns="0" lIns="0" bIns="0" rIns="0">
+            <a:bodyPr lIns="0" tIns="0" rIns="0" bIns="0" rtlCol="0" anchor="t">
               <a:spAutoFit/>
             </a:bodyPr>
             <a:lstStyle/>
@@ -17765,28 +17755,37 @@
                 </a:lnSpc>
               </a:pPr>
               <a:r>
-                <a:rPr lang="en-US" sz="1200" b="true">
+                <a:rPr lang="en-US" sz="1200" b="1">
                   <a:solidFill>
                     <a:srgbClr val="01327B"/>
                   </a:solidFill>
-                  <a:latin typeface="Caladea Bold"/>
-                  <a:ea typeface="Caladea Bold"/>
-                  <a:cs typeface="Caladea Bold"/>
-                  <a:sym typeface="Caladea Bold"/>
+                  <a:latin typeface="Caladea Bold" panose="02040803050406030204"/>
+                  <a:ea typeface="Caladea Bold" panose="02040803050406030204"/>
+                  <a:cs typeface="Caladea Bold" panose="02040803050406030204"/>
+                  <a:sym typeface="Caladea Bold" panose="02040803050406030204"/>
                 </a:rPr>
                 <a:t>Dr. Vootla Ashok Kumar</a:t>
               </a:r>
+              <a:endParaRPr lang="en-US" sz="1200" b="1">
+                <a:solidFill>
+                  <a:srgbClr val="01327B"/>
+                </a:solidFill>
+                <a:latin typeface="Caladea Bold" panose="02040803050406030204"/>
+                <a:ea typeface="Caladea Bold" panose="02040803050406030204"/>
+                <a:cs typeface="Caladea Bold" panose="02040803050406030204"/>
+                <a:sym typeface="Caladea Bold" panose="02040803050406030204"/>
+              </a:endParaRPr>
             </a:p>
           </p:txBody>
         </p:sp>
         <p:sp>
           <p:nvSpPr>
-            <p:cNvPr name="Freeform 146" id="146"/>
+            <p:cNvPr id="146" name="Freeform 146"/>
             <p:cNvSpPr/>
             <p:nvPr/>
           </p:nvSpPr>
           <p:spPr>
-            <a:xfrm flipH="false" flipV="false" rot="0">
+            <a:xfrm>
               <a:off x="831010" y="517697"/>
               <a:ext cx="1261292" cy="1002966"/>
             </a:xfrm>
@@ -17795,9 +17794,9 @@
               <a:gdLst/>
               <a:ahLst/>
               <a:cxnLst/>
-              <a:rect r="r" b="b" t="t" l="l"/>
+              <a:rect l="l" t="t" r="r" b="b"/>
               <a:pathLst>
-                <a:path h="1002966" w="1261292">
+                <a:path w="1261292" h="1002966">
                   <a:moveTo>
                     <a:pt x="0" y="0"/>
                   </a:moveTo>
@@ -17818,21 +17817,21 @@
               </a:pathLst>
             </a:custGeom>
             <a:blipFill>
-              <a:blip r:embed="rId12"/>
+              <a:blip r:embed="rId9"/>
               <a:stretch>
-                <a:fillRect l="0" t="-5249" r="0" b="-5249"/>
+                <a:fillRect t="-5249" b="-5249"/>
               </a:stretch>
             </a:blipFill>
           </p:spPr>
         </p:sp>
         <p:sp>
           <p:nvSpPr>
-            <p:cNvPr name="Freeform 147" id="147"/>
+            <p:cNvPr id="147" name="Freeform 147"/>
             <p:cNvSpPr/>
             <p:nvPr/>
           </p:nvSpPr>
           <p:spPr>
-            <a:xfrm flipH="false" flipV="false" rot="0">
+            <a:xfrm>
               <a:off x="6056510" y="486483"/>
               <a:ext cx="1387073" cy="833111"/>
             </a:xfrm>
@@ -17841,9 +17840,9 @@
               <a:gdLst/>
               <a:ahLst/>
               <a:cxnLst/>
-              <a:rect r="r" b="b" t="t" l="l"/>
+              <a:rect l="l" t="t" r="r" b="b"/>
               <a:pathLst>
-                <a:path h="833111" w="1387073">
+                <a:path w="1387073" h="833111">
                   <a:moveTo>
                     <a:pt x="0" y="0"/>
                   </a:moveTo>
@@ -17864,21 +17863,21 @@
               </a:pathLst>
             </a:custGeom>
             <a:blipFill>
-              <a:blip r:embed="rId13"/>
+              <a:blip r:embed="rId10"/>
               <a:stretch>
-                <a:fillRect l="0" t="0" r="0" b="0"/>
+                <a:fillRect/>
               </a:stretch>
             </a:blipFill>
           </p:spPr>
         </p:sp>
         <p:sp>
           <p:nvSpPr>
-            <p:cNvPr name="TextBox 148" id="148"/>
-            <p:cNvSpPr txBox="true"/>
+            <p:cNvPr id="148" name="TextBox 148"/>
+            <p:cNvSpPr txBox="1"/>
             <p:nvPr/>
           </p:nvSpPr>
           <p:spPr>
-            <a:xfrm rot="0">
+            <a:xfrm>
               <a:off x="6164926" y="1403568"/>
               <a:ext cx="1170240" cy="207609"/>
             </a:xfrm>
@@ -17887,7 +17886,7 @@
             </a:prstGeom>
           </p:spPr>
           <p:txBody>
-            <a:bodyPr anchor="t" rtlCol="false" tIns="0" lIns="0" bIns="0" rIns="0">
+            <a:bodyPr lIns="0" tIns="0" rIns="0" bIns="0" rtlCol="0" anchor="t">
               <a:spAutoFit/>
             </a:bodyPr>
             <a:lstStyle/>
@@ -17902,163 +17901,34 @@
                   <a:solidFill>
                     <a:srgbClr val="01327B"/>
                   </a:solidFill>
-                  <a:latin typeface="Caladea"/>
-                  <a:ea typeface="Caladea"/>
-                  <a:cs typeface="Caladea"/>
-                  <a:sym typeface="Caladea"/>
+                  <a:latin typeface="Caladea" panose="02040503050406030204"/>
+                  <a:ea typeface="Caladea" panose="02040503050406030204"/>
+                  <a:cs typeface="Caladea" panose="02040503050406030204"/>
+                  <a:sym typeface="Caladea" panose="02040503050406030204"/>
                 </a:rPr>
                 <a:t>Principal</a:t>
               </a:r>
+              <a:endParaRPr lang="en-US" sz="1200">
+                <a:solidFill>
+                  <a:srgbClr val="01327B"/>
+                </a:solidFill>
+                <a:latin typeface="Caladea" panose="02040503050406030204"/>
+                <a:ea typeface="Caladea" panose="02040503050406030204"/>
+                <a:cs typeface="Caladea" panose="02040503050406030204"/>
+                <a:sym typeface="Caladea" panose="02040503050406030204"/>
+              </a:endParaRPr>
             </a:p>
           </p:txBody>
         </p:sp>
       </p:grpSp>
       <p:sp>
         <p:nvSpPr>
-          <p:cNvPr name="Freeform 149" id="149"/>
+          <p:cNvPr id="149" name="Freeform 149"/>
           <p:cNvSpPr/>
           <p:nvPr/>
         </p:nvSpPr>
         <p:spPr>
-          <a:xfrm flipH="false" flipV="false" rot="5400000">
-            <a:off x="479967" y="-1218826"/>
-            <a:ext cx="1935630" cy="4373282"/>
-          </a:xfrm>
-          <a:custGeom>
-            <a:avLst/>
-            <a:gdLst/>
-            <a:ahLst/>
-            <a:cxnLst/>
-            <a:rect r="r" b="b" t="t" l="l"/>
-            <a:pathLst>
-              <a:path h="4373282" w="1935630">
-                <a:moveTo>
-                  <a:pt x="0" y="0"/>
-                </a:moveTo>
-                <a:lnTo>
-                  <a:pt x="1935630" y="0"/>
-                </a:lnTo>
-                <a:lnTo>
-                  <a:pt x="1935630" y="4373282"/>
-                </a:lnTo>
-                <a:lnTo>
-                  <a:pt x="0" y="4373282"/>
-                </a:lnTo>
-                <a:lnTo>
-                  <a:pt x="0" y="0"/>
-                </a:lnTo>
-                <a:close/>
-              </a:path>
-            </a:pathLst>
-          </a:custGeom>
-          <a:blipFill>
-            <a:blip r:embed="rId10"/>
-            <a:stretch>
-              <a:fillRect l="0" t="-5814" r="-155694" b="0"/>
-            </a:stretch>
-          </a:blipFill>
-        </p:spPr>
-      </p:sp>
-      <p:sp>
-        <p:nvSpPr>
-          <p:cNvPr name="Freeform 150" id="150"/>
-          <p:cNvSpPr/>
-          <p:nvPr/>
-        </p:nvSpPr>
-        <p:spPr>
-          <a:xfrm flipH="false" flipV="false" rot="0">
-            <a:off x="8841013" y="187608"/>
-            <a:ext cx="1706987" cy="1724229"/>
-          </a:xfrm>
-          <a:custGeom>
-            <a:avLst/>
-            <a:gdLst/>
-            <a:ahLst/>
-            <a:cxnLst/>
-            <a:rect r="r" b="b" t="t" l="l"/>
-            <a:pathLst>
-              <a:path h="1724229" w="1706987">
-                <a:moveTo>
-                  <a:pt x="0" y="0"/>
-                </a:moveTo>
-                <a:lnTo>
-                  <a:pt x="1706987" y="0"/>
-                </a:lnTo>
-                <a:lnTo>
-                  <a:pt x="1706987" y="1724229"/>
-                </a:lnTo>
-                <a:lnTo>
-                  <a:pt x="0" y="1724229"/>
-                </a:lnTo>
-                <a:lnTo>
-                  <a:pt x="0" y="0"/>
-                </a:lnTo>
-                <a:close/>
-              </a:path>
-            </a:pathLst>
-          </a:custGeom>
-          <a:blipFill>
-            <a:blip r:embed="rId14"/>
-            <a:stretch>
-              <a:fillRect l="0" t="0" r="0" b="0"/>
-            </a:stretch>
-          </a:blipFill>
-        </p:spPr>
-      </p:sp>
-      <p:sp>
-        <p:nvSpPr>
-          <p:cNvPr name="Freeform 151" id="151"/>
-          <p:cNvSpPr/>
-          <p:nvPr/>
-        </p:nvSpPr>
-        <p:spPr>
-          <a:xfrm flipH="false" flipV="false" rot="-10800000">
-            <a:off x="130354" y="5643407"/>
-            <a:ext cx="1706987" cy="1724229"/>
-          </a:xfrm>
-          <a:custGeom>
-            <a:avLst/>
-            <a:gdLst/>
-            <a:ahLst/>
-            <a:cxnLst/>
-            <a:rect r="r" b="b" t="t" l="l"/>
-            <a:pathLst>
-              <a:path h="1724229" w="1706987">
-                <a:moveTo>
-                  <a:pt x="0" y="0"/>
-                </a:moveTo>
-                <a:lnTo>
-                  <a:pt x="1706987" y="0"/>
-                </a:lnTo>
-                <a:lnTo>
-                  <a:pt x="1706987" y="1724229"/>
-                </a:lnTo>
-                <a:lnTo>
-                  <a:pt x="0" y="1724229"/>
-                </a:lnTo>
-                <a:lnTo>
-                  <a:pt x="0" y="0"/>
-                </a:lnTo>
-                <a:close/>
-              </a:path>
-            </a:pathLst>
-          </a:custGeom>
-          <a:blipFill>
-            <a:blip r:embed="rId14"/>
-            <a:stretch>
-              <a:fillRect l="0" t="0" r="0" b="0"/>
-            </a:stretch>
-          </a:blipFill>
-        </p:spPr>
-      </p:sp>
-      <p:sp>
-        <p:nvSpPr>
-          <p:cNvPr name="Freeform 152" id="152"/>
-          <p:cNvSpPr/>
-          <p:nvPr/>
-        </p:nvSpPr>
-        <p:spPr>
-          <a:xfrm flipH="false" flipV="false" rot="0">
+          <a:xfrm>
             <a:off x="3441772" y="421159"/>
             <a:ext cx="3808456" cy="836002"/>
           </a:xfrm>
@@ -18067,9 +17937,9 @@
             <a:gdLst/>
             <a:ahLst/>
             <a:cxnLst/>
-            <a:rect r="r" b="b" t="t" l="l"/>
+            <a:rect l="l" t="t" r="r" b="b"/>
             <a:pathLst>
-              <a:path h="836002" w="3808456">
+              <a:path w="3808456" h="836002">
                 <a:moveTo>
                   <a:pt x="0" y="0"/>
                 </a:moveTo>
@@ -18090,21 +17960,21 @@
             </a:pathLst>
           </a:custGeom>
           <a:blipFill>
-            <a:blip r:embed="rId15"/>
+            <a:blip r:embed="rId11"/>
             <a:stretch>
-              <a:fillRect l="0" t="0" r="0" b="0"/>
+              <a:fillRect/>
             </a:stretch>
           </a:blipFill>
         </p:spPr>
       </p:sp>
       <p:sp>
         <p:nvSpPr>
-          <p:cNvPr name="Freeform 153" id="153"/>
+          <p:cNvPr id="150" name="Freeform 150"/>
           <p:cNvSpPr/>
           <p:nvPr/>
         </p:nvSpPr>
         <p:spPr>
-          <a:xfrm flipH="false" flipV="false" rot="0">
+          <a:xfrm>
             <a:off x="3441772" y="1166756"/>
             <a:ext cx="3808456" cy="928716"/>
           </a:xfrm>
@@ -18113,9 +17983,9 @@
             <a:gdLst/>
             <a:ahLst/>
             <a:cxnLst/>
-            <a:rect r="r" b="b" t="t" l="l"/>
+            <a:rect l="l" t="t" r="r" b="b"/>
             <a:pathLst>
-              <a:path h="928716" w="3808456">
+              <a:path w="3808456" h="928716">
                 <a:moveTo>
                   <a:pt x="0" y="0"/>
                 </a:moveTo>
@@ -18136,21 +18006,21 @@
             </a:pathLst>
           </a:custGeom>
           <a:blipFill>
-            <a:blip r:embed="rId16"/>
+            <a:blip r:embed="rId12"/>
             <a:stretch>
-              <a:fillRect l="0" t="0" r="0" b="0"/>
+              <a:fillRect/>
             </a:stretch>
           </a:blipFill>
         </p:spPr>
       </p:sp>
       <p:sp>
         <p:nvSpPr>
-          <p:cNvPr name="TextBox 154" id="154"/>
-          <p:cNvSpPr txBox="true"/>
+          <p:cNvPr id="151" name="TextBox 151"/>
+          <p:cNvSpPr txBox="1"/>
           <p:nvPr/>
         </p:nvSpPr>
         <p:spPr>
-          <a:xfrm rot="0">
+          <a:xfrm>
             <a:off x="1574763" y="1849951"/>
             <a:ext cx="7542474" cy="1109953"/>
           </a:xfrm>
@@ -18159,39 +18029,48 @@
           </a:prstGeom>
         </p:spPr>
         <p:txBody>
-          <a:bodyPr anchor="t" rtlCol="false" tIns="0" lIns="0" bIns="0" rIns="0">
+          <a:bodyPr lIns="0" tIns="0" rIns="0" bIns="0" rtlCol="0" anchor="t">
             <a:spAutoFit/>
           </a:bodyPr>
           <a:lstStyle/>
           <a:p>
             <a:pPr algn="ctr">
               <a:lnSpc>
-                <a:spcPts val="8119"/>
+                <a:spcPts val="8120"/>
               </a:lnSpc>
             </a:pPr>
             <a:r>
-              <a:rPr lang="en-US" b="true" sz="5799" spc="1873">
+              <a:rPr lang="en-US" sz="5800" b="1" spc="1873">
                 <a:solidFill>
                   <a:srgbClr val="01327B"/>
                 </a:solidFill>
-                <a:latin typeface="Palatino Bold"/>
-                <a:ea typeface="Palatino Bold"/>
-                <a:cs typeface="Palatino Bold"/>
-                <a:sym typeface="Palatino Bold"/>
+                <a:latin typeface="Palatino Bold" panose="02040702050505030304"/>
+                <a:ea typeface="Palatino Bold" panose="02040702050505030304"/>
+                <a:cs typeface="Palatino Bold" panose="02040702050505030304"/>
+                <a:sym typeface="Palatino Bold" panose="02040702050505030304"/>
               </a:rPr>
               <a:t>CERTIFICATE</a:t>
             </a:r>
+            <a:endParaRPr lang="en-US" sz="5800" b="1" spc="1873">
+              <a:solidFill>
+                <a:srgbClr val="01327B"/>
+              </a:solidFill>
+              <a:latin typeface="Palatino Bold" panose="02040702050505030304"/>
+              <a:ea typeface="Palatino Bold" panose="02040702050505030304"/>
+              <a:cs typeface="Palatino Bold" panose="02040702050505030304"/>
+              <a:sym typeface="Palatino Bold" panose="02040702050505030304"/>
+            </a:endParaRPr>
           </a:p>
         </p:txBody>
       </p:sp>
       <p:sp>
         <p:nvSpPr>
-          <p:cNvPr name="TextBox 155" id="155"/>
-          <p:cNvSpPr txBox="true"/>
+          <p:cNvPr id="152" name="TextBox 152"/>
+          <p:cNvSpPr txBox="1"/>
           <p:nvPr/>
         </p:nvSpPr>
         <p:spPr>
-          <a:xfrm rot="0">
+          <a:xfrm>
             <a:off x="1574763" y="2760981"/>
             <a:ext cx="7542474" cy="422275"/>
           </a:xfrm>
@@ -18200,18 +18079,18 @@
           </a:prstGeom>
         </p:spPr>
         <p:txBody>
-          <a:bodyPr anchor="t" rtlCol="false" tIns="0" lIns="0" bIns="0" rIns="0">
+          <a:bodyPr lIns="0" tIns="0" rIns="0" bIns="0" rtlCol="0" anchor="t">
             <a:spAutoFit/>
           </a:bodyPr>
           <a:lstStyle/>
           <a:p>
             <a:pPr algn="ctr">
               <a:lnSpc>
-                <a:spcPts val="3499"/>
+                <a:spcPts val="3500"/>
               </a:lnSpc>
             </a:pPr>
             <a:r>
-              <a:rPr lang="en-US" b="true" sz="2499" spc="1299">
+              <a:rPr lang="en-US" sz="2500" b="1" spc="1299">
                 <a:solidFill>
                   <a:srgbClr val="01327B"/>
                 </a:solidFill>
@@ -18222,17 +18101,26 @@
               </a:rPr>
               <a:t>OF Participation</a:t>
             </a:r>
+            <a:endParaRPr lang="en-US" sz="2500" b="1" spc="1299">
+              <a:solidFill>
+                <a:srgbClr val="01327B"/>
+              </a:solidFill>
+              <a:latin typeface="Inria Serif Bold"/>
+              <a:ea typeface="Inria Serif Bold"/>
+              <a:cs typeface="Inria Serif Bold"/>
+              <a:sym typeface="Inria Serif Bold"/>
+            </a:endParaRPr>
           </a:p>
         </p:txBody>
       </p:sp>
       <p:sp>
         <p:nvSpPr>
-          <p:cNvPr name="TextBox 156" id="156"/>
-          <p:cNvSpPr txBox="true"/>
+          <p:cNvPr id="153" name="TextBox 153"/>
+          <p:cNvSpPr txBox="1"/>
           <p:nvPr/>
         </p:nvSpPr>
         <p:spPr>
-          <a:xfrm rot="0">
+          <a:xfrm>
             <a:off x="1689892" y="3286956"/>
             <a:ext cx="7542474" cy="266700"/>
           </a:xfrm>
@@ -18241,7 +18129,7 @@
           </a:prstGeom>
         </p:spPr>
         <p:txBody>
-          <a:bodyPr anchor="t" rtlCol="false" tIns="0" lIns="0" bIns="0" rIns="0">
+          <a:bodyPr lIns="0" tIns="0" rIns="0" bIns="0" rtlCol="0" anchor="t">
             <a:spAutoFit/>
           </a:bodyPr>
           <a:lstStyle/>
@@ -18263,17 +18151,26 @@
               </a:rPr>
               <a:t>This is to certify that</a:t>
             </a:r>
+            <a:endParaRPr lang="en-US" sz="1500" spc="162">
+              <a:solidFill>
+                <a:srgbClr val="01327B"/>
+              </a:solidFill>
+              <a:latin typeface="Inria Serif"/>
+              <a:ea typeface="Inria Serif"/>
+              <a:cs typeface="Inria Serif"/>
+              <a:sym typeface="Inria Serif"/>
+            </a:endParaRPr>
           </a:p>
         </p:txBody>
       </p:sp>
       <p:sp>
         <p:nvSpPr>
-          <p:cNvPr name="TextBox 157" id="157"/>
-          <p:cNvSpPr txBox="true"/>
+          <p:cNvPr id="154" name="TextBox 154"/>
+          <p:cNvSpPr txBox="1"/>
           <p:nvPr/>
         </p:nvSpPr>
         <p:spPr>
-          <a:xfrm rot="0">
+          <a:xfrm>
             <a:off x="893277" y="4479007"/>
             <a:ext cx="8905445" cy="1529588"/>
           </a:xfrm>
@@ -18282,14 +18179,14 @@
           </a:prstGeom>
         </p:spPr>
         <p:txBody>
-          <a:bodyPr anchor="t" rtlCol="false" tIns="0" lIns="0" bIns="0" rIns="0">
+          <a:bodyPr lIns="0" tIns="0" rIns="0" bIns="0" rtlCol="0" anchor="t">
             <a:spAutoFit/>
           </a:bodyPr>
           <a:lstStyle/>
           <a:p>
             <a:pPr algn="ctr">
               <a:lnSpc>
-                <a:spcPts val="1792"/>
+                <a:spcPts val="1790"/>
               </a:lnSpc>
             </a:pPr>
             <a:r>
@@ -18449,14 +18346,14 @@
               <a:t>a</a:t>
             </a:r>
             <a:r>
-              <a:rPr lang="en-US" b="true" sz="1280" spc="138">
+              <a:rPr lang="en-US" sz="1280" b="1" spc="138">
                 <a:solidFill>
                   <a:srgbClr val="01327B"/>
                 </a:solidFill>
-                <a:latin typeface="Cormorant Garamond Bold"/>
-                <a:ea typeface="Cormorant Garamond Bold"/>
-                <a:cs typeface="Cormorant Garamond Bold"/>
-                <a:sym typeface="Cormorant Garamond Bold"/>
+                <a:latin typeface="Cormorant Garamond Bold" panose="00000800000000000000"/>
+                <a:ea typeface="Cormorant Garamond Bold" panose="00000800000000000000"/>
+                <a:cs typeface="Cormorant Garamond Bold" panose="00000800000000000000"/>
+                <a:sym typeface="Cormorant Garamond Bold" panose="00000800000000000000"/>
               </a:rPr>
               <a:t> {{ROLE}}</a:t>
             </a:r>
@@ -18473,14 +18370,14 @@
               <a:t> in the </a:t>
             </a:r>
             <a:r>
-              <a:rPr lang="en-US" b="true" sz="1280" spc="138">
+              <a:rPr lang="en-US" sz="1280" b="1" spc="138">
                 <a:solidFill>
                   <a:srgbClr val="01327B"/>
                 </a:solidFill>
-                <a:latin typeface="Cormorant Garamond Bold"/>
-                <a:ea typeface="Cormorant Garamond Bold"/>
-                <a:cs typeface="Cormorant Garamond Bold"/>
-                <a:sym typeface="Cormorant Garamond Bold"/>
+                <a:latin typeface="Cormorant Garamond Bold" panose="00000800000000000000"/>
+                <a:ea typeface="Cormorant Garamond Bold" panose="00000800000000000000"/>
+                <a:cs typeface="Cormorant Garamond Bold" panose="00000800000000000000"/>
+                <a:sym typeface="Cormorant Garamond Bold" panose="00000800000000000000"/>
               </a:rPr>
               <a:t>{{HACKATHON NAME}},</a:t>
             </a:r>
@@ -18497,14 +18394,14 @@
               <a:t> organized by </a:t>
             </a:r>
             <a:r>
-              <a:rPr lang="en-US" b="true" sz="1280" spc="138">
+              <a:rPr lang="en-US" sz="1280" b="1" spc="138">
                 <a:solidFill>
                   <a:srgbClr val="01327B"/>
                 </a:solidFill>
-                <a:latin typeface="Cormorant Garamond Bold"/>
-                <a:ea typeface="Cormorant Garamond Bold"/>
-                <a:cs typeface="Cormorant Garamond Bold"/>
-                <a:sym typeface="Cormorant Garamond Bold"/>
+                <a:latin typeface="Cormorant Garamond Bold" panose="00000800000000000000"/>
+                <a:ea typeface="Cormorant Garamond Bold" panose="00000800000000000000"/>
+                <a:cs typeface="Cormorant Garamond Bold" panose="00000800000000000000"/>
+                <a:sym typeface="Cormorant Garamond Bold" panose="00000800000000000000"/>
               </a:rPr>
               <a:t>Trinity College of Engineering and Technology (Autonomous), Peddapalli</a:t>
             </a:r>
@@ -18521,14 +18418,14 @@
               <a:t>, held on</a:t>
             </a:r>
             <a:r>
-              <a:rPr lang="en-US" b="true" sz="1280" spc="138">
+              <a:rPr lang="en-US" sz="1280" b="1" spc="138">
                 <a:solidFill>
                   <a:srgbClr val="01327B"/>
                 </a:solidFill>
-                <a:latin typeface="Cormorant Garamond Bold"/>
-                <a:ea typeface="Cormorant Garamond Bold"/>
-                <a:cs typeface="Cormorant Garamond Bold"/>
-                <a:sym typeface="Cormorant Garamond Bold"/>
+                <a:latin typeface="Cormorant Garamond Bold" panose="00000800000000000000"/>
+                <a:ea typeface="Cormorant Garamond Bold" panose="00000800000000000000"/>
+                <a:cs typeface="Cormorant Garamond Bold" panose="00000800000000000000"/>
+                <a:sym typeface="Cormorant Garamond Bold" panose="00000800000000000000"/>
               </a:rPr>
               <a:t> {{DATE}}</a:t>
             </a:r>
@@ -18544,18 +18441,27 @@
               </a:rPr>
               <a:t>.</a:t>
             </a:r>
+            <a:endParaRPr lang="en-US" sz="1280" spc="138">
+              <a:solidFill>
+                <a:srgbClr val="01327B"/>
+              </a:solidFill>
+              <a:latin typeface="Cormorant Garamond"/>
+              <a:ea typeface="Cormorant Garamond"/>
+              <a:cs typeface="Cormorant Garamond"/>
+              <a:sym typeface="Cormorant Garamond"/>
+            </a:endParaRPr>
           </a:p>
           <a:p>
             <a:pPr algn="ctr">
               <a:lnSpc>
-                <a:spcPts val="1792"/>
+                <a:spcPts val="1790"/>
               </a:lnSpc>
             </a:pPr>
           </a:p>
           <a:p>
             <a:pPr algn="ctr">
               <a:lnSpc>
-                <a:spcPts val="1792"/>
+                <a:spcPts val="1790"/>
               </a:lnSpc>
             </a:pPr>
             <a:r>
@@ -18571,14 +18477,14 @@
               <a:t>As a member of Team</a:t>
             </a:r>
             <a:r>
-              <a:rPr lang="en-US" b="true" sz="1280" spc="138">
+              <a:rPr lang="en-US" sz="1280" b="1" spc="138">
                 <a:solidFill>
                   <a:srgbClr val="01327B"/>
                 </a:solidFill>
-                <a:latin typeface="Cormorant Garamond Bold"/>
-                <a:ea typeface="Cormorant Garamond Bold"/>
-                <a:cs typeface="Cormorant Garamond Bold"/>
-                <a:sym typeface="Cormorant Garamond Bold"/>
+                <a:latin typeface="Cormorant Garamond Bold" panose="00000800000000000000"/>
+                <a:ea typeface="Cormorant Garamond Bold" panose="00000800000000000000"/>
+                <a:cs typeface="Cormorant Garamond Bold" panose="00000800000000000000"/>
+                <a:sym typeface="Cormorant Garamond Bold" panose="00000800000000000000"/>
               </a:rPr>
               <a:t> {{TEAM NAME}}</a:t>
             </a:r>
@@ -18595,14 +18501,14 @@
               <a:t>, they contributed to the development and presentation of the innovative project </a:t>
             </a:r>
             <a:r>
-              <a:rPr lang="en-US" b="true" sz="1280" spc="138">
+              <a:rPr lang="en-US" sz="1280" b="1" spc="138">
                 <a:solidFill>
                   <a:srgbClr val="01327B"/>
                 </a:solidFill>
-                <a:latin typeface="Cormorant Garamond Bold"/>
-                <a:ea typeface="Cormorant Garamond Bold"/>
-                <a:cs typeface="Cormorant Garamond Bold"/>
-                <a:sym typeface="Cormorant Garamond Bold"/>
+                <a:latin typeface="Cormorant Garamond Bold" panose="00000800000000000000"/>
+                <a:ea typeface="Cormorant Garamond Bold" panose="00000800000000000000"/>
+                <a:cs typeface="Cormorant Garamond Bold" panose="00000800000000000000"/>
+                <a:sym typeface="Cormorant Garamond Bold" panose="00000800000000000000"/>
               </a:rPr>
               <a:t>“{{PROJECT TITLE}}”</a:t>
             </a:r>
@@ -18618,11 +18524,20 @@
               </a:rPr>
               <a:t>, demonstrating creativity, technical skills, teamwork, and problem-solving abilities.</a:t>
             </a:r>
+            <a:endParaRPr lang="en-US" sz="1280" spc="138">
+              <a:solidFill>
+                <a:srgbClr val="01327B"/>
+              </a:solidFill>
+              <a:latin typeface="Cormorant Garamond"/>
+              <a:ea typeface="Cormorant Garamond"/>
+              <a:cs typeface="Cormorant Garamond"/>
+              <a:sym typeface="Cormorant Garamond"/>
+            </a:endParaRPr>
           </a:p>
           <a:p>
             <a:pPr algn="ctr">
               <a:lnSpc>
-                <a:spcPts val="1792"/>
+                <a:spcPts val="1790"/>
               </a:lnSpc>
             </a:pPr>
           </a:p>
@@ -18630,12 +18545,12 @@
       </p:sp>
       <p:sp>
         <p:nvSpPr>
-          <p:cNvPr name="TextBox 158" id="158"/>
-          <p:cNvSpPr txBox="true"/>
+          <p:cNvPr id="155" name="TextBox 155"/>
+          <p:cNvSpPr txBox="1"/>
           <p:nvPr/>
         </p:nvSpPr>
         <p:spPr>
-          <a:xfrm rot="0">
+          <a:xfrm>
             <a:off x="4279955" y="7062276"/>
             <a:ext cx="2132090" cy="138637"/>
           </a:xfrm>
@@ -18644,18 +18559,18 @@
           </a:prstGeom>
         </p:spPr>
         <p:txBody>
-          <a:bodyPr anchor="t" rtlCol="false" tIns="0" lIns="0" bIns="0" rIns="0">
+          <a:bodyPr lIns="0" tIns="0" rIns="0" bIns="0" rtlCol="0" anchor="t">
             <a:spAutoFit/>
           </a:bodyPr>
           <a:lstStyle/>
           <a:p>
             <a:pPr algn="l">
               <a:lnSpc>
-                <a:spcPts val="1163"/>
+                <a:spcPts val="1165"/>
               </a:lnSpc>
             </a:pPr>
             <a:r>
-              <a:rPr lang="en-US" b="true" sz="830" spc="15">
+              <a:rPr lang="en-US" sz="830" b="1" spc="15">
                 <a:solidFill>
                   <a:srgbClr val="B30D3E"/>
                 </a:solidFill>
@@ -18666,17 +18581,26 @@
               </a:rPr>
               <a:t>Certificate ID.: TCEK/RD/2026/H0001    </a:t>
             </a:r>
+            <a:endParaRPr lang="en-US" sz="830" b="1" spc="15">
+              <a:solidFill>
+                <a:srgbClr val="B30D3E"/>
+              </a:solidFill>
+              <a:latin typeface="Inria Serif Bold"/>
+              <a:ea typeface="Inria Serif Bold"/>
+              <a:cs typeface="Inria Serif Bold"/>
+              <a:sym typeface="Inria Serif Bold"/>
+            </a:endParaRPr>
           </a:p>
         </p:txBody>
       </p:sp>
       <p:sp>
         <p:nvSpPr>
-          <p:cNvPr name="TextBox 159" id="159"/>
-          <p:cNvSpPr txBox="true"/>
+          <p:cNvPr id="156" name="TextBox 156"/>
+          <p:cNvSpPr txBox="1"/>
           <p:nvPr/>
         </p:nvSpPr>
         <p:spPr>
-          <a:xfrm rot="0">
+          <a:xfrm>
             <a:off x="276221" y="3867981"/>
             <a:ext cx="10206242" cy="422783"/>
           </a:xfrm>
@@ -18685,14 +18609,14 @@
           </a:prstGeom>
         </p:spPr>
         <p:txBody>
-          <a:bodyPr anchor="t" rtlCol="false" tIns="0" lIns="0" bIns="0" rIns="0">
+          <a:bodyPr lIns="0" tIns="0" rIns="0" bIns="0" rtlCol="0" anchor="t">
             <a:spAutoFit/>
           </a:bodyPr>
           <a:lstStyle/>
           <a:p>
             <a:pPr algn="ctr">
               <a:lnSpc>
-                <a:spcPts val="3472"/>
+                <a:spcPts val="3470"/>
               </a:lnSpc>
             </a:pPr>
             <a:r>
@@ -18707,6 +18631,15 @@
               </a:rPr>
               <a:t>{{PARTICIPANT NAME}} </a:t>
             </a:r>
+            <a:endParaRPr lang="en-US" sz="2480">
+              <a:solidFill>
+                <a:srgbClr val="000000"/>
+              </a:solidFill>
+              <a:latin typeface="Great Vibes"/>
+              <a:ea typeface="Great Vibes"/>
+              <a:cs typeface="Great Vibes"/>
+              <a:sym typeface="Great Vibes"/>
+            </a:endParaRPr>
           </a:p>
         </p:txBody>
       </p:sp>
@@ -18996,7 +18929,10 @@
       </a:bgFillStyleLst>
     </a:fmtScheme>
   </a:themeElements>
-  <a:objectDefaults/>
-  <a:extraClrSchemeLst/>
+  <a:extLst>
+    <a:ext uri="{05A4C25C-085E-4340-85A3-A5531E510DB2}">
+      <thm15:themeFamily xmlns:thm15="http://schemas.microsoft.com/office/thememl/2012/main" name="Office Theme" id="{62F939B6-93AF-4DB8-9C6B-D6C7DFDC589F}" vid="{4A3C46E8-61CC-4603-A589-7422A47A8E4A}"/>
+    </a:ext>
+  </a:extLst>
 </a:theme>
 </file>
</xml_diff>

<commit_message>
Deploy updated hackathon template
</commit_message>
<xml_diff>
--- a/backend/CERTIFICATE_TEMPLATE - hackathon.pptx
+++ b/backend/CERTIFICATE_TEMPLATE - hackathon.pptx
@@ -50,6 +50,13 @@
       <p:bold r:id="rId21"/>
       <p:italic r:id="rId22"/>
       <p:boldItalic r:id="rId23"/>
+    </p:embeddedFont>
+    <p:embeddedFont>
+      <p:font typeface="Cormorant Garamond" charset="0"/>
+      <p:regular r:id="rId24"/>
+      <p:bold r:id="rId25"/>
+      <p:italic r:id="rId26"/>
+      <p:boldItalic r:id="rId27"/>
     </p:embeddedFont>
   </p:embeddedFontLst>
   <p:defaultTextStyle>
@@ -18172,7 +18179,7 @@
         <p:spPr>
           <a:xfrm>
             <a:off x="893277" y="4479007"/>
-            <a:ext cx="8905445" cy="1529588"/>
+            <a:ext cx="8905445" cy="1606550"/>
           </a:xfrm>
           <a:prstGeom prst="rect">
             <a:avLst/>
@@ -18194,165 +18201,45 @@
                 <a:solidFill>
                   <a:srgbClr val="01327B"/>
                 </a:solidFill>
-                <a:latin typeface="Cormorant Garamond"/>
+                <a:latin typeface="Cormorant Garamond" charset="0"/>
                 <a:ea typeface="Cormorant Garamond"/>
-                <a:cs typeface="Cormorant Garamond"/>
+                <a:cs typeface="Cormorant Garamond" charset="0"/>
                 <a:sym typeface="Cormorant Garamond"/>
               </a:rPr>
-              <a:t>has successfully {{C</a:t>
+              <a:t>has successfully </a:t>
+            </a:r>
+            <a:r>
+              <a:rPr lang="en-US" sz="1280" b="1" spc="138">
+                <a:solidFill>
+                  <a:srgbClr val="01327B"/>
+                </a:solidFill>
+                <a:latin typeface="Cormorant Garamond" charset="0"/>
+                <a:ea typeface="Cormorant Garamond"/>
+                <a:cs typeface="Cormorant Garamond" charset="0"/>
+                <a:sym typeface="Cormorant Garamond"/>
+              </a:rPr>
+              <a:t>{{CERTIFICATE TYPE}}</a:t>
             </a:r>
             <a:r>
               <a:rPr lang="en-US" sz="1280" spc="138">
                 <a:solidFill>
                   <a:srgbClr val="01327B"/>
                 </a:solidFill>
-                <a:latin typeface="Cormorant Garamond"/>
+                <a:latin typeface="Cormorant Garamond" charset="0"/>
                 <a:ea typeface="Cormorant Garamond"/>
-                <a:cs typeface="Cormorant Garamond"/>
+                <a:cs typeface="Cormorant Garamond" charset="0"/>
                 <a:sym typeface="Cormorant Garamond"/>
               </a:rPr>
-              <a:t>E</a:t>
+              <a:t> as a</a:t>
             </a:r>
             <a:r>
               <a:rPr lang="en-US" sz="1280" spc="138">
                 <a:solidFill>
                   <a:srgbClr val="01327B"/>
                 </a:solidFill>
-                <a:latin typeface="Cormorant Garamond"/>
-                <a:ea typeface="Cormorant Garamond"/>
-                <a:cs typeface="Cormorant Garamond"/>
-                <a:sym typeface="Cormorant Garamond"/>
-              </a:rPr>
-              <a:t>RT</a:t>
-            </a:r>
-            <a:r>
-              <a:rPr lang="en-US" sz="1280" spc="138">
-                <a:solidFill>
-                  <a:srgbClr val="01327B"/>
-                </a:solidFill>
-                <a:latin typeface="Cormorant Garamond"/>
-                <a:ea typeface="Cormorant Garamond"/>
-                <a:cs typeface="Cormorant Garamond"/>
-                <a:sym typeface="Cormorant Garamond"/>
-              </a:rPr>
-              <a:t>I</a:t>
-            </a:r>
-            <a:r>
-              <a:rPr lang="en-US" sz="1280" spc="138">
-                <a:solidFill>
-                  <a:srgbClr val="01327B"/>
-                </a:solidFill>
-                <a:latin typeface="Cormorant Garamond"/>
-                <a:ea typeface="Cormorant Garamond"/>
-                <a:cs typeface="Cormorant Garamond"/>
-                <a:sym typeface="Cormorant Garamond"/>
-              </a:rPr>
-              <a:t>F</a:t>
-            </a:r>
-            <a:r>
-              <a:rPr lang="en-US" sz="1280" spc="138">
-                <a:solidFill>
-                  <a:srgbClr val="01327B"/>
-                </a:solidFill>
-                <a:latin typeface="Cormorant Garamond"/>
-                <a:ea typeface="Cormorant Garamond"/>
-                <a:cs typeface="Cormorant Garamond"/>
-                <a:sym typeface="Cormorant Garamond"/>
-              </a:rPr>
-              <a:t>I</a:t>
-            </a:r>
-            <a:r>
-              <a:rPr lang="en-US" sz="1280" spc="138">
-                <a:solidFill>
-                  <a:srgbClr val="01327B"/>
-                </a:solidFill>
-                <a:latin typeface="Cormorant Garamond"/>
-                <a:ea typeface="Cormorant Garamond"/>
-                <a:cs typeface="Cormorant Garamond"/>
-                <a:sym typeface="Cormorant Garamond"/>
-              </a:rPr>
-              <a:t>CATE</a:t>
-            </a:r>
-            <a:r>
-              <a:rPr lang="en-US" sz="1280" spc="138">
-                <a:solidFill>
-                  <a:srgbClr val="01327B"/>
-                </a:solidFill>
-                <a:latin typeface="Cormorant Garamond"/>
-                <a:ea typeface="Cormorant Garamond"/>
-                <a:cs typeface="Cormorant Garamond"/>
-                <a:sym typeface="Cormorant Garamond"/>
-              </a:rPr>
-              <a:t> </a:t>
-            </a:r>
-            <a:r>
-              <a:rPr lang="en-US" sz="1280" spc="138">
-                <a:solidFill>
-                  <a:srgbClr val="01327B"/>
-                </a:solidFill>
-                <a:latin typeface="Cormorant Garamond"/>
-                <a:ea typeface="Cormorant Garamond"/>
-                <a:cs typeface="Cormorant Garamond"/>
-                <a:sym typeface="Cormorant Garamond"/>
-              </a:rPr>
-              <a:t>TYPE}} </a:t>
-            </a:r>
-            <a:r>
-              <a:rPr lang="en-US" sz="1280" spc="138">
-                <a:solidFill>
-                  <a:srgbClr val="01327B"/>
-                </a:solidFill>
-                <a:latin typeface="Cormorant Garamond"/>
-                <a:ea typeface="Cormorant Garamond"/>
-                <a:cs typeface="Cormorant Garamond"/>
-                <a:sym typeface="Cormorant Garamond"/>
-              </a:rPr>
-              <a:t>a</a:t>
-            </a:r>
-            <a:r>
-              <a:rPr lang="en-US" sz="1280" spc="138">
-                <a:solidFill>
-                  <a:srgbClr val="01327B"/>
-                </a:solidFill>
-                <a:latin typeface="Cormorant Garamond"/>
-                <a:ea typeface="Cormorant Garamond"/>
-                <a:cs typeface="Cormorant Garamond"/>
-                <a:sym typeface="Cormorant Garamond"/>
-              </a:rPr>
-              <a:t>s</a:t>
-            </a:r>
-            <a:r>
-              <a:rPr lang="en-US" sz="1280" spc="138">
-                <a:solidFill>
-                  <a:srgbClr val="01327B"/>
-                </a:solidFill>
-                <a:latin typeface="Cormorant Garamond"/>
-                <a:ea typeface="Cormorant Garamond"/>
-                <a:cs typeface="Cormorant Garamond"/>
-                <a:sym typeface="Cormorant Garamond"/>
-              </a:rPr>
-              <a:t> </a:t>
-            </a:r>
-            <a:r>
-              <a:rPr lang="en-US" sz="1280" spc="138">
-                <a:solidFill>
-                  <a:srgbClr val="01327B"/>
-                </a:solidFill>
-                <a:latin typeface="Cormorant Garamond"/>
-                <a:ea typeface="Cormorant Garamond"/>
-                <a:cs typeface="Cormorant Garamond"/>
-                <a:sym typeface="Cormorant Garamond"/>
-              </a:rPr>
-              <a:t>a</a:t>
-            </a:r>
-            <a:r>
-              <a:rPr lang="en-US" sz="1280" b="1" spc="138">
-                <a:solidFill>
-                  <a:srgbClr val="01327B"/>
-                </a:solidFill>
-                <a:latin typeface="Cormorant Garamond Bold" panose="00000800000000000000"/>
+                <a:latin typeface="Cormorant Garamond" charset="0"/>
                 <a:ea typeface="Cormorant Garamond Bold" panose="00000800000000000000"/>
-                <a:cs typeface="Cormorant Garamond Bold" panose="00000800000000000000"/>
+                <a:cs typeface="Cormorant Garamond" charset="0"/>
                 <a:sym typeface="Cormorant Garamond Bold" panose="00000800000000000000"/>
               </a:rPr>
               <a:t> {{ROLE}}</a:t>
@@ -18362,21 +18249,33 @@
                 <a:solidFill>
                   <a:srgbClr val="01327B"/>
                 </a:solidFill>
-                <a:latin typeface="Cormorant Garamond"/>
+                <a:latin typeface="Cormorant Garamond" charset="0"/>
                 <a:ea typeface="Cormorant Garamond"/>
-                <a:cs typeface="Cormorant Garamond"/>
+                <a:cs typeface="Cormorant Garamond" charset="0"/>
                 <a:sym typeface="Cormorant Garamond"/>
               </a:rPr>
-              <a:t> in the </a:t>
+              <a:t> in the</a:t>
             </a:r>
             <a:r>
               <a:rPr lang="en-US" sz="1280" b="1" spc="138">
                 <a:solidFill>
                   <a:srgbClr val="01327B"/>
                 </a:solidFill>
-                <a:latin typeface="Cormorant Garamond Bold" panose="00000800000000000000"/>
+                <a:latin typeface="Cormorant Garamond" charset="0"/>
+                <a:ea typeface="Cormorant Garamond"/>
+                <a:cs typeface="Cormorant Garamond" charset="0"/>
+                <a:sym typeface="Cormorant Garamond"/>
+              </a:rPr>
+              <a:t> </a:t>
+            </a:r>
+            <a:r>
+              <a:rPr lang="en-US" sz="1280" b="1" spc="138">
+                <a:solidFill>
+                  <a:srgbClr val="01327B"/>
+                </a:solidFill>
+                <a:latin typeface="Cormorant Garamond" charset="0"/>
                 <a:ea typeface="Cormorant Garamond Bold" panose="00000800000000000000"/>
-                <a:cs typeface="Cormorant Garamond Bold" panose="00000800000000000000"/>
+                <a:cs typeface="Cormorant Garamond" charset="0"/>
                 <a:sym typeface="Cormorant Garamond Bold" panose="00000800000000000000"/>
               </a:rPr>
               <a:t>{{HACKATHON NAME}},</a:t>
@@ -18386,57 +18285,93 @@
                 <a:solidFill>
                   <a:srgbClr val="01327B"/>
                 </a:solidFill>
-                <a:latin typeface="Cormorant Garamond"/>
+                <a:latin typeface="Cormorant Garamond" charset="0"/>
                 <a:ea typeface="Cormorant Garamond"/>
-                <a:cs typeface="Cormorant Garamond"/>
+                <a:cs typeface="Cormorant Garamond" charset="0"/>
                 <a:sym typeface="Cormorant Garamond"/>
               </a:rPr>
-              <a:t> organized by </a:t>
+              <a:t> organized by</a:t>
             </a:r>
             <a:r>
               <a:rPr lang="en-US" sz="1280" b="1" spc="138">
                 <a:solidFill>
                   <a:srgbClr val="01327B"/>
                 </a:solidFill>
-                <a:latin typeface="Cormorant Garamond Bold" panose="00000800000000000000"/>
+                <a:latin typeface="Cormorant Garamond" charset="0"/>
+                <a:ea typeface="Cormorant Garamond"/>
+                <a:cs typeface="Cormorant Garamond" charset="0"/>
+                <a:sym typeface="Cormorant Garamond"/>
+              </a:rPr>
+              <a:t> </a:t>
+            </a:r>
+            <a:r>
+              <a:rPr lang="en-US" sz="1280" b="1" spc="138">
+                <a:solidFill>
+                  <a:srgbClr val="01327B"/>
+                </a:solidFill>
+                <a:latin typeface="Cormorant Garamond" charset="0"/>
                 <a:ea typeface="Cormorant Garamond Bold" panose="00000800000000000000"/>
-                <a:cs typeface="Cormorant Garamond Bold" panose="00000800000000000000"/>
+                <a:cs typeface="Cormorant Garamond" charset="0"/>
                 <a:sym typeface="Cormorant Garamond Bold" panose="00000800000000000000"/>
               </a:rPr>
               <a:t>Trinity College of Engineering and Technology (Autonomous), Peddapalli</a:t>
+            </a:r>
+            <a:r>
+              <a:rPr lang="en-US" sz="1280" b="1" spc="138">
+                <a:solidFill>
+                  <a:srgbClr val="01327B"/>
+                </a:solidFill>
+                <a:latin typeface="Cormorant Garamond" charset="0"/>
+                <a:ea typeface="Cormorant Garamond"/>
+                <a:cs typeface="Cormorant Garamond" charset="0"/>
+                <a:sym typeface="Cormorant Garamond"/>
+              </a:rPr>
+              <a:t>, </a:t>
             </a:r>
             <a:r>
               <a:rPr lang="en-US" sz="1280" spc="138">
                 <a:solidFill>
                   <a:srgbClr val="01327B"/>
                 </a:solidFill>
-                <a:latin typeface="Cormorant Garamond"/>
+                <a:latin typeface="Cormorant Garamond" charset="0"/>
                 <a:ea typeface="Cormorant Garamond"/>
-                <a:cs typeface="Cormorant Garamond"/>
+                <a:cs typeface="Cormorant Garamond" charset="0"/>
                 <a:sym typeface="Cormorant Garamond"/>
               </a:rPr>
-              <a:t>, held on</a:t>
+              <a:t>held on</a:t>
+            </a:r>
+            <a:r>
+              <a:rPr lang="en-US" sz="1280" spc="138">
+                <a:solidFill>
+                  <a:srgbClr val="01327B"/>
+                </a:solidFill>
+                <a:latin typeface="Cormorant Garamond" charset="0"/>
+                <a:ea typeface="Cormorant Garamond Bold" panose="00000800000000000000"/>
+                <a:cs typeface="Cormorant Garamond" charset="0"/>
+                <a:sym typeface="Cormorant Garamond Bold" panose="00000800000000000000"/>
+              </a:rPr>
+              <a:t> </a:t>
             </a:r>
             <a:r>
               <a:rPr lang="en-US" sz="1280" b="1" spc="138">
                 <a:solidFill>
                   <a:srgbClr val="01327B"/>
                 </a:solidFill>
-                <a:latin typeface="Cormorant Garamond Bold" panose="00000800000000000000"/>
+                <a:latin typeface="Cormorant Garamond" charset="0"/>
                 <a:ea typeface="Cormorant Garamond Bold" panose="00000800000000000000"/>
-                <a:cs typeface="Cormorant Garamond Bold" panose="00000800000000000000"/>
+                <a:cs typeface="Cormorant Garamond" charset="0"/>
                 <a:sym typeface="Cormorant Garamond Bold" panose="00000800000000000000"/>
               </a:rPr>
-              <a:t> {{DATE}}</a:t>
+              <a:t>{{DATE}}</a:t>
             </a:r>
             <a:r>
               <a:rPr lang="en-US" sz="1280" spc="138">
                 <a:solidFill>
                   <a:srgbClr val="01327B"/>
                 </a:solidFill>
-                <a:latin typeface="Cormorant Garamond"/>
+                <a:latin typeface="Cormorant Garamond" charset="0"/>
                 <a:ea typeface="Cormorant Garamond"/>
-                <a:cs typeface="Cormorant Garamond"/>
+                <a:cs typeface="Cormorant Garamond" charset="0"/>
                 <a:sym typeface="Cormorant Garamond"/>
               </a:rPr>
               <a:t>.</a:t>
@@ -18445,9 +18380,9 @@
               <a:solidFill>
                 <a:srgbClr val="01327B"/>
               </a:solidFill>
-              <a:latin typeface="Cormorant Garamond"/>
+              <a:latin typeface="Cormorant Garamond" charset="0"/>
               <a:ea typeface="Cormorant Garamond"/>
-              <a:cs typeface="Cormorant Garamond"/>
+              <a:cs typeface="Cormorant Garamond" charset="0"/>
               <a:sym typeface="Cormorant Garamond"/>
             </a:endParaRPr>
           </a:p>
@@ -18457,6 +18392,10 @@
                 <a:spcPts val="1790"/>
               </a:lnSpc>
             </a:pPr>
+            <a:endParaRPr>
+              <a:latin typeface="Cormorant Garamond" charset="0"/>
+              <a:cs typeface="Cormorant Garamond" charset="0"/>
+            </a:endParaRPr>
           </a:p>
           <a:p>
             <a:pPr algn="ctr">
@@ -18469,68 +18408,104 @@
                 <a:solidFill>
                   <a:srgbClr val="01327B"/>
                 </a:solidFill>
-                <a:latin typeface="Cormorant Garamond"/>
+                <a:latin typeface="Cormorant Garamond" charset="0"/>
                 <a:ea typeface="Cormorant Garamond"/>
-                <a:cs typeface="Cormorant Garamond"/>
+                <a:cs typeface="Cormorant Garamond" charset="0"/>
                 <a:sym typeface="Cormorant Garamond"/>
               </a:rPr>
               <a:t>As a member of Team</a:t>
+            </a:r>
+            <a:r>
+              <a:rPr lang="en-US" sz="1280" spc="138">
+                <a:solidFill>
+                  <a:srgbClr val="01327B"/>
+                </a:solidFill>
+                <a:latin typeface="Cormorant Garamond" charset="0"/>
+                <a:ea typeface="Cormorant Garamond Bold" panose="00000800000000000000"/>
+                <a:cs typeface="Cormorant Garamond" charset="0"/>
+                <a:sym typeface="Cormorant Garamond Bold" panose="00000800000000000000"/>
+              </a:rPr>
+              <a:t> </a:t>
             </a:r>
             <a:r>
               <a:rPr lang="en-US" sz="1280" b="1" spc="138">
                 <a:solidFill>
                   <a:srgbClr val="01327B"/>
                 </a:solidFill>
-                <a:latin typeface="Cormorant Garamond Bold" panose="00000800000000000000"/>
+                <a:latin typeface="Cormorant Garamond" charset="0"/>
                 <a:ea typeface="Cormorant Garamond Bold" panose="00000800000000000000"/>
-                <a:cs typeface="Cormorant Garamond Bold" panose="00000800000000000000"/>
+                <a:cs typeface="Cormorant Garamond" charset="0"/>
                 <a:sym typeface="Cormorant Garamond Bold" panose="00000800000000000000"/>
               </a:rPr>
-              <a:t> {{TEAM NAME}}</a:t>
+              <a:t>{{TEAM NAME}}</a:t>
+            </a:r>
+            <a:r>
+              <a:rPr lang="en-US" sz="1280" b="1" spc="138">
+                <a:solidFill>
+                  <a:srgbClr val="01327B"/>
+                </a:solidFill>
+                <a:latin typeface="Cormorant Garamond" charset="0"/>
+                <a:ea typeface="Cormorant Garamond"/>
+                <a:cs typeface="Cormorant Garamond" charset="0"/>
+                <a:sym typeface="Cormorant Garamond"/>
+              </a:rPr>
+              <a:t>,</a:t>
             </a:r>
             <a:r>
               <a:rPr lang="en-US" sz="1280" spc="138">
                 <a:solidFill>
                   <a:srgbClr val="01327B"/>
                 </a:solidFill>
-                <a:latin typeface="Cormorant Garamond"/>
+                <a:latin typeface="Cormorant Garamond" charset="0"/>
                 <a:ea typeface="Cormorant Garamond"/>
-                <a:cs typeface="Cormorant Garamond"/>
+                <a:cs typeface="Cormorant Garamond" charset="0"/>
                 <a:sym typeface="Cormorant Garamond"/>
               </a:rPr>
-              <a:t>, they contributed to the development and presentation of the innovative project </a:t>
+              <a:t> they contributed to the development and presentation of the innovative project </a:t>
             </a:r>
             <a:r>
               <a:rPr lang="en-US" sz="1280" b="1" spc="138">
                 <a:solidFill>
                   <a:srgbClr val="01327B"/>
                 </a:solidFill>
-                <a:latin typeface="Cormorant Garamond Bold" panose="00000800000000000000"/>
+                <a:latin typeface="Cormorant Garamond" charset="0"/>
                 <a:ea typeface="Cormorant Garamond Bold" panose="00000800000000000000"/>
-                <a:cs typeface="Cormorant Garamond Bold" panose="00000800000000000000"/>
+                <a:cs typeface="Cormorant Garamond" charset="0"/>
                 <a:sym typeface="Cormorant Garamond Bold" panose="00000800000000000000"/>
               </a:rPr>
               <a:t>“{{PROJECT TITLE}}”</a:t>
+            </a:r>
+            <a:r>
+              <a:rPr lang="en-US" sz="1280" b="1" spc="138">
+                <a:solidFill>
+                  <a:srgbClr val="01327B"/>
+                </a:solidFill>
+                <a:latin typeface="Cormorant Garamond" charset="0"/>
+                <a:ea typeface="Cormorant Garamond"/>
+                <a:cs typeface="Cormorant Garamond" charset="0"/>
+                <a:sym typeface="Cormorant Garamond"/>
+              </a:rPr>
+              <a:t>,</a:t>
             </a:r>
             <a:r>
               <a:rPr lang="en-US" sz="1280" spc="138">
                 <a:solidFill>
                   <a:srgbClr val="01327B"/>
                 </a:solidFill>
-                <a:latin typeface="Cormorant Garamond"/>
+                <a:latin typeface="Cormorant Garamond" charset="0"/>
                 <a:ea typeface="Cormorant Garamond"/>
-                <a:cs typeface="Cormorant Garamond"/>
+                <a:cs typeface="Cormorant Garamond" charset="0"/>
                 <a:sym typeface="Cormorant Garamond"/>
               </a:rPr>
-              <a:t>, demonstrating creativity, technical skills, teamwork, and problem-solving abilities.</a:t>
+              <a:t> demonstrating creativity, technical skills, teamwork, and problem-solving abilities.</a:t>
             </a:r>
             <a:endParaRPr lang="en-US" sz="1280" spc="138">
               <a:solidFill>
                 <a:srgbClr val="01327B"/>
               </a:solidFill>
-              <a:latin typeface="Cormorant Garamond"/>
+              <a:latin typeface="Cormorant Garamond" charset="0"/>
               <a:ea typeface="Cormorant Garamond"/>
-              <a:cs typeface="Cormorant Garamond"/>
+              <a:cs typeface="Cormorant Garamond" charset="0"/>
               <a:sym typeface="Cormorant Garamond"/>
             </a:endParaRPr>
           </a:p>
@@ -18540,6 +18515,10 @@
                 <a:spcPts val="1790"/>
               </a:lnSpc>
             </a:pPr>
+            <a:endParaRPr>
+              <a:latin typeface="Cormorant Garamond" charset="0"/>
+              <a:cs typeface="Cormorant Garamond" charset="0"/>
+            </a:endParaRPr>
           </a:p>
         </p:txBody>
       </p:sp>
@@ -18602,7 +18581,7 @@
         <p:spPr>
           <a:xfrm>
             <a:off x="276221" y="3867981"/>
-            <a:ext cx="10206242" cy="422783"/>
+            <a:ext cx="10206242" cy="444500"/>
           </a:xfrm>
           <a:prstGeom prst="rect">
             <a:avLst/>
@@ -18629,7 +18608,31 @@
                 <a:cs typeface="Great Vibes"/>
                 <a:sym typeface="Great Vibes"/>
               </a:rPr>
-              <a:t>{{PARTICIPANT NAME}} </a:t>
+              <a:t>{{</a:t>
+            </a:r>
+            <a:r>
+              <a:rPr lang="en-US" sz="3600">
+                <a:solidFill>
+                  <a:srgbClr val="000000"/>
+                </a:solidFill>
+                <a:latin typeface="Great Vibes"/>
+                <a:ea typeface="Great Vibes"/>
+                <a:cs typeface="Great Vibes"/>
+                <a:sym typeface="Great Vibes"/>
+              </a:rPr>
+              <a:t>PARTICIPANT </a:t>
+            </a:r>
+            <a:r>
+              <a:rPr lang="en-US" sz="2480">
+                <a:solidFill>
+                  <a:srgbClr val="000000"/>
+                </a:solidFill>
+                <a:latin typeface="Great Vibes"/>
+                <a:ea typeface="Great Vibes"/>
+                <a:cs typeface="Great Vibes"/>
+                <a:sym typeface="Great Vibes"/>
+              </a:rPr>
+              <a:t>NAME}} </a:t>
             </a:r>
             <a:endParaRPr lang="en-US" sz="2480">
               <a:solidFill>

</xml_diff>

<commit_message>
Deploy latest template updates
</commit_message>
<xml_diff>
--- a/backend/CERTIFICATE_TEMPLATE - hackathon.pptx
+++ b/backend/CERTIFICATE_TEMPLATE - hackathon.pptx
@@ -30,33 +30,40 @@
       <p:regular r:id="rId13"/>
     </p:embeddedFont>
     <p:embeddedFont>
-      <p:font typeface="Cormorant Garamond"/>
+      <p:font typeface="Cormorant Garamond" charset="0"/>
       <p:regular r:id="rId14"/>
       <p:bold r:id="rId15"/>
       <p:italic r:id="rId16"/>
       <p:boldItalic r:id="rId17"/>
     </p:embeddedFont>
     <p:embeddedFont>
+      <p:font typeface="Cormorant Garamond"/>
+      <p:regular r:id="rId18"/>
+      <p:bold r:id="rId19"/>
+      <p:italic r:id="rId20"/>
+      <p:boldItalic r:id="rId21"/>
+    </p:embeddedFont>
+    <p:embeddedFont>
       <p:font typeface="Cormorant Garamond Bold" panose="00000800000000000000"/>
-      <p:bold r:id="rId18"/>
+      <p:bold r:id="rId22"/>
     </p:embeddedFont>
     <p:embeddedFont>
       <p:font typeface="Great Vibes"/>
-      <p:regular r:id="rId19"/>
+      <p:regular r:id="rId23"/>
     </p:embeddedFont>
     <p:embeddedFont>
       <p:font typeface="Calibri" panose="020F0502020204030204" charset="0"/>
-      <p:regular r:id="rId20"/>
-      <p:bold r:id="rId21"/>
-      <p:italic r:id="rId22"/>
-      <p:boldItalic r:id="rId23"/>
-    </p:embeddedFont>
-    <p:embeddedFont>
-      <p:font typeface="Cormorant Garamond" charset="0"/>
       <p:regular r:id="rId24"/>
       <p:bold r:id="rId25"/>
       <p:italic r:id="rId26"/>
       <p:boldItalic r:id="rId27"/>
+    </p:embeddedFont>
+    <p:embeddedFont>
+      <p:font typeface="Palatino Linotype" panose="02040502050505030304" charset="0"/>
+      <p:regular r:id="rId28"/>
+      <p:bold r:id="rId29"/>
+      <p:italic r:id="rId30"/>
+      <p:boldItalic r:id="rId31"/>
     </p:embeddedFont>
   </p:embeddedFontLst>
   <p:defaultTextStyle>
@@ -157,7 +164,7 @@
   <p:extLst>
     <p:ext uri="{EFAFB233-063F-42B5-8137-9DF3F51BA10A}">
       <p15:sldGuideLst xmlns:p15="http://schemas.microsoft.com/office/powerpoint/2012/main">
-        <p15:guide id="1" orient="horz" pos="2160" userDrawn="1">
+        <p15:guide id="1" orient="horz" pos="2154" userDrawn="1">
           <p15:clr>
             <a:srgbClr val="A4A3A4"/>
           </p15:clr>
@@ -17417,7 +17424,7 @@
         </p:nvSpPr>
         <p:spPr>
           <a:xfrm flipV="1">
-            <a:off x="2381886" y="4392938"/>
+            <a:off x="2381886" y="4164338"/>
             <a:ext cx="5928227" cy="0"/>
           </a:xfrm>
           <a:prstGeom prst="line">
@@ -18029,7 +18036,7 @@
         <p:spPr>
           <a:xfrm>
             <a:off x="1574763" y="1849951"/>
-            <a:ext cx="7542474" cy="1109953"/>
+            <a:ext cx="7542474" cy="1040765"/>
           </a:xfrm>
           <a:prstGeom prst="rect">
             <a:avLst/>
@@ -18051,9 +18058,9 @@
                 <a:solidFill>
                   <a:srgbClr val="01327B"/>
                 </a:solidFill>
-                <a:latin typeface="Palatino Bold" panose="02040702050505030304"/>
+                <a:latin typeface="Palatino Linotype" panose="02040502050505030304" charset="0"/>
                 <a:ea typeface="Palatino Bold" panose="02040702050505030304"/>
-                <a:cs typeface="Palatino Bold" panose="02040702050505030304"/>
+                <a:cs typeface="Palatino Linotype" panose="02040502050505030304" charset="0"/>
                 <a:sym typeface="Palatino Bold" panose="02040702050505030304"/>
               </a:rPr>
               <a:t>CERTIFICATE</a:t>
@@ -18062,60 +18069,10 @@
               <a:solidFill>
                 <a:srgbClr val="01327B"/>
               </a:solidFill>
-              <a:latin typeface="Palatino Bold" panose="02040702050505030304"/>
+              <a:latin typeface="Palatino Linotype" panose="02040502050505030304" charset="0"/>
               <a:ea typeface="Palatino Bold" panose="02040702050505030304"/>
-              <a:cs typeface="Palatino Bold" panose="02040702050505030304"/>
+              <a:cs typeface="Palatino Linotype" panose="02040502050505030304" charset="0"/>
               <a:sym typeface="Palatino Bold" panose="02040702050505030304"/>
-            </a:endParaRPr>
-          </a:p>
-        </p:txBody>
-      </p:sp>
-      <p:sp>
-        <p:nvSpPr>
-          <p:cNvPr id="152" name="TextBox 152"/>
-          <p:cNvSpPr txBox="1"/>
-          <p:nvPr/>
-        </p:nvSpPr>
-        <p:spPr>
-          <a:xfrm>
-            <a:off x="1574763" y="2760981"/>
-            <a:ext cx="7542474" cy="422275"/>
-          </a:xfrm>
-          <a:prstGeom prst="rect">
-            <a:avLst/>
-          </a:prstGeom>
-        </p:spPr>
-        <p:txBody>
-          <a:bodyPr lIns="0" tIns="0" rIns="0" bIns="0" rtlCol="0" anchor="t">
-            <a:spAutoFit/>
-          </a:bodyPr>
-          <a:lstStyle/>
-          <a:p>
-            <a:pPr algn="ctr">
-              <a:lnSpc>
-                <a:spcPts val="3500"/>
-              </a:lnSpc>
-            </a:pPr>
-            <a:r>
-              <a:rPr lang="en-US" sz="2500" b="1" spc="1299">
-                <a:solidFill>
-                  <a:srgbClr val="01327B"/>
-                </a:solidFill>
-                <a:latin typeface="Inria Serif Bold"/>
-                <a:ea typeface="Inria Serif Bold"/>
-                <a:cs typeface="Inria Serif Bold"/>
-                <a:sym typeface="Inria Serif Bold"/>
-              </a:rPr>
-              <a:t>OF Participation</a:t>
-            </a:r>
-            <a:endParaRPr lang="en-US" sz="2500" b="1" spc="1299">
-              <a:solidFill>
-                <a:srgbClr val="01327B"/>
-              </a:solidFill>
-              <a:latin typeface="Inria Serif Bold"/>
-              <a:ea typeface="Inria Serif Bold"/>
-              <a:cs typeface="Inria Serif Bold"/>
-              <a:sym typeface="Inria Serif Bold"/>
             </a:endParaRPr>
           </a:p>
         </p:txBody>
@@ -18128,7 +18085,7 @@
         </p:nvSpPr>
         <p:spPr>
           <a:xfrm>
-            <a:off x="1689892" y="3286956"/>
+            <a:off x="1608105" y="2940246"/>
             <a:ext cx="7542474" cy="266700"/>
           </a:xfrm>
           <a:prstGeom prst="rect">
@@ -18178,7 +18135,7 @@
         </p:nvSpPr>
         <p:spPr>
           <a:xfrm>
-            <a:off x="893277" y="4479007"/>
+            <a:off x="926619" y="4250407"/>
             <a:ext cx="8905445" cy="1606550"/>
           </a:xfrm>
           <a:prstGeom prst="rect">
@@ -18580,7 +18537,7 @@
         </p:nvSpPr>
         <p:spPr>
           <a:xfrm>
-            <a:off x="276221" y="3867981"/>
+            <a:off x="276221" y="3639381"/>
             <a:ext cx="10206242" cy="444500"/>
           </a:xfrm>
           <a:prstGeom prst="rect">

</xml_diff>

<commit_message>
Deploy latest template updates from PowerPoint
</commit_message>
<xml_diff>
--- a/backend/CERTIFICATE_TEMPLATE - hackathon.pptx
+++ b/backend/CERTIFICATE_TEMPLATE - hackathon.pptx
@@ -30,40 +30,26 @@
       <p:regular r:id="rId13"/>
     </p:embeddedFont>
     <p:embeddedFont>
-      <p:font typeface="Cormorant Garamond" charset="0"/>
+      <p:font typeface="Cormorant Garamond"/>
       <p:regular r:id="rId14"/>
       <p:bold r:id="rId15"/>
       <p:italic r:id="rId16"/>
       <p:boldItalic r:id="rId17"/>
     </p:embeddedFont>
     <p:embeddedFont>
-      <p:font typeface="Cormorant Garamond"/>
-      <p:regular r:id="rId18"/>
-      <p:bold r:id="rId19"/>
-      <p:italic r:id="rId20"/>
-      <p:boldItalic r:id="rId21"/>
-    </p:embeddedFont>
-    <p:embeddedFont>
       <p:font typeface="Cormorant Garamond Bold" panose="00000800000000000000"/>
-      <p:bold r:id="rId22"/>
+      <p:bold r:id="rId18"/>
     </p:embeddedFont>
     <p:embeddedFont>
       <p:font typeface="Great Vibes"/>
-      <p:regular r:id="rId23"/>
+      <p:regular r:id="rId19"/>
     </p:embeddedFont>
     <p:embeddedFont>
       <p:font typeface="Calibri" panose="020F0502020204030204" charset="0"/>
-      <p:regular r:id="rId24"/>
-      <p:bold r:id="rId25"/>
-      <p:italic r:id="rId26"/>
-      <p:boldItalic r:id="rId27"/>
-    </p:embeddedFont>
-    <p:embeddedFont>
-      <p:font typeface="Palatino Linotype" panose="02040502050505030304" charset="0"/>
-      <p:regular r:id="rId28"/>
-      <p:bold r:id="rId29"/>
-      <p:italic r:id="rId30"/>
-      <p:boldItalic r:id="rId31"/>
+      <p:regular r:id="rId20"/>
+      <p:bold r:id="rId21"/>
+      <p:italic r:id="rId22"/>
+      <p:boldItalic r:id="rId23"/>
     </p:embeddedFont>
   </p:embeddedFontLst>
   <p:defaultTextStyle>
@@ -164,7 +150,7 @@
   <p:extLst>
     <p:ext uri="{EFAFB233-063F-42B5-8137-9DF3F51BA10A}">
       <p15:sldGuideLst xmlns:p15="http://schemas.microsoft.com/office/powerpoint/2012/main">
-        <p15:guide id="1" orient="horz" pos="2154" userDrawn="1">
+        <p15:guide id="1" orient="horz" pos="2160" userDrawn="1">
           <p15:clr>
             <a:srgbClr val="A4A3A4"/>
           </p15:clr>
@@ -17424,7 +17410,7 @@
         </p:nvSpPr>
         <p:spPr>
           <a:xfrm flipV="1">
-            <a:off x="2381886" y="4164338"/>
+            <a:off x="2381886" y="4392938"/>
             <a:ext cx="5928227" cy="0"/>
           </a:xfrm>
           <a:prstGeom prst="line">
@@ -18036,7 +18022,7 @@
         <p:spPr>
           <a:xfrm>
             <a:off x="1574763" y="1849951"/>
-            <a:ext cx="7542474" cy="1040765"/>
+            <a:ext cx="7542474" cy="1109953"/>
           </a:xfrm>
           <a:prstGeom prst="rect">
             <a:avLst/>
@@ -18058,9 +18044,9 @@
                 <a:solidFill>
                   <a:srgbClr val="01327B"/>
                 </a:solidFill>
-                <a:latin typeface="Palatino Linotype" panose="02040502050505030304" charset="0"/>
+                <a:latin typeface="Palatino Bold" panose="02040702050505030304"/>
                 <a:ea typeface="Palatino Bold" panose="02040702050505030304"/>
-                <a:cs typeface="Palatino Linotype" panose="02040502050505030304" charset="0"/>
+                <a:cs typeface="Palatino Bold" panose="02040702050505030304"/>
                 <a:sym typeface="Palatino Bold" panose="02040702050505030304"/>
               </a:rPr>
               <a:t>CERTIFICATE</a:t>
@@ -18069,10 +18055,60 @@
               <a:solidFill>
                 <a:srgbClr val="01327B"/>
               </a:solidFill>
-              <a:latin typeface="Palatino Linotype" panose="02040502050505030304" charset="0"/>
+              <a:latin typeface="Palatino Bold" panose="02040702050505030304"/>
               <a:ea typeface="Palatino Bold" panose="02040702050505030304"/>
-              <a:cs typeface="Palatino Linotype" panose="02040502050505030304" charset="0"/>
+              <a:cs typeface="Palatino Bold" panose="02040702050505030304"/>
               <a:sym typeface="Palatino Bold" panose="02040702050505030304"/>
+            </a:endParaRPr>
+          </a:p>
+        </p:txBody>
+      </p:sp>
+      <p:sp>
+        <p:nvSpPr>
+          <p:cNvPr id="152" name="TextBox 152"/>
+          <p:cNvSpPr txBox="1"/>
+          <p:nvPr/>
+        </p:nvSpPr>
+        <p:spPr>
+          <a:xfrm>
+            <a:off x="1574763" y="2760981"/>
+            <a:ext cx="7542474" cy="422275"/>
+          </a:xfrm>
+          <a:prstGeom prst="rect">
+            <a:avLst/>
+          </a:prstGeom>
+        </p:spPr>
+        <p:txBody>
+          <a:bodyPr lIns="0" tIns="0" rIns="0" bIns="0" rtlCol="0" anchor="t">
+            <a:spAutoFit/>
+          </a:bodyPr>
+          <a:lstStyle/>
+          <a:p>
+            <a:pPr algn="ctr">
+              <a:lnSpc>
+                <a:spcPts val="3500"/>
+              </a:lnSpc>
+            </a:pPr>
+            <a:r>
+              <a:rPr lang="en-US" sz="2500" b="1" spc="1299">
+                <a:solidFill>
+                  <a:srgbClr val="01327B"/>
+                </a:solidFill>
+                <a:latin typeface="Inria Serif Bold"/>
+                <a:ea typeface="Inria Serif Bold"/>
+                <a:cs typeface="Inria Serif Bold"/>
+                <a:sym typeface="Inria Serif Bold"/>
+              </a:rPr>
+              <a:t>OF Participation</a:t>
+            </a:r>
+            <a:endParaRPr lang="en-US" sz="2500" b="1" spc="1299">
+              <a:solidFill>
+                <a:srgbClr val="01327B"/>
+              </a:solidFill>
+              <a:latin typeface="Inria Serif Bold"/>
+              <a:ea typeface="Inria Serif Bold"/>
+              <a:cs typeface="Inria Serif Bold"/>
+              <a:sym typeface="Inria Serif Bold"/>
             </a:endParaRPr>
           </a:p>
         </p:txBody>
@@ -18085,7 +18121,7 @@
         </p:nvSpPr>
         <p:spPr>
           <a:xfrm>
-            <a:off x="1608105" y="2940246"/>
+            <a:off x="1689892" y="3286956"/>
             <a:ext cx="7542474" cy="266700"/>
           </a:xfrm>
           <a:prstGeom prst="rect">
@@ -18135,8 +18171,8 @@
         </p:nvSpPr>
         <p:spPr>
           <a:xfrm>
-            <a:off x="926619" y="4250407"/>
-            <a:ext cx="8905445" cy="1606550"/>
+            <a:off x="893277" y="4479007"/>
+            <a:ext cx="8905445" cy="1529588"/>
           </a:xfrm>
           <a:prstGeom prst="rect">
             <a:avLst/>
@@ -18158,45 +18194,165 @@
                 <a:solidFill>
                   <a:srgbClr val="01327B"/>
                 </a:solidFill>
-                <a:latin typeface="Cormorant Garamond" charset="0"/>
+                <a:latin typeface="Cormorant Garamond"/>
                 <a:ea typeface="Cormorant Garamond"/>
-                <a:cs typeface="Cormorant Garamond" charset="0"/>
+                <a:cs typeface="Cormorant Garamond"/>
                 <a:sym typeface="Cormorant Garamond"/>
               </a:rPr>
-              <a:t>has successfully </a:t>
+              <a:t>has successfully {{C</a:t>
+            </a:r>
+            <a:r>
+              <a:rPr lang="en-US" sz="1280" spc="138">
+                <a:solidFill>
+                  <a:srgbClr val="01327B"/>
+                </a:solidFill>
+                <a:latin typeface="Cormorant Garamond"/>
+                <a:ea typeface="Cormorant Garamond"/>
+                <a:cs typeface="Cormorant Garamond"/>
+                <a:sym typeface="Cormorant Garamond"/>
+              </a:rPr>
+              <a:t>E</a:t>
+            </a:r>
+            <a:r>
+              <a:rPr lang="en-US" sz="1280" spc="138">
+                <a:solidFill>
+                  <a:srgbClr val="01327B"/>
+                </a:solidFill>
+                <a:latin typeface="Cormorant Garamond"/>
+                <a:ea typeface="Cormorant Garamond"/>
+                <a:cs typeface="Cormorant Garamond"/>
+                <a:sym typeface="Cormorant Garamond"/>
+              </a:rPr>
+              <a:t>RT</a:t>
+            </a:r>
+            <a:r>
+              <a:rPr lang="en-US" sz="1280" spc="138">
+                <a:solidFill>
+                  <a:srgbClr val="01327B"/>
+                </a:solidFill>
+                <a:latin typeface="Cormorant Garamond"/>
+                <a:ea typeface="Cormorant Garamond"/>
+                <a:cs typeface="Cormorant Garamond"/>
+                <a:sym typeface="Cormorant Garamond"/>
+              </a:rPr>
+              <a:t>I</a:t>
+            </a:r>
+            <a:r>
+              <a:rPr lang="en-US" sz="1280" spc="138">
+                <a:solidFill>
+                  <a:srgbClr val="01327B"/>
+                </a:solidFill>
+                <a:latin typeface="Cormorant Garamond"/>
+                <a:ea typeface="Cormorant Garamond"/>
+                <a:cs typeface="Cormorant Garamond"/>
+                <a:sym typeface="Cormorant Garamond"/>
+              </a:rPr>
+              <a:t>F</a:t>
+            </a:r>
+            <a:r>
+              <a:rPr lang="en-US" sz="1280" spc="138">
+                <a:solidFill>
+                  <a:srgbClr val="01327B"/>
+                </a:solidFill>
+                <a:latin typeface="Cormorant Garamond"/>
+                <a:ea typeface="Cormorant Garamond"/>
+                <a:cs typeface="Cormorant Garamond"/>
+                <a:sym typeface="Cormorant Garamond"/>
+              </a:rPr>
+              <a:t>I</a:t>
+            </a:r>
+            <a:r>
+              <a:rPr lang="en-US" sz="1280" spc="138">
+                <a:solidFill>
+                  <a:srgbClr val="01327B"/>
+                </a:solidFill>
+                <a:latin typeface="Cormorant Garamond"/>
+                <a:ea typeface="Cormorant Garamond"/>
+                <a:cs typeface="Cormorant Garamond"/>
+                <a:sym typeface="Cormorant Garamond"/>
+              </a:rPr>
+              <a:t>CATE</a:t>
+            </a:r>
+            <a:r>
+              <a:rPr lang="en-US" sz="1280" spc="138">
+                <a:solidFill>
+                  <a:srgbClr val="01327B"/>
+                </a:solidFill>
+                <a:latin typeface="Cormorant Garamond"/>
+                <a:ea typeface="Cormorant Garamond"/>
+                <a:cs typeface="Cormorant Garamond"/>
+                <a:sym typeface="Cormorant Garamond"/>
+              </a:rPr>
+              <a:t> </a:t>
+            </a:r>
+            <a:r>
+              <a:rPr lang="en-US" sz="1280" spc="138">
+                <a:solidFill>
+                  <a:srgbClr val="01327B"/>
+                </a:solidFill>
+                <a:latin typeface="Cormorant Garamond"/>
+                <a:ea typeface="Cormorant Garamond"/>
+                <a:cs typeface="Cormorant Garamond"/>
+                <a:sym typeface="Cormorant Garamond"/>
+              </a:rPr>
+              <a:t>TYPE}} </a:t>
+            </a:r>
+            <a:r>
+              <a:rPr lang="en-US" sz="1280" spc="138">
+                <a:solidFill>
+                  <a:srgbClr val="01327B"/>
+                </a:solidFill>
+                <a:latin typeface="Cormorant Garamond"/>
+                <a:ea typeface="Cormorant Garamond"/>
+                <a:cs typeface="Cormorant Garamond"/>
+                <a:sym typeface="Cormorant Garamond"/>
+              </a:rPr>
+              <a:t>a</a:t>
+            </a:r>
+            <a:r>
+              <a:rPr lang="en-US" sz="1280" spc="138">
+                <a:solidFill>
+                  <a:srgbClr val="01327B"/>
+                </a:solidFill>
+                <a:latin typeface="Cormorant Garamond"/>
+                <a:ea typeface="Cormorant Garamond"/>
+                <a:cs typeface="Cormorant Garamond"/>
+                <a:sym typeface="Cormorant Garamond"/>
+              </a:rPr>
+              <a:t>s</a:t>
+            </a:r>
+            <a:r>
+              <a:rPr lang="en-US" sz="1280" spc="138">
+                <a:solidFill>
+                  <a:srgbClr val="01327B"/>
+                </a:solidFill>
+                <a:latin typeface="Cormorant Garamond"/>
+                <a:ea typeface="Cormorant Garamond"/>
+                <a:cs typeface="Cormorant Garamond"/>
+                <a:sym typeface="Cormorant Garamond"/>
+              </a:rPr>
+              <a:t> </a:t>
+            </a:r>
+            <a:r>
+              <a:rPr lang="en-US" sz="1280" spc="138">
+                <a:solidFill>
+                  <a:srgbClr val="01327B"/>
+                </a:solidFill>
+                <a:latin typeface="Cormorant Garamond"/>
+                <a:ea typeface="Cormorant Garamond"/>
+                <a:cs typeface="Cormorant Garamond"/>
+                <a:sym typeface="Cormorant Garamond"/>
+              </a:rPr>
+              <a:t>a</a:t>
             </a:r>
             <a:r>
               <a:rPr lang="en-US" sz="1280" b="1" spc="138">
                 <a:solidFill>
                   <a:srgbClr val="01327B"/>
                 </a:solidFill>
-                <a:latin typeface="Cormorant Garamond" charset="0"/>
-                <a:ea typeface="Cormorant Garamond"/>
-                <a:cs typeface="Cormorant Garamond" charset="0"/>
-                <a:sym typeface="Cormorant Garamond"/>
-              </a:rPr>
-              <a:t>{{CERTIFICATE TYPE}}</a:t>
-            </a:r>
-            <a:r>
-              <a:rPr lang="en-US" sz="1280" spc="138">
-                <a:solidFill>
-                  <a:srgbClr val="01327B"/>
-                </a:solidFill>
-                <a:latin typeface="Cormorant Garamond" charset="0"/>
-                <a:ea typeface="Cormorant Garamond"/>
-                <a:cs typeface="Cormorant Garamond" charset="0"/>
-                <a:sym typeface="Cormorant Garamond"/>
-              </a:rPr>
-              <a:t> as a</a:t>
-            </a:r>
-            <a:r>
-              <a:rPr lang="en-US" sz="1280" spc="138">
-                <a:solidFill>
-                  <a:srgbClr val="01327B"/>
-                </a:solidFill>
-                <a:latin typeface="Cormorant Garamond" charset="0"/>
+                <a:latin typeface="Cormorant Garamond Bold" panose="00000800000000000000"/>
                 <a:ea typeface="Cormorant Garamond Bold" panose="00000800000000000000"/>
-                <a:cs typeface="Cormorant Garamond" charset="0"/>
+                <a:cs typeface="Cormorant Garamond Bold" panose="00000800000000000000"/>
                 <a:sym typeface="Cormorant Garamond Bold" panose="00000800000000000000"/>
               </a:rPr>
               <a:t> {{ROLE}}</a:t>
@@ -18206,33 +18362,21 @@
                 <a:solidFill>
                   <a:srgbClr val="01327B"/>
                 </a:solidFill>
-                <a:latin typeface="Cormorant Garamond" charset="0"/>
+                <a:latin typeface="Cormorant Garamond"/>
                 <a:ea typeface="Cormorant Garamond"/>
-                <a:cs typeface="Cormorant Garamond" charset="0"/>
+                <a:cs typeface="Cormorant Garamond"/>
                 <a:sym typeface="Cormorant Garamond"/>
               </a:rPr>
-              <a:t> in the</a:t>
+              <a:t> in the </a:t>
             </a:r>
             <a:r>
               <a:rPr lang="en-US" sz="1280" b="1" spc="138">
                 <a:solidFill>
                   <a:srgbClr val="01327B"/>
                 </a:solidFill>
-                <a:latin typeface="Cormorant Garamond" charset="0"/>
-                <a:ea typeface="Cormorant Garamond"/>
-                <a:cs typeface="Cormorant Garamond" charset="0"/>
-                <a:sym typeface="Cormorant Garamond"/>
-              </a:rPr>
-              <a:t> </a:t>
-            </a:r>
-            <a:r>
-              <a:rPr lang="en-US" sz="1280" b="1" spc="138">
-                <a:solidFill>
-                  <a:srgbClr val="01327B"/>
-                </a:solidFill>
-                <a:latin typeface="Cormorant Garamond" charset="0"/>
+                <a:latin typeface="Cormorant Garamond Bold" panose="00000800000000000000"/>
                 <a:ea typeface="Cormorant Garamond Bold" panose="00000800000000000000"/>
-                <a:cs typeface="Cormorant Garamond" charset="0"/>
+                <a:cs typeface="Cormorant Garamond Bold" panose="00000800000000000000"/>
                 <a:sym typeface="Cormorant Garamond Bold" panose="00000800000000000000"/>
               </a:rPr>
               <a:t>{{HACKATHON NAME}},</a:t>
@@ -18242,93 +18386,57 @@
                 <a:solidFill>
                   <a:srgbClr val="01327B"/>
                 </a:solidFill>
-                <a:latin typeface="Cormorant Garamond" charset="0"/>
+                <a:latin typeface="Cormorant Garamond"/>
                 <a:ea typeface="Cormorant Garamond"/>
-                <a:cs typeface="Cormorant Garamond" charset="0"/>
+                <a:cs typeface="Cormorant Garamond"/>
                 <a:sym typeface="Cormorant Garamond"/>
               </a:rPr>
-              <a:t> organized by</a:t>
+              <a:t> organized by </a:t>
             </a:r>
             <a:r>
               <a:rPr lang="en-US" sz="1280" b="1" spc="138">
                 <a:solidFill>
                   <a:srgbClr val="01327B"/>
                 </a:solidFill>
-                <a:latin typeface="Cormorant Garamond" charset="0"/>
+                <a:latin typeface="Cormorant Garamond Bold" panose="00000800000000000000"/>
+                <a:ea typeface="Cormorant Garamond Bold" panose="00000800000000000000"/>
+                <a:cs typeface="Cormorant Garamond Bold" panose="00000800000000000000"/>
+                <a:sym typeface="Cormorant Garamond Bold" panose="00000800000000000000"/>
+              </a:rPr>
+              <a:t>Trinity College of Engineering and Technology (Autonomous), Peddapalli</a:t>
+            </a:r>
+            <a:r>
+              <a:rPr lang="en-US" sz="1280" spc="138">
+                <a:solidFill>
+                  <a:srgbClr val="01327B"/>
+                </a:solidFill>
+                <a:latin typeface="Cormorant Garamond"/>
                 <a:ea typeface="Cormorant Garamond"/>
-                <a:cs typeface="Cormorant Garamond" charset="0"/>
+                <a:cs typeface="Cormorant Garamond"/>
                 <a:sym typeface="Cormorant Garamond"/>
               </a:rPr>
-              <a:t> </a:t>
+              <a:t>, held on</a:t>
             </a:r>
             <a:r>
               <a:rPr lang="en-US" sz="1280" b="1" spc="138">
                 <a:solidFill>
                   <a:srgbClr val="01327B"/>
                 </a:solidFill>
-                <a:latin typeface="Cormorant Garamond" charset="0"/>
+                <a:latin typeface="Cormorant Garamond Bold" panose="00000800000000000000"/>
                 <a:ea typeface="Cormorant Garamond Bold" panose="00000800000000000000"/>
-                <a:cs typeface="Cormorant Garamond" charset="0"/>
+                <a:cs typeface="Cormorant Garamond Bold" panose="00000800000000000000"/>
                 <a:sym typeface="Cormorant Garamond Bold" panose="00000800000000000000"/>
               </a:rPr>
-              <a:t>Trinity College of Engineering and Technology (Autonomous), Peddapalli</a:t>
-            </a:r>
-            <a:r>
-              <a:rPr lang="en-US" sz="1280" b="1" spc="138">
-                <a:solidFill>
-                  <a:srgbClr val="01327B"/>
-                </a:solidFill>
-                <a:latin typeface="Cormorant Garamond" charset="0"/>
-                <a:ea typeface="Cormorant Garamond"/>
-                <a:cs typeface="Cormorant Garamond" charset="0"/>
-                <a:sym typeface="Cormorant Garamond"/>
-              </a:rPr>
-              <a:t>, </a:t>
+              <a:t> {{DATE}}</a:t>
             </a:r>
             <a:r>
               <a:rPr lang="en-US" sz="1280" spc="138">
                 <a:solidFill>
                   <a:srgbClr val="01327B"/>
                 </a:solidFill>
-                <a:latin typeface="Cormorant Garamond" charset="0"/>
+                <a:latin typeface="Cormorant Garamond"/>
                 <a:ea typeface="Cormorant Garamond"/>
-                <a:cs typeface="Cormorant Garamond" charset="0"/>
-                <a:sym typeface="Cormorant Garamond"/>
-              </a:rPr>
-              <a:t>held on</a:t>
-            </a:r>
-            <a:r>
-              <a:rPr lang="en-US" sz="1280" spc="138">
-                <a:solidFill>
-                  <a:srgbClr val="01327B"/>
-                </a:solidFill>
-                <a:latin typeface="Cormorant Garamond" charset="0"/>
-                <a:ea typeface="Cormorant Garamond Bold" panose="00000800000000000000"/>
-                <a:cs typeface="Cormorant Garamond" charset="0"/>
-                <a:sym typeface="Cormorant Garamond Bold" panose="00000800000000000000"/>
-              </a:rPr>
-              <a:t> </a:t>
-            </a:r>
-            <a:r>
-              <a:rPr lang="en-US" sz="1280" b="1" spc="138">
-                <a:solidFill>
-                  <a:srgbClr val="01327B"/>
-                </a:solidFill>
-                <a:latin typeface="Cormorant Garamond" charset="0"/>
-                <a:ea typeface="Cormorant Garamond Bold" panose="00000800000000000000"/>
-                <a:cs typeface="Cormorant Garamond" charset="0"/>
-                <a:sym typeface="Cormorant Garamond Bold" panose="00000800000000000000"/>
-              </a:rPr>
-              <a:t>{{DATE}}</a:t>
-            </a:r>
-            <a:r>
-              <a:rPr lang="en-US" sz="1280" spc="138">
-                <a:solidFill>
-                  <a:srgbClr val="01327B"/>
-                </a:solidFill>
-                <a:latin typeface="Cormorant Garamond" charset="0"/>
-                <a:ea typeface="Cormorant Garamond"/>
-                <a:cs typeface="Cormorant Garamond" charset="0"/>
+                <a:cs typeface="Cormorant Garamond"/>
                 <a:sym typeface="Cormorant Garamond"/>
               </a:rPr>
               <a:t>.</a:t>
@@ -18337,9 +18445,9 @@
               <a:solidFill>
                 <a:srgbClr val="01327B"/>
               </a:solidFill>
-              <a:latin typeface="Cormorant Garamond" charset="0"/>
+              <a:latin typeface="Cormorant Garamond"/>
               <a:ea typeface="Cormorant Garamond"/>
-              <a:cs typeface="Cormorant Garamond" charset="0"/>
+              <a:cs typeface="Cormorant Garamond"/>
               <a:sym typeface="Cormorant Garamond"/>
             </a:endParaRPr>
           </a:p>
@@ -18349,10 +18457,6 @@
                 <a:spcPts val="1790"/>
               </a:lnSpc>
             </a:pPr>
-            <a:endParaRPr>
-              <a:latin typeface="Cormorant Garamond" charset="0"/>
-              <a:cs typeface="Cormorant Garamond" charset="0"/>
-            </a:endParaRPr>
           </a:p>
           <a:p>
             <a:pPr algn="ctr">
@@ -18365,104 +18469,68 @@
                 <a:solidFill>
                   <a:srgbClr val="01327B"/>
                 </a:solidFill>
-                <a:latin typeface="Cormorant Garamond" charset="0"/>
+                <a:latin typeface="Cormorant Garamond"/>
                 <a:ea typeface="Cormorant Garamond"/>
-                <a:cs typeface="Cormorant Garamond" charset="0"/>
+                <a:cs typeface="Cormorant Garamond"/>
                 <a:sym typeface="Cormorant Garamond"/>
               </a:rPr>
               <a:t>As a member of Team</a:t>
+            </a:r>
+            <a:r>
+              <a:rPr lang="en-US" sz="1280" b="1" spc="138">
+                <a:solidFill>
+                  <a:srgbClr val="01327B"/>
+                </a:solidFill>
+                <a:latin typeface="Cormorant Garamond Bold" panose="00000800000000000000"/>
+                <a:ea typeface="Cormorant Garamond Bold" panose="00000800000000000000"/>
+                <a:cs typeface="Cormorant Garamond Bold" panose="00000800000000000000"/>
+                <a:sym typeface="Cormorant Garamond Bold" panose="00000800000000000000"/>
+              </a:rPr>
+              <a:t> {{TEAM NAME}}</a:t>
             </a:r>
             <a:r>
               <a:rPr lang="en-US" sz="1280" spc="138">
                 <a:solidFill>
                   <a:srgbClr val="01327B"/>
                 </a:solidFill>
-                <a:latin typeface="Cormorant Garamond" charset="0"/>
-                <a:ea typeface="Cormorant Garamond Bold" panose="00000800000000000000"/>
-                <a:cs typeface="Cormorant Garamond" charset="0"/>
-                <a:sym typeface="Cormorant Garamond Bold" panose="00000800000000000000"/>
+                <a:latin typeface="Cormorant Garamond"/>
+                <a:ea typeface="Cormorant Garamond"/>
+                <a:cs typeface="Cormorant Garamond"/>
+                <a:sym typeface="Cormorant Garamond"/>
               </a:rPr>
-              <a:t> </a:t>
+              <a:t>, they contributed to the development and presentation of the innovative project </a:t>
             </a:r>
             <a:r>
               <a:rPr lang="en-US" sz="1280" b="1" spc="138">
                 <a:solidFill>
                   <a:srgbClr val="01327B"/>
                 </a:solidFill>
-                <a:latin typeface="Cormorant Garamond" charset="0"/>
+                <a:latin typeface="Cormorant Garamond Bold" panose="00000800000000000000"/>
                 <a:ea typeface="Cormorant Garamond Bold" panose="00000800000000000000"/>
-                <a:cs typeface="Cormorant Garamond" charset="0"/>
+                <a:cs typeface="Cormorant Garamond Bold" panose="00000800000000000000"/>
                 <a:sym typeface="Cormorant Garamond Bold" panose="00000800000000000000"/>
               </a:rPr>
-              <a:t>{{TEAM NAME}}</a:t>
-            </a:r>
-            <a:r>
-              <a:rPr lang="en-US" sz="1280" b="1" spc="138">
-                <a:solidFill>
-                  <a:srgbClr val="01327B"/>
-                </a:solidFill>
-                <a:latin typeface="Cormorant Garamond" charset="0"/>
-                <a:ea typeface="Cormorant Garamond"/>
-                <a:cs typeface="Cormorant Garamond" charset="0"/>
-                <a:sym typeface="Cormorant Garamond"/>
-              </a:rPr>
-              <a:t>,</a:t>
+              <a:t>“{{PROJECT TITLE}}”</a:t>
             </a:r>
             <a:r>
               <a:rPr lang="en-US" sz="1280" spc="138">
                 <a:solidFill>
                   <a:srgbClr val="01327B"/>
                 </a:solidFill>
-                <a:latin typeface="Cormorant Garamond" charset="0"/>
+                <a:latin typeface="Cormorant Garamond"/>
                 <a:ea typeface="Cormorant Garamond"/>
-                <a:cs typeface="Cormorant Garamond" charset="0"/>
+                <a:cs typeface="Cormorant Garamond"/>
                 <a:sym typeface="Cormorant Garamond"/>
               </a:rPr>
-              <a:t> they contributed to the development and presentation of the innovative project </a:t>
-            </a:r>
-            <a:r>
-              <a:rPr lang="en-US" sz="1280" b="1" spc="138">
-                <a:solidFill>
-                  <a:srgbClr val="01327B"/>
-                </a:solidFill>
-                <a:latin typeface="Cormorant Garamond" charset="0"/>
-                <a:ea typeface="Cormorant Garamond Bold" panose="00000800000000000000"/>
-                <a:cs typeface="Cormorant Garamond" charset="0"/>
-                <a:sym typeface="Cormorant Garamond Bold" panose="00000800000000000000"/>
-              </a:rPr>
-              <a:t>“{{PROJECT TITLE}}”</a:t>
-            </a:r>
-            <a:r>
-              <a:rPr lang="en-US" sz="1280" b="1" spc="138">
-                <a:solidFill>
-                  <a:srgbClr val="01327B"/>
-                </a:solidFill>
-                <a:latin typeface="Cormorant Garamond" charset="0"/>
-                <a:ea typeface="Cormorant Garamond"/>
-                <a:cs typeface="Cormorant Garamond" charset="0"/>
-                <a:sym typeface="Cormorant Garamond"/>
-              </a:rPr>
-              <a:t>,</a:t>
-            </a:r>
-            <a:r>
-              <a:rPr lang="en-US" sz="1280" spc="138">
-                <a:solidFill>
-                  <a:srgbClr val="01327B"/>
-                </a:solidFill>
-                <a:latin typeface="Cormorant Garamond" charset="0"/>
-                <a:ea typeface="Cormorant Garamond"/>
-                <a:cs typeface="Cormorant Garamond" charset="0"/>
-                <a:sym typeface="Cormorant Garamond"/>
-              </a:rPr>
-              <a:t> demonstrating creativity, technical skills, teamwork, and problem-solving abilities.</a:t>
+              <a:t>, demonstrating creativity, technical skills, teamwork, and problem-solving abilities.</a:t>
             </a:r>
             <a:endParaRPr lang="en-US" sz="1280" spc="138">
               <a:solidFill>
                 <a:srgbClr val="01327B"/>
               </a:solidFill>
-              <a:latin typeface="Cormorant Garamond" charset="0"/>
+              <a:latin typeface="Cormorant Garamond"/>
               <a:ea typeface="Cormorant Garamond"/>
-              <a:cs typeface="Cormorant Garamond" charset="0"/>
+              <a:cs typeface="Cormorant Garamond"/>
               <a:sym typeface="Cormorant Garamond"/>
             </a:endParaRPr>
           </a:p>
@@ -18472,10 +18540,6 @@
                 <a:spcPts val="1790"/>
               </a:lnSpc>
             </a:pPr>
-            <a:endParaRPr>
-              <a:latin typeface="Cormorant Garamond" charset="0"/>
-              <a:cs typeface="Cormorant Garamond" charset="0"/>
-            </a:endParaRPr>
           </a:p>
         </p:txBody>
       </p:sp>
@@ -18537,8 +18601,8 @@
         </p:nvSpPr>
         <p:spPr>
           <a:xfrm>
-            <a:off x="276221" y="3639381"/>
-            <a:ext cx="10206242" cy="444500"/>
+            <a:off x="276221" y="3867981"/>
+            <a:ext cx="10206242" cy="422783"/>
           </a:xfrm>
           <a:prstGeom prst="rect">
             <a:avLst/>
@@ -18565,31 +18629,7 @@
                 <a:cs typeface="Great Vibes"/>
                 <a:sym typeface="Great Vibes"/>
               </a:rPr>
-              <a:t>{{</a:t>
-            </a:r>
-            <a:r>
-              <a:rPr lang="en-US" sz="3600">
-                <a:solidFill>
-                  <a:srgbClr val="000000"/>
-                </a:solidFill>
-                <a:latin typeface="Great Vibes"/>
-                <a:ea typeface="Great Vibes"/>
-                <a:cs typeface="Great Vibes"/>
-                <a:sym typeface="Great Vibes"/>
-              </a:rPr>
-              <a:t>PARTICIPANT </a:t>
-            </a:r>
-            <a:r>
-              <a:rPr lang="en-US" sz="2480">
-                <a:solidFill>
-                  <a:srgbClr val="000000"/>
-                </a:solidFill>
-                <a:latin typeface="Great Vibes"/>
-                <a:ea typeface="Great Vibes"/>
-                <a:cs typeface="Great Vibes"/>
-                <a:sym typeface="Great Vibes"/>
-              </a:rPr>
-              <a:t>NAME}} </a:t>
+              <a:t>{{PARTICIPANT NAME}} </a:t>
             </a:r>
             <a:endParaRPr lang="en-US" sz="2480">
               <a:solidFill>

</xml_diff>

<commit_message>
Deploy updated hackathon certificate template from backend folder
</commit_message>
<xml_diff>
--- a/backend/CERTIFICATE_TEMPLATE - hackathon.pptx
+++ b/backend/CERTIFICATE_TEMPLATE - hackathon.pptx
@@ -50,6 +50,13 @@
       <p:bold r:id="rId21"/>
       <p:italic r:id="rId22"/>
       <p:boldItalic r:id="rId23"/>
+    </p:embeddedFont>
+    <p:embeddedFont>
+      <p:font typeface="Palatino Linotype" panose="02040502050505030304" charset="0"/>
+      <p:regular r:id="rId24"/>
+      <p:bold r:id="rId25"/>
+      <p:italic r:id="rId26"/>
+      <p:boldItalic r:id="rId27"/>
     </p:embeddedFont>
   </p:embeddedFontLst>
   <p:defaultTextStyle>
@@ -17410,7 +17417,7 @@
         </p:nvSpPr>
         <p:spPr>
           <a:xfrm flipV="1">
-            <a:off x="2381886" y="4392938"/>
+            <a:off x="2381886" y="4088138"/>
             <a:ext cx="5928227" cy="0"/>
           </a:xfrm>
           <a:prstGeom prst="line">
@@ -18022,7 +18029,7 @@
         <p:spPr>
           <a:xfrm>
             <a:off x="1574763" y="1849951"/>
-            <a:ext cx="7542474" cy="1109953"/>
+            <a:ext cx="7542474" cy="1040765"/>
           </a:xfrm>
           <a:prstGeom prst="rect">
             <a:avLst/>
@@ -18044,9 +18051,9 @@
                 <a:solidFill>
                   <a:srgbClr val="01327B"/>
                 </a:solidFill>
-                <a:latin typeface="Palatino Bold" panose="02040702050505030304"/>
+                <a:latin typeface="Palatino Linotype" panose="02040502050505030304" charset="0"/>
                 <a:ea typeface="Palatino Bold" panose="02040702050505030304"/>
-                <a:cs typeface="Palatino Bold" panose="02040702050505030304"/>
+                <a:cs typeface="Palatino Linotype" panose="02040502050505030304" charset="0"/>
                 <a:sym typeface="Palatino Bold" panose="02040702050505030304"/>
               </a:rPr>
               <a:t>CERTIFICATE</a:t>
@@ -18055,60 +18062,10 @@
               <a:solidFill>
                 <a:srgbClr val="01327B"/>
               </a:solidFill>
-              <a:latin typeface="Palatino Bold" panose="02040702050505030304"/>
+              <a:latin typeface="Palatino Linotype" panose="02040502050505030304" charset="0"/>
               <a:ea typeface="Palatino Bold" panose="02040702050505030304"/>
-              <a:cs typeface="Palatino Bold" panose="02040702050505030304"/>
+              <a:cs typeface="Palatino Linotype" panose="02040502050505030304" charset="0"/>
               <a:sym typeface="Palatino Bold" panose="02040702050505030304"/>
-            </a:endParaRPr>
-          </a:p>
-        </p:txBody>
-      </p:sp>
-      <p:sp>
-        <p:nvSpPr>
-          <p:cNvPr id="152" name="TextBox 152"/>
-          <p:cNvSpPr txBox="1"/>
-          <p:nvPr/>
-        </p:nvSpPr>
-        <p:spPr>
-          <a:xfrm>
-            <a:off x="1574763" y="2760981"/>
-            <a:ext cx="7542474" cy="422275"/>
-          </a:xfrm>
-          <a:prstGeom prst="rect">
-            <a:avLst/>
-          </a:prstGeom>
-        </p:spPr>
-        <p:txBody>
-          <a:bodyPr lIns="0" tIns="0" rIns="0" bIns="0" rtlCol="0" anchor="t">
-            <a:spAutoFit/>
-          </a:bodyPr>
-          <a:lstStyle/>
-          <a:p>
-            <a:pPr algn="ctr">
-              <a:lnSpc>
-                <a:spcPts val="3500"/>
-              </a:lnSpc>
-            </a:pPr>
-            <a:r>
-              <a:rPr lang="en-US" sz="2500" b="1" spc="1299">
-                <a:solidFill>
-                  <a:srgbClr val="01327B"/>
-                </a:solidFill>
-                <a:latin typeface="Inria Serif Bold"/>
-                <a:ea typeface="Inria Serif Bold"/>
-                <a:cs typeface="Inria Serif Bold"/>
-                <a:sym typeface="Inria Serif Bold"/>
-              </a:rPr>
-              <a:t>OF Participation</a:t>
-            </a:r>
-            <a:endParaRPr lang="en-US" sz="2500" b="1" spc="1299">
-              <a:solidFill>
-                <a:srgbClr val="01327B"/>
-              </a:solidFill>
-              <a:latin typeface="Inria Serif Bold"/>
-              <a:ea typeface="Inria Serif Bold"/>
-              <a:cs typeface="Inria Serif Bold"/>
-              <a:sym typeface="Inria Serif Bold"/>
             </a:endParaRPr>
           </a:p>
         </p:txBody>
@@ -18121,7 +18078,7 @@
         </p:nvSpPr>
         <p:spPr>
           <a:xfrm>
-            <a:off x="1689892" y="3286956"/>
+            <a:off x="1689892" y="2982156"/>
             <a:ext cx="7542474" cy="266700"/>
           </a:xfrm>
           <a:prstGeom prst="rect">
@@ -18171,7 +18128,7 @@
         </p:nvSpPr>
         <p:spPr>
           <a:xfrm>
-            <a:off x="893277" y="4479007"/>
+            <a:off x="893277" y="4174207"/>
             <a:ext cx="8905445" cy="1529588"/>
           </a:xfrm>
           <a:prstGeom prst="rect">
@@ -18601,8 +18558,8 @@
         </p:nvSpPr>
         <p:spPr>
           <a:xfrm>
-            <a:off x="276221" y="3867981"/>
-            <a:ext cx="10206242" cy="422783"/>
+            <a:off x="276221" y="3563181"/>
+            <a:ext cx="10206242" cy="444500"/>
           </a:xfrm>
           <a:prstGeom prst="rect">
             <a:avLst/>
@@ -18620,7 +18577,7 @@
               </a:lnSpc>
             </a:pPr>
             <a:r>
-              <a:rPr lang="en-US" sz="2480">
+              <a:rPr lang="en-US" sz="4000">
                 <a:solidFill>
                   <a:srgbClr val="000000"/>
                 </a:solidFill>
@@ -18631,7 +18588,7 @@
               </a:rPr>
               <a:t>{{PARTICIPANT NAME}} </a:t>
             </a:r>
-            <a:endParaRPr lang="en-US" sz="2480">
+            <a:endParaRPr lang="en-US" sz="4000">
               <a:solidFill>
                 <a:srgbClr val="000000"/>
               </a:solidFill>

</xml_diff>

<commit_message>
Deploy latest template modifications
</commit_message>
<xml_diff>
--- a/backend/CERTIFICATE_TEMPLATE - hackathon.pptx
+++ b/backend/CERTIFICATE_TEMPLATE - hackathon.pptx
@@ -22,41 +22,48 @@
       <p:bold r:id="rId11"/>
     </p:embeddedFont>
     <p:embeddedFont>
-      <p:font typeface="Inria Serif Bold"/>
-      <p:bold r:id="rId12"/>
+      <p:font typeface="Palatino Linotype" panose="02040502050505030304" charset="0"/>
+      <p:regular r:id="rId12"/>
+      <p:bold r:id="rId13"/>
+      <p:italic r:id="rId14"/>
+      <p:boldItalic r:id="rId15"/>
     </p:embeddedFont>
     <p:embeddedFont>
       <p:font typeface="Inria Serif"/>
-      <p:regular r:id="rId13"/>
+      <p:regular r:id="rId16"/>
     </p:embeddedFont>
     <p:embeddedFont>
       <p:font typeface="Cormorant Garamond"/>
-      <p:regular r:id="rId14"/>
-      <p:bold r:id="rId15"/>
-      <p:italic r:id="rId16"/>
-      <p:boldItalic r:id="rId17"/>
+      <p:regular r:id="rId17"/>
+      <p:bold r:id="rId18"/>
+      <p:italic r:id="rId19"/>
+      <p:boldItalic r:id="rId20"/>
     </p:embeddedFont>
     <p:embeddedFont>
       <p:font typeface="Cormorant Garamond Bold" panose="00000800000000000000"/>
-      <p:bold r:id="rId18"/>
+      <p:bold r:id="rId21"/>
+    </p:embeddedFont>
+    <p:embeddedFont>
+      <p:font typeface="Inria Serif Bold"/>
+      <p:bold r:id="rId22"/>
     </p:embeddedFont>
     <p:embeddedFont>
       <p:font typeface="Great Vibes"/>
-      <p:regular r:id="rId19"/>
+      <p:regular r:id="rId23"/>
     </p:embeddedFont>
     <p:embeddedFont>
       <p:font typeface="Calibri" panose="020F0502020204030204" charset="0"/>
-      <p:regular r:id="rId20"/>
-      <p:bold r:id="rId21"/>
-      <p:italic r:id="rId22"/>
-      <p:boldItalic r:id="rId23"/>
-    </p:embeddedFont>
-    <p:embeddedFont>
-      <p:font typeface="Palatino Linotype" panose="02040502050505030304" charset="0"/>
       <p:regular r:id="rId24"/>
       <p:bold r:id="rId25"/>
       <p:italic r:id="rId26"/>
       <p:boldItalic r:id="rId27"/>
+    </p:embeddedFont>
+    <p:embeddedFont>
+      <p:font typeface="Cormorant Garamond" charset="0"/>
+      <p:regular r:id="rId28"/>
+      <p:bold r:id="rId29"/>
+      <p:italic r:id="rId30"/>
+      <p:boldItalic r:id="rId31"/>
     </p:embeddedFont>
   </p:embeddedFontLst>
   <p:defaultTextStyle>
@@ -18129,7 +18136,7 @@
         <p:spPr>
           <a:xfrm>
             <a:off x="893277" y="4174207"/>
-            <a:ext cx="8905445" cy="1529588"/>
+            <a:ext cx="8905445" cy="1606550"/>
           </a:xfrm>
           <a:prstGeom prst="rect">
             <a:avLst/>
@@ -18151,9 +18158,9 @@
                 <a:solidFill>
                   <a:srgbClr val="01327B"/>
                 </a:solidFill>
-                <a:latin typeface="Cormorant Garamond"/>
+                <a:latin typeface="Cormorant Garamond" charset="0"/>
                 <a:ea typeface="Cormorant Garamond"/>
-                <a:cs typeface="Cormorant Garamond"/>
+                <a:cs typeface="Cormorant Garamond" charset="0"/>
                 <a:sym typeface="Cormorant Garamond"/>
               </a:rPr>
               <a:t>has successfully {{C</a:t>
@@ -18163,153 +18170,45 @@
                 <a:solidFill>
                   <a:srgbClr val="01327B"/>
                 </a:solidFill>
-                <a:latin typeface="Cormorant Garamond"/>
+                <a:latin typeface="Cormorant Garamond" charset="0"/>
                 <a:ea typeface="Cormorant Garamond"/>
-                <a:cs typeface="Cormorant Garamond"/>
+                <a:cs typeface="Cormorant Garamond" charset="0"/>
                 <a:sym typeface="Cormorant Garamond"/>
               </a:rPr>
-              <a:t>E</a:t>
+              <a:t>ERTIF</a:t>
             </a:r>
             <a:r>
               <a:rPr lang="en-US" sz="1280" spc="138">
                 <a:solidFill>
                   <a:srgbClr val="01327B"/>
                 </a:solidFill>
-                <a:latin typeface="Cormorant Garamond"/>
+                <a:latin typeface="Cormorant Garamond" charset="0"/>
                 <a:ea typeface="Cormorant Garamond"/>
-                <a:cs typeface="Cormorant Garamond"/>
+                <a:cs typeface="Cormorant Garamond" charset="0"/>
                 <a:sym typeface="Cormorant Garamond"/>
               </a:rPr>
-              <a:t>RT</a:t>
+              <a:t>ICATE TYPE}} </a:t>
             </a:r>
             <a:r>
               <a:rPr lang="en-US" sz="1280" spc="138">
                 <a:solidFill>
                   <a:srgbClr val="01327B"/>
                 </a:solidFill>
-                <a:latin typeface="Cormorant Garamond"/>
+                <a:latin typeface="Cormorant Garamond" charset="0"/>
                 <a:ea typeface="Cormorant Garamond"/>
-                <a:cs typeface="Cormorant Garamond"/>
+                <a:cs typeface="Cormorant Garamond" charset="0"/>
                 <a:sym typeface="Cormorant Garamond"/>
               </a:rPr>
-              <a:t>I</a:t>
-            </a:r>
-            <a:r>
-              <a:rPr lang="en-US" sz="1280" spc="138">
-                <a:solidFill>
-                  <a:srgbClr val="01327B"/>
-                </a:solidFill>
-                <a:latin typeface="Cormorant Garamond"/>
-                <a:ea typeface="Cormorant Garamond"/>
-                <a:cs typeface="Cormorant Garamond"/>
-                <a:sym typeface="Cormorant Garamond"/>
-              </a:rPr>
-              <a:t>F</a:t>
-            </a:r>
-            <a:r>
-              <a:rPr lang="en-US" sz="1280" spc="138">
-                <a:solidFill>
-                  <a:srgbClr val="01327B"/>
-                </a:solidFill>
-                <a:latin typeface="Cormorant Garamond"/>
-                <a:ea typeface="Cormorant Garamond"/>
-                <a:cs typeface="Cormorant Garamond"/>
-                <a:sym typeface="Cormorant Garamond"/>
-              </a:rPr>
-              <a:t>I</a:t>
-            </a:r>
-            <a:r>
-              <a:rPr lang="en-US" sz="1280" spc="138">
-                <a:solidFill>
-                  <a:srgbClr val="01327B"/>
-                </a:solidFill>
-                <a:latin typeface="Cormorant Garamond"/>
-                <a:ea typeface="Cormorant Garamond"/>
-                <a:cs typeface="Cormorant Garamond"/>
-                <a:sym typeface="Cormorant Garamond"/>
-              </a:rPr>
-              <a:t>CATE</a:t>
-            </a:r>
-            <a:r>
-              <a:rPr lang="en-US" sz="1280" spc="138">
-                <a:solidFill>
-                  <a:srgbClr val="01327B"/>
-                </a:solidFill>
-                <a:latin typeface="Cormorant Garamond"/>
-                <a:ea typeface="Cormorant Garamond"/>
-                <a:cs typeface="Cormorant Garamond"/>
-                <a:sym typeface="Cormorant Garamond"/>
-              </a:rPr>
-              <a:t> </a:t>
-            </a:r>
-            <a:r>
-              <a:rPr lang="en-US" sz="1280" spc="138">
-                <a:solidFill>
-                  <a:srgbClr val="01327B"/>
-                </a:solidFill>
-                <a:latin typeface="Cormorant Garamond"/>
-                <a:ea typeface="Cormorant Garamond"/>
-                <a:cs typeface="Cormorant Garamond"/>
-                <a:sym typeface="Cormorant Garamond"/>
-              </a:rPr>
-              <a:t>TYPE}} </a:t>
-            </a:r>
-            <a:r>
-              <a:rPr lang="en-US" sz="1280" spc="138">
-                <a:solidFill>
-                  <a:srgbClr val="01327B"/>
-                </a:solidFill>
-                <a:latin typeface="Cormorant Garamond"/>
-                <a:ea typeface="Cormorant Garamond"/>
-                <a:cs typeface="Cormorant Garamond"/>
-                <a:sym typeface="Cormorant Garamond"/>
-              </a:rPr>
-              <a:t>a</a:t>
-            </a:r>
-            <a:r>
-              <a:rPr lang="en-US" sz="1280" spc="138">
-                <a:solidFill>
-                  <a:srgbClr val="01327B"/>
-                </a:solidFill>
-                <a:latin typeface="Cormorant Garamond"/>
-                <a:ea typeface="Cormorant Garamond"/>
-                <a:cs typeface="Cormorant Garamond"/>
-                <a:sym typeface="Cormorant Garamond"/>
-              </a:rPr>
-              <a:t>s</a:t>
-            </a:r>
-            <a:r>
-              <a:rPr lang="en-US" sz="1280" spc="138">
-                <a:solidFill>
-                  <a:srgbClr val="01327B"/>
-                </a:solidFill>
-                <a:latin typeface="Cormorant Garamond"/>
-                <a:ea typeface="Cormorant Garamond"/>
-                <a:cs typeface="Cormorant Garamond"/>
-                <a:sym typeface="Cormorant Garamond"/>
-              </a:rPr>
-              <a:t> </a:t>
-            </a:r>
-            <a:r>
-              <a:rPr lang="en-US" sz="1280" spc="138">
-                <a:solidFill>
-                  <a:srgbClr val="01327B"/>
-                </a:solidFill>
-                <a:latin typeface="Cormorant Garamond"/>
-                <a:ea typeface="Cormorant Garamond"/>
-                <a:cs typeface="Cormorant Garamond"/>
-                <a:sym typeface="Cormorant Garamond"/>
-              </a:rPr>
-              <a:t>a</a:t>
+              <a:t>as a</a:t>
             </a:r>
             <a:r>
               <a:rPr lang="en-US" sz="1280" b="1" spc="138">
                 <a:solidFill>
                   <a:srgbClr val="01327B"/>
                 </a:solidFill>
-                <a:latin typeface="Cormorant Garamond Bold" panose="00000800000000000000"/>
+                <a:latin typeface="Cormorant Garamond" charset="0"/>
                 <a:ea typeface="Cormorant Garamond Bold" panose="00000800000000000000"/>
-                <a:cs typeface="Cormorant Garamond Bold" panose="00000800000000000000"/>
+                <a:cs typeface="Cormorant Garamond" charset="0"/>
                 <a:sym typeface="Cormorant Garamond Bold" panose="00000800000000000000"/>
               </a:rPr>
               <a:t> {{ROLE}}</a:t>
@@ -18319,9 +18218,9 @@
                 <a:solidFill>
                   <a:srgbClr val="01327B"/>
                 </a:solidFill>
-                <a:latin typeface="Cormorant Garamond"/>
+                <a:latin typeface="Cormorant Garamond" charset="0"/>
                 <a:ea typeface="Cormorant Garamond"/>
-                <a:cs typeface="Cormorant Garamond"/>
+                <a:cs typeface="Cormorant Garamond" charset="0"/>
                 <a:sym typeface="Cormorant Garamond"/>
               </a:rPr>
               <a:t> in the </a:t>
@@ -18331,9 +18230,9 @@
                 <a:solidFill>
                   <a:srgbClr val="01327B"/>
                 </a:solidFill>
-                <a:latin typeface="Cormorant Garamond Bold" panose="00000800000000000000"/>
+                <a:latin typeface="Cormorant Garamond" charset="0"/>
                 <a:ea typeface="Cormorant Garamond Bold" panose="00000800000000000000"/>
-                <a:cs typeface="Cormorant Garamond Bold" panose="00000800000000000000"/>
+                <a:cs typeface="Cormorant Garamond" charset="0"/>
                 <a:sym typeface="Cormorant Garamond Bold" panose="00000800000000000000"/>
               </a:rPr>
               <a:t>{{HACKATHON NAME}},</a:t>
@@ -18343,9 +18242,9 @@
                 <a:solidFill>
                   <a:srgbClr val="01327B"/>
                 </a:solidFill>
-                <a:latin typeface="Cormorant Garamond"/>
+                <a:latin typeface="Cormorant Garamond" charset="0"/>
                 <a:ea typeface="Cormorant Garamond"/>
-                <a:cs typeface="Cormorant Garamond"/>
+                <a:cs typeface="Cormorant Garamond" charset="0"/>
                 <a:sym typeface="Cormorant Garamond"/>
               </a:rPr>
               <a:t> organized by </a:t>
@@ -18355,9 +18254,9 @@
                 <a:solidFill>
                   <a:srgbClr val="01327B"/>
                 </a:solidFill>
-                <a:latin typeface="Cormorant Garamond Bold" panose="00000800000000000000"/>
+                <a:latin typeface="Cormorant Garamond" charset="0"/>
                 <a:ea typeface="Cormorant Garamond Bold" panose="00000800000000000000"/>
-                <a:cs typeface="Cormorant Garamond Bold" panose="00000800000000000000"/>
+                <a:cs typeface="Cormorant Garamond" charset="0"/>
                 <a:sym typeface="Cormorant Garamond Bold" panose="00000800000000000000"/>
               </a:rPr>
               <a:t>Trinity College of Engineering and Technology (Autonomous), Peddapalli</a:t>
@@ -18367,9 +18266,9 @@
                 <a:solidFill>
                   <a:srgbClr val="01327B"/>
                 </a:solidFill>
-                <a:latin typeface="Cormorant Garamond"/>
+                <a:latin typeface="Cormorant Garamond" charset="0"/>
                 <a:ea typeface="Cormorant Garamond"/>
-                <a:cs typeface="Cormorant Garamond"/>
+                <a:cs typeface="Cormorant Garamond" charset="0"/>
                 <a:sym typeface="Cormorant Garamond"/>
               </a:rPr>
               <a:t>, held on</a:t>
@@ -18379,9 +18278,9 @@
                 <a:solidFill>
                   <a:srgbClr val="01327B"/>
                 </a:solidFill>
-                <a:latin typeface="Cormorant Garamond Bold" panose="00000800000000000000"/>
+                <a:latin typeface="Cormorant Garamond" charset="0"/>
                 <a:ea typeface="Cormorant Garamond Bold" panose="00000800000000000000"/>
-                <a:cs typeface="Cormorant Garamond Bold" panose="00000800000000000000"/>
+                <a:cs typeface="Cormorant Garamond" charset="0"/>
                 <a:sym typeface="Cormorant Garamond Bold" panose="00000800000000000000"/>
               </a:rPr>
               <a:t> {{DATE}}</a:t>
@@ -18391,9 +18290,9 @@
                 <a:solidFill>
                   <a:srgbClr val="01327B"/>
                 </a:solidFill>
-                <a:latin typeface="Cormorant Garamond"/>
+                <a:latin typeface="Cormorant Garamond" charset="0"/>
                 <a:ea typeface="Cormorant Garamond"/>
-                <a:cs typeface="Cormorant Garamond"/>
+                <a:cs typeface="Cormorant Garamond" charset="0"/>
                 <a:sym typeface="Cormorant Garamond"/>
               </a:rPr>
               <a:t>.</a:t>
@@ -18402,9 +18301,9 @@
               <a:solidFill>
                 <a:srgbClr val="01327B"/>
               </a:solidFill>
-              <a:latin typeface="Cormorant Garamond"/>
+              <a:latin typeface="Cormorant Garamond" charset="0"/>
               <a:ea typeface="Cormorant Garamond"/>
-              <a:cs typeface="Cormorant Garamond"/>
+              <a:cs typeface="Cormorant Garamond" charset="0"/>
               <a:sym typeface="Cormorant Garamond"/>
             </a:endParaRPr>
           </a:p>
@@ -18414,6 +18313,10 @@
                 <a:spcPts val="1790"/>
               </a:lnSpc>
             </a:pPr>
+            <a:endParaRPr>
+              <a:latin typeface="Cormorant Garamond" charset="0"/>
+              <a:cs typeface="Cormorant Garamond" charset="0"/>
+            </a:endParaRPr>
           </a:p>
           <a:p>
             <a:pPr algn="ctr">
@@ -18426,9 +18329,9 @@
                 <a:solidFill>
                   <a:srgbClr val="01327B"/>
                 </a:solidFill>
-                <a:latin typeface="Cormorant Garamond"/>
+                <a:latin typeface="Cormorant Garamond" charset="0"/>
                 <a:ea typeface="Cormorant Garamond"/>
-                <a:cs typeface="Cormorant Garamond"/>
+                <a:cs typeface="Cormorant Garamond" charset="0"/>
                 <a:sym typeface="Cormorant Garamond"/>
               </a:rPr>
               <a:t>As a member of Team</a:t>
@@ -18438,9 +18341,9 @@
                 <a:solidFill>
                   <a:srgbClr val="01327B"/>
                 </a:solidFill>
-                <a:latin typeface="Cormorant Garamond Bold" panose="00000800000000000000"/>
+                <a:latin typeface="Cormorant Garamond" charset="0"/>
                 <a:ea typeface="Cormorant Garamond Bold" panose="00000800000000000000"/>
-                <a:cs typeface="Cormorant Garamond Bold" panose="00000800000000000000"/>
+                <a:cs typeface="Cormorant Garamond" charset="0"/>
                 <a:sym typeface="Cormorant Garamond Bold" panose="00000800000000000000"/>
               </a:rPr>
               <a:t> {{TEAM NAME}}</a:t>
@@ -18450,9 +18353,9 @@
                 <a:solidFill>
                   <a:srgbClr val="01327B"/>
                 </a:solidFill>
-                <a:latin typeface="Cormorant Garamond"/>
+                <a:latin typeface="Cormorant Garamond" charset="0"/>
                 <a:ea typeface="Cormorant Garamond"/>
-                <a:cs typeface="Cormorant Garamond"/>
+                <a:cs typeface="Cormorant Garamond" charset="0"/>
                 <a:sym typeface="Cormorant Garamond"/>
               </a:rPr>
               <a:t>, they contributed to the development and presentation of the innovative project </a:t>
@@ -18462,9 +18365,9 @@
                 <a:solidFill>
                   <a:srgbClr val="01327B"/>
                 </a:solidFill>
-                <a:latin typeface="Cormorant Garamond Bold" panose="00000800000000000000"/>
+                <a:latin typeface="Cormorant Garamond" charset="0"/>
                 <a:ea typeface="Cormorant Garamond Bold" panose="00000800000000000000"/>
-                <a:cs typeface="Cormorant Garamond Bold" panose="00000800000000000000"/>
+                <a:cs typeface="Cormorant Garamond" charset="0"/>
                 <a:sym typeface="Cormorant Garamond Bold" panose="00000800000000000000"/>
               </a:rPr>
               <a:t>“{{PROJECT TITLE}}”</a:t>
@@ -18474,9 +18377,9 @@
                 <a:solidFill>
                   <a:srgbClr val="01327B"/>
                 </a:solidFill>
-                <a:latin typeface="Cormorant Garamond"/>
+                <a:latin typeface="Cormorant Garamond" charset="0"/>
                 <a:ea typeface="Cormorant Garamond"/>
-                <a:cs typeface="Cormorant Garamond"/>
+                <a:cs typeface="Cormorant Garamond" charset="0"/>
                 <a:sym typeface="Cormorant Garamond"/>
               </a:rPr>
               <a:t>, demonstrating creativity, technical skills, teamwork, and problem-solving abilities.</a:t>
@@ -18485,9 +18388,9 @@
               <a:solidFill>
                 <a:srgbClr val="01327B"/>
               </a:solidFill>
-              <a:latin typeface="Cormorant Garamond"/>
+              <a:latin typeface="Cormorant Garamond" charset="0"/>
               <a:ea typeface="Cormorant Garamond"/>
-              <a:cs typeface="Cormorant Garamond"/>
+              <a:cs typeface="Cormorant Garamond" charset="0"/>
               <a:sym typeface="Cormorant Garamond"/>
             </a:endParaRPr>
           </a:p>
@@ -18497,6 +18400,10 @@
                 <a:spcPts val="1790"/>
               </a:lnSpc>
             </a:pPr>
+            <a:endParaRPr>
+              <a:latin typeface="Cormorant Garamond" charset="0"/>
+              <a:cs typeface="Cormorant Garamond" charset="0"/>
+            </a:endParaRPr>
           </a:p>
         </p:txBody>
       </p:sp>

</xml_diff>

<commit_message>
Deploy latest hackathon certificate template tweaks
</commit_message>
<xml_diff>
--- a/backend/CERTIFICATE_TEMPLATE - hackathon.pptx
+++ b/backend/CERTIFICATE_TEMPLATE - hackathon.pptx
@@ -33,33 +33,33 @@
       <p:regular r:id="rId16"/>
     </p:embeddedFont>
     <p:embeddedFont>
-      <p:font typeface="Cormorant Garamond"/>
+      <p:font typeface="Cormorant Garamond" charset="0"/>
       <p:regular r:id="rId17"/>
       <p:bold r:id="rId18"/>
       <p:italic r:id="rId19"/>
       <p:boldItalic r:id="rId20"/>
     </p:embeddedFont>
     <p:embeddedFont>
+      <p:font typeface="Cormorant Garamond"/>
+      <p:regular r:id="rId21"/>
+      <p:bold r:id="rId22"/>
+      <p:italic r:id="rId23"/>
+      <p:boldItalic r:id="rId24"/>
+    </p:embeddedFont>
+    <p:embeddedFont>
       <p:font typeface="Cormorant Garamond Bold" panose="00000800000000000000"/>
-      <p:bold r:id="rId21"/>
+      <p:bold r:id="rId25"/>
     </p:embeddedFont>
     <p:embeddedFont>
       <p:font typeface="Inria Serif Bold"/>
-      <p:bold r:id="rId22"/>
+      <p:bold r:id="rId26"/>
     </p:embeddedFont>
     <p:embeddedFont>
       <p:font typeface="Great Vibes"/>
-      <p:regular r:id="rId23"/>
+      <p:regular r:id="rId27"/>
     </p:embeddedFont>
     <p:embeddedFont>
       <p:font typeface="Calibri" panose="020F0502020204030204" charset="0"/>
-      <p:regular r:id="rId24"/>
-      <p:bold r:id="rId25"/>
-      <p:italic r:id="rId26"/>
-      <p:boldItalic r:id="rId27"/>
-    </p:embeddedFont>
-    <p:embeddedFont>
-      <p:font typeface="Cormorant Garamond" charset="0"/>
       <p:regular r:id="rId28"/>
       <p:bold r:id="rId29"/>
       <p:italic r:id="rId30"/>
@@ -18484,7 +18484,7 @@
               </a:lnSpc>
             </a:pPr>
             <a:r>
-              <a:rPr lang="en-US" sz="4000">
+              <a:rPr lang="en-US" sz="4800">
                 <a:solidFill>
                   <a:srgbClr val="000000"/>
                 </a:solidFill>
@@ -18495,7 +18495,7 @@
               </a:rPr>
               <a:t>{{PARTICIPANT NAME}} </a:t>
             </a:r>
-            <a:endParaRPr lang="en-US" sz="4000">
+            <a:endParaRPr lang="en-US" sz="4800">
               <a:solidFill>
                 <a:srgbClr val="000000"/>
               </a:solidFill>

</xml_diff>

<commit_message>
Deploy backend v1.0.1 with latest hackathon certificate template and build updates
</commit_message>
<xml_diff>
--- a/backend/CERTIFICATE_TEMPLATE - hackathon.pptx
+++ b/backend/CERTIFICATE_TEMPLATE - hackathon.pptx
@@ -130,7 +130,7 @@
   <p:extLst>
     <p:ext uri="{EFAFB233-063F-42B5-8137-9DF3F51BA10A}">
       <p15:sldGuideLst xmlns:p15="http://schemas.microsoft.com/office/powerpoint/2012/main">
-        <p15:guide id="1" orient="horz" pos="2192" userDrawn="1">
+        <p15:guide id="1" orient="horz" pos="2208" userDrawn="1">
           <p15:clr>
             <a:srgbClr val="A4A3A4"/>
           </p15:clr>
@@ -4840,7 +4840,7 @@
         </p:nvSpPr>
         <p:spPr>
           <a:xfrm>
-            <a:off x="4341524" y="3352342"/>
+            <a:off x="4341524" y="3504742"/>
             <a:ext cx="1882035" cy="256380"/>
           </a:xfrm>
           <a:prstGeom prst="rect">
@@ -5090,7 +5090,7 @@
         </p:nvGrpSpPr>
         <p:grpSpPr>
           <a:xfrm rot="0">
-            <a:off x="4505869" y="3011380"/>
+            <a:off x="4505869" y="3087580"/>
             <a:ext cx="1497873" cy="236782"/>
             <a:chOff x="0" y="0"/>
             <a:chExt cx="2538971" cy="401358"/>
@@ -5151,7 +5151,7 @@
         </p:nvSpPr>
         <p:spPr>
           <a:xfrm>
-            <a:off x="4726682" y="3022090"/>
+            <a:off x="4726682" y="3098290"/>
             <a:ext cx="1122415" cy="171548"/>
           </a:xfrm>
           <a:prstGeom prst="rect">
@@ -5213,7 +5213,7 @@
         </p:nvGrpSpPr>
         <p:grpSpPr>
           <a:xfrm rot="0">
-            <a:off x="3666284" y="2979262"/>
+            <a:off x="3666284" y="3055462"/>
             <a:ext cx="969300" cy="301019"/>
             <a:chOff x="0" y="0"/>
             <a:chExt cx="1292401" cy="401358"/>
@@ -5274,7 +5274,7 @@
         </p:nvGrpSpPr>
         <p:grpSpPr>
           <a:xfrm rot="0">
-            <a:off x="5984854" y="2979262"/>
+            <a:off x="5984854" y="3055462"/>
             <a:ext cx="969300" cy="301019"/>
             <a:chOff x="0" y="0"/>
             <a:chExt cx="1292401" cy="401358"/>

</xml_diff>

<commit_message>
Update hackathon certificate template and redeploy backend
</commit_message>
<xml_diff>
--- a/backend/CERTIFICATE_TEMPLATE - hackathon.pptx
+++ b/backend/CERTIFICATE_TEMPLATE - hackathon.pptx
@@ -5152,7 +5152,7 @@
         <p:spPr>
           <a:xfrm>
             <a:off x="4726682" y="3098290"/>
-            <a:ext cx="1122415" cy="171548"/>
+            <a:ext cx="1122415" cy="601980"/>
           </a:xfrm>
           <a:prstGeom prst="rect">
             <a:avLst/>
@@ -5179,7 +5179,19 @@
                 <a:cs typeface="Cardo Bold" panose="02020804080000020003"/>
                 <a:sym typeface="Cardo Bold" panose="02020804080000020003"/>
               </a:rPr>
-              <a:t>for participation</a:t>
+              <a:t>for </a:t>
+            </a:r>
+            <a:r>
+              <a:rPr lang="en-US" altLang="en-US" sz="1115" b="1">
+                <a:solidFill>
+                  <a:srgbClr val="FFFFFF"/>
+                </a:solidFill>
+                <a:latin typeface="Cardo Bold" panose="02020804080000020003"/>
+                <a:ea typeface="Cardo Bold" panose="02020804080000020003"/>
+                <a:cs typeface="Cardo Bold" panose="02020804080000020003"/>
+                <a:sym typeface="Cardo Bold" panose="02020804080000020003"/>
+              </a:rPr>
+              <a:t>{{CERTIFICATE TYPE}}</a:t>
             </a:r>
             <a:r>
               <a:rPr lang="en-US" sz="1115" b="1">

</xml_diff>

<commit_message>
feat: Add Judge & Dignitary Recognition application and certification workflow
</commit_message>
<xml_diff>
--- a/backend/CERTIFICATE_TEMPLATE - hackathon.pptx
+++ b/backend/CERTIFICATE_TEMPLATE - hackathon.pptx
@@ -4941,7 +4941,7 @@
         <p:spPr>
           <a:xfrm>
             <a:off x="3041266" y="6916845"/>
-            <a:ext cx="1366056" cy="142799"/>
+            <a:ext cx="1366056" cy="123190"/>
           </a:xfrm>
           <a:prstGeom prst="rect">
             <a:avLst/>
@@ -4968,7 +4968,7 @@
                 <a:cs typeface="Cardo Bold" panose="02020804080000020003"/>
                 <a:sym typeface="Cardo Bold" panose="02020804080000020003"/>
               </a:rPr>
-              <a:t>R&amp;D CHEF CO ORDINATOR</a:t>
+              <a:t>R&amp;D CHEF COORDINATOR</a:t>
             </a:r>
             <a:endParaRPr lang="en-US" sz="690" b="1">
               <a:solidFill>

</xml_diff>

<commit_message>
fix(backend): update SIH hackathon certificate template
</commit_message>
<xml_diff>
--- a/backend/CERTIFICATE_TEMPLATE - hackathon.pptx
+++ b/backend/CERTIFICATE_TEMPLATE - hackathon.pptx
@@ -4174,43 +4174,7 @@
                 <a:cs typeface="Cardo" panose="02020600000000000000"/>
                 <a:sym typeface="Cardo" panose="02020600000000000000"/>
               </a:rPr>
-              <a:t>has successfully participated in the </a:t>
-            </a:r>
-            <a:r>
-              <a:rPr lang="en-US" sz="1280">
-                <a:solidFill>
-                  <a:srgbClr val="0D1E4A"/>
-                </a:solidFill>
-                <a:latin typeface="Cardo" panose="02020600000000000000"/>
-                <a:ea typeface="Cardo" panose="02020600000000000000"/>
-                <a:cs typeface="Cardo" panose="02020600000000000000"/>
-                <a:sym typeface="Cardo" panose="02020600000000000000"/>
-              </a:rPr>
-              <a:t>{{EVENT NAME}}</a:t>
-            </a:r>
-            <a:r>
-              <a:rPr lang="en-US" sz="1280">
-                <a:solidFill>
-                  <a:srgbClr val="0D1E4A"/>
-                </a:solidFill>
-                <a:latin typeface="Cardo" panose="02020600000000000000"/>
-                <a:ea typeface="Cardo" panose="02020600000000000000"/>
-                <a:cs typeface="Cardo" panose="02020600000000000000"/>
-                <a:sym typeface="Cardo" panose="02020600000000000000"/>
-              </a:rPr>
-              <a:t> organized by </a:t>
-            </a:r>
-            <a:r>
-              <a:rPr lang="en-US" sz="1280">
-                <a:solidFill>
-                  <a:srgbClr val="0D1E4A"/>
-                </a:solidFill>
-                <a:latin typeface="Cardo" panose="02020600000000000000"/>
-                <a:ea typeface="Cardo" panose="02020600000000000000"/>
-                <a:cs typeface="Cardo" panose="02020600000000000000"/>
-                <a:sym typeface="Cardo" panose="02020600000000000000"/>
-              </a:rPr>
-              <a:t>Trinity College of Engineering and Technology - </a:t>
+              <a:t>has successfully participated in the {{EVENT NAME}} organized by Trinity College of Engineering and Technology - </a:t>
             </a:r>
             <a:r>
               <a:rPr lang="en-US" altLang="en-US" sz="1280">
@@ -4222,7 +4186,19 @@
                 <a:cs typeface="Cardo" panose="02020600000000000000"/>
                 <a:sym typeface="Cardo" panose="02020600000000000000"/>
               </a:rPr>
-              <a:t>Automation</a:t>
+              <a:t>Auto</a:t>
+            </a:r>
+            <a:r>
+              <a:rPr lang="en-IN" altLang="en-US" sz="1280">
+                <a:solidFill>
+                  <a:srgbClr val="0D1E4A"/>
+                </a:solidFill>
+                <a:latin typeface="Cardo" panose="02020600000000000000"/>
+                <a:ea typeface="Cardo" panose="02020600000000000000"/>
+                <a:cs typeface="Cardo" panose="02020600000000000000"/>
+                <a:sym typeface="Cardo" panose="02020600000000000000"/>
+              </a:rPr>
+              <a:t>nomous</a:t>
             </a:r>
             <a:r>
               <a:rPr lang="en-US" sz="1280">

</xml_diff>